<commit_message>
feat: per-report AI analysis button, replace saved analysis, remove empty indicator text
</commit_message>
<xml_diff>
--- a/ppt/健康追踪-商业计划书.pptx
+++ b/ppt/健康追踪-商业计划书.pptx
@@ -2450,7 +2450,7 @@
                   <a:srgbClr val="888888"/>
                 </a:solidFill>
               </a:rPr>
-              <a:t>付费 ¥19/月 无限使用</a:t>
+              <a:t>每月付费可以无限使用</a:t>
             </a:r>
             <a:endParaRPr lang="en-US" sz="1100" dirty="0"/>
           </a:p>
@@ -2564,7 +2564,7 @@
                   <a:srgbClr val="888888"/>
                 </a:solidFill>
               </a:rPr>
-              <a:t>¥5-10/人/月</a:t>
+              <a:t>¥9.9/人/月</a:t>
             </a:r>
             <a:endParaRPr lang="en-US" sz="1100" dirty="0"/>
           </a:p>
@@ -5503,7 +5503,7 @@
                 <a:ea typeface="Microsoft YaHei" pitchFamily="34" charset="-122"/>
                 <a:cs typeface="Microsoft YaHei" pitchFamily="34" charset="-120"/>
               </a:rPr>
-              <a:t>项目概况</a:t>
+              <a:t>市场痛点</a:t>
             </a:r>
             <a:endParaRPr lang="en-US" sz="1200" dirty="0"/>
           </a:p>
@@ -5511,53 +5511,14 @@
       </p:sp>
       <p:sp>
         <p:nvSpPr>
-          <p:cNvPr id="3" name="Text 1"/>
-          <p:cNvSpPr/>
-          <p:nvPr/>
-        </p:nvSpPr>
-        <p:spPr>
-          <a:xfrm>
-            <a:off x="1097280" y="1097280"/>
-            <a:ext cx="9144000" cy="0"/>
-          </a:xfrm>
-          <a:prstGeom prst="rect">
-            <a:avLst/>
-          </a:prstGeom>
-          <a:noFill/>
-          <a:ln/>
-        </p:spPr>
-        <p:txBody>
-          <a:bodyPr wrap="square" rtlCol="0" anchor="ctr"/>
-          <a:lstStyle/>
-          <a:p>
-            <a:pPr indent="0" marL="0">
-              <a:buNone/>
-            </a:pPr>
-            <a:r>
-              <a:rPr lang="en-US" sz="2800" dirty="0">
-                <a:solidFill>
-                  <a:srgbClr val="0A0A0A"/>
-                </a:solidFill>
-                <a:latin typeface="Microsoft YaHei Light" pitchFamily="34" charset="0"/>
-                <a:ea typeface="Microsoft YaHei Light" pitchFamily="34" charset="-122"/>
-                <a:cs typeface="Microsoft YaHei Light" pitchFamily="34" charset="-120"/>
-              </a:rPr>
-              <a:t>拍照即所得，AI 全流程</a:t>
-            </a:r>
-            <a:endParaRPr lang="en-US" sz="2800" dirty="0"/>
-          </a:p>
-        </p:txBody>
-      </p:sp>
-      <p:sp>
-        <p:nvSpPr>
-          <p:cNvPr id="4" name="Shape 2"/>
-          <p:cNvSpPr/>
-          <p:nvPr/>
-        </p:nvSpPr>
-        <p:spPr>
-          <a:xfrm>
-            <a:off x="1097280" y="2743200"/>
-            <a:ext cx="1920240" cy="1828800"/>
+          <p:cNvPr id="3" name="Shape 1"/>
+          <p:cNvSpPr/>
+          <p:nvPr/>
+        </p:nvSpPr>
+        <p:spPr>
+          <a:xfrm>
+            <a:off x="1097280" y="2011680"/>
+            <a:ext cx="2468880" cy="1463040"/>
           </a:xfrm>
           <a:prstGeom prst="rect">
             <a:avLst/>
@@ -5575,14 +5536,14 @@
       </p:sp>
       <p:sp>
         <p:nvSpPr>
-          <p:cNvPr id="5" name="Text 3"/>
-          <p:cNvSpPr/>
-          <p:nvPr/>
-        </p:nvSpPr>
-        <p:spPr>
-          <a:xfrm>
-            <a:off x="1280160" y="2880360"/>
-            <a:ext cx="1554480" cy="365760"/>
+          <p:cNvPr id="4" name="Text 2"/>
+          <p:cNvSpPr/>
+          <p:nvPr/>
+        </p:nvSpPr>
+        <p:spPr>
+          <a:xfrm>
+            <a:off x="1280160" y="2148840"/>
+            <a:ext cx="2103120" cy="365760"/>
           </a:xfrm>
           <a:prstGeom prst="rect">
             <a:avLst/>
@@ -5606,7 +5567,7 @@
                 <a:ea typeface="Microsoft YaHei" pitchFamily="34" charset="-122"/>
                 <a:cs typeface="Microsoft YaHei" pitchFamily="34" charset="-120"/>
               </a:rPr>
-              <a:t>AI 识别</a:t>
+              <a:t>记录太麻烦</a:t>
             </a:r>
             <a:endParaRPr lang="en-US" sz="1400" dirty="0"/>
           </a:p>
@@ -5614,14 +5575,14 @@
       </p:sp>
       <p:sp>
         <p:nvSpPr>
-          <p:cNvPr id="6" name="Text 4"/>
-          <p:cNvSpPr/>
-          <p:nvPr/>
-        </p:nvSpPr>
-        <p:spPr>
-          <a:xfrm>
-            <a:off x="1280160" y="3246120"/>
-            <a:ext cx="1554480" cy="1188720"/>
+          <p:cNvPr id="5" name="Text 3"/>
+          <p:cNvSpPr/>
+          <p:nvPr/>
+        </p:nvSpPr>
+        <p:spPr>
+          <a:xfrm>
+            <a:off x="1280160" y="2514600"/>
+            <a:ext cx="2103120" cy="822960"/>
           </a:xfrm>
           <a:prstGeom prst="rect">
             <a:avLst/>
@@ -5642,7 +5603,7 @@
                   <a:srgbClr val="888888"/>
                 </a:solidFill>
               </a:rPr>
-              <a:t>拍照识别食物</a:t>
+              <a:t>手动查热量表效率极低</a:t>
             </a:r>
             <a:endParaRPr lang="en-US" sz="1100" dirty="0"/>
           </a:p>
@@ -5656,7 +5617,7 @@
                   <a:srgbClr val="888888"/>
                 </a:solidFill>
               </a:rPr>
-              <a:t>自动匹配营养成分</a:t>
+              <a:t>AI 拍照一秒完成</a:t>
             </a:r>
             <a:endParaRPr lang="en-US" sz="1100" dirty="0"/>
           </a:p>
@@ -5664,14 +5625,14 @@
       </p:sp>
       <p:sp>
         <p:nvSpPr>
-          <p:cNvPr id="7" name="Shape 5"/>
-          <p:cNvSpPr/>
-          <p:nvPr/>
-        </p:nvSpPr>
-        <p:spPr>
-          <a:xfrm>
-            <a:off x="3200400" y="2743200"/>
-            <a:ext cx="1920240" cy="1828800"/>
+          <p:cNvPr id="6" name="Shape 4"/>
+          <p:cNvSpPr/>
+          <p:nvPr/>
+        </p:nvSpPr>
+        <p:spPr>
+          <a:xfrm>
+            <a:off x="3840480" y="2011680"/>
+            <a:ext cx="2468880" cy="1463040"/>
           </a:xfrm>
           <a:prstGeom prst="rect">
             <a:avLst/>
@@ -5689,14 +5650,14 @@
       </p:sp>
       <p:sp>
         <p:nvSpPr>
-          <p:cNvPr id="8" name="Text 6"/>
-          <p:cNvSpPr/>
-          <p:nvPr/>
-        </p:nvSpPr>
-        <p:spPr>
-          <a:xfrm>
-            <a:off x="3383280" y="2880360"/>
-            <a:ext cx="1554480" cy="365760"/>
+          <p:cNvPr id="7" name="Text 5"/>
+          <p:cNvSpPr/>
+          <p:nvPr/>
+        </p:nvSpPr>
+        <p:spPr>
+          <a:xfrm>
+            <a:off x="4023360" y="2148840"/>
+            <a:ext cx="2103120" cy="365760"/>
           </a:xfrm>
           <a:prstGeom prst="rect">
             <a:avLst/>
@@ -5720,7 +5681,7 @@
                 <a:ea typeface="Microsoft YaHei" pitchFamily="34" charset="-122"/>
                 <a:cs typeface="Microsoft YaHei" pitchFamily="34" charset="-120"/>
               </a:rPr>
-              <a:t>体检分析</a:t>
+              <a:t>不知道该吃什么</a:t>
             </a:r>
             <a:endParaRPr lang="en-US" sz="1400" dirty="0"/>
           </a:p>
@@ -5728,14 +5689,14 @@
       </p:sp>
       <p:sp>
         <p:nvSpPr>
-          <p:cNvPr id="9" name="Text 7"/>
-          <p:cNvSpPr/>
-          <p:nvPr/>
-        </p:nvSpPr>
-        <p:spPr>
-          <a:xfrm>
-            <a:off x="3383280" y="3246120"/>
-            <a:ext cx="1554480" cy="1188720"/>
+          <p:cNvPr id="8" name="Text 6"/>
+          <p:cNvSpPr/>
+          <p:nvPr/>
+        </p:nvSpPr>
+        <p:spPr>
+          <a:xfrm>
+            <a:off x="4023360" y="2514600"/>
+            <a:ext cx="2103120" cy="822960"/>
           </a:xfrm>
           <a:prstGeom prst="rect">
             <a:avLst/>
@@ -5756,7 +5717,7 @@
                   <a:srgbClr val="888888"/>
                 </a:solidFill>
               </a:rPr>
-              <a:t>上传报告图片</a:t>
+              <a:t>知道有高血糖</a:t>
             </a:r>
             <a:endParaRPr lang="en-US" sz="1100" dirty="0"/>
           </a:p>
@@ -5770,7 +5731,7 @@
                   <a:srgbClr val="888888"/>
                 </a:solidFill>
               </a:rPr>
-              <a:t>AI 提取指标并解读</a:t>
+              <a:t>不知道这盘菜能不能吃</a:t>
             </a:r>
             <a:endParaRPr lang="en-US" sz="1100" dirty="0"/>
           </a:p>
@@ -5778,14 +5739,14 @@
       </p:sp>
       <p:sp>
         <p:nvSpPr>
-          <p:cNvPr id="10" name="Shape 8"/>
-          <p:cNvSpPr/>
-          <p:nvPr/>
-        </p:nvSpPr>
-        <p:spPr>
-          <a:xfrm>
-            <a:off x="5303520" y="2743200"/>
-            <a:ext cx="1920240" cy="1828800"/>
+          <p:cNvPr id="9" name="Shape 7"/>
+          <p:cNvSpPr/>
+          <p:nvPr/>
+        </p:nvSpPr>
+        <p:spPr>
+          <a:xfrm>
+            <a:off x="6583680" y="2011680"/>
+            <a:ext cx="2468880" cy="1463040"/>
           </a:xfrm>
           <a:prstGeom prst="rect">
             <a:avLst/>
@@ -5803,14 +5764,14 @@
       </p:sp>
       <p:sp>
         <p:nvSpPr>
-          <p:cNvPr id="11" name="Text 9"/>
-          <p:cNvSpPr/>
-          <p:nvPr/>
-        </p:nvSpPr>
-        <p:spPr>
-          <a:xfrm>
-            <a:off x="5486400" y="2880360"/>
-            <a:ext cx="1554480" cy="365760"/>
+          <p:cNvPr id="10" name="Text 8"/>
+          <p:cNvSpPr/>
+          <p:nvPr/>
+        </p:nvSpPr>
+        <p:spPr>
+          <a:xfrm>
+            <a:off x="6766560" y="2148840"/>
+            <a:ext cx="2103120" cy="365760"/>
           </a:xfrm>
           <a:prstGeom prst="rect">
             <a:avLst/>
@@ -5834,7 +5795,7 @@
                 <a:ea typeface="Microsoft YaHei" pitchFamily="34" charset="-122"/>
                 <a:cs typeface="Microsoft YaHei" pitchFamily="34" charset="-120"/>
               </a:rPr>
-              <a:t>个性建议</a:t>
+              <a:t>体检报告看不懂</a:t>
             </a:r>
             <a:endParaRPr lang="en-US" sz="1400" dirty="0"/>
           </a:p>
@@ -5842,14 +5803,14 @@
       </p:sp>
       <p:sp>
         <p:nvSpPr>
-          <p:cNvPr id="12" name="Text 10"/>
-          <p:cNvSpPr/>
-          <p:nvPr/>
-        </p:nvSpPr>
-        <p:spPr>
-          <a:xfrm>
-            <a:off x="5486400" y="3246120"/>
-            <a:ext cx="1554480" cy="1188720"/>
+          <p:cNvPr id="11" name="Text 9"/>
+          <p:cNvSpPr/>
+          <p:nvPr/>
+        </p:nvSpPr>
+        <p:spPr>
+          <a:xfrm>
+            <a:off x="6766560" y="2514600"/>
+            <a:ext cx="2103120" cy="822960"/>
           </a:xfrm>
           <a:prstGeom prst="rect">
             <a:avLst/>
@@ -5870,7 +5831,7 @@
                   <a:srgbClr val="888888"/>
                 </a:solidFill>
               </a:rPr>
-              <a:t>结合健康档案</a:t>
+              <a:t>拿了报告不知指标含义</a:t>
             </a:r>
             <a:endParaRPr lang="en-US" sz="1100" dirty="0"/>
           </a:p>
@@ -5884,7 +5845,7 @@
                   <a:srgbClr val="888888"/>
                 </a:solidFill>
               </a:rPr>
-              <a:t>实时生成饮食指导</a:t>
+              <a:t>不知怎么调整饮食</a:t>
             </a:r>
             <a:endParaRPr lang="en-US" sz="1100" dirty="0"/>
           </a:p>
@@ -5892,14 +5853,14 @@
       </p:sp>
       <p:sp>
         <p:nvSpPr>
-          <p:cNvPr id="13" name="Shape 11"/>
-          <p:cNvSpPr/>
-          <p:nvPr/>
-        </p:nvSpPr>
-        <p:spPr>
-          <a:xfrm>
-            <a:off x="7406640" y="2743200"/>
-            <a:ext cx="1920240" cy="1828800"/>
+          <p:cNvPr id="12" name="Shape 10"/>
+          <p:cNvSpPr/>
+          <p:nvPr/>
+        </p:nvSpPr>
+        <p:spPr>
+          <a:xfrm>
+            <a:off x="1097280" y="3840480"/>
+            <a:ext cx="2468880" cy="1463040"/>
           </a:xfrm>
           <a:prstGeom prst="rect">
             <a:avLst/>
@@ -5917,14 +5878,14 @@
       </p:sp>
       <p:sp>
         <p:nvSpPr>
-          <p:cNvPr id="14" name="Text 12"/>
-          <p:cNvSpPr/>
-          <p:nvPr/>
-        </p:nvSpPr>
-        <p:spPr>
-          <a:xfrm>
-            <a:off x="7589520" y="2880360"/>
-            <a:ext cx="1554480" cy="365760"/>
+          <p:cNvPr id="13" name="Text 11"/>
+          <p:cNvSpPr/>
+          <p:nvPr/>
+        </p:nvSpPr>
+        <p:spPr>
+          <a:xfrm>
+            <a:off x="1280160" y="3977640"/>
+            <a:ext cx="2103120" cy="365760"/>
           </a:xfrm>
           <a:prstGeom prst="rect">
             <a:avLst/>
@@ -5948,7 +5909,7 @@
                 <a:ea typeface="Microsoft YaHei" pitchFamily="34" charset="-122"/>
                 <a:cs typeface="Microsoft YaHei" pitchFamily="34" charset="-120"/>
               </a:rPr>
-              <a:t>中医食补</a:t>
+              <a:t>缺乏个性化</a:t>
             </a:r>
             <a:endParaRPr lang="en-US" sz="1400" dirty="0"/>
           </a:p>
@@ -5956,14 +5917,14 @@
       </p:sp>
       <p:sp>
         <p:nvSpPr>
-          <p:cNvPr id="15" name="Text 13"/>
-          <p:cNvSpPr/>
-          <p:nvPr/>
-        </p:nvSpPr>
-        <p:spPr>
-          <a:xfrm>
-            <a:off x="7589520" y="3246120"/>
-            <a:ext cx="1554480" cy="1188720"/>
+          <p:cNvPr id="14" name="Text 12"/>
+          <p:cNvSpPr/>
+          <p:nvPr/>
+        </p:nvSpPr>
+        <p:spPr>
+          <a:xfrm>
+            <a:off x="1280160" y="4343400"/>
+            <a:ext cx="2103120" cy="822960"/>
           </a:xfrm>
           <a:prstGeom prst="rect">
             <a:avLst/>
@@ -5984,7 +5945,7 @@
                   <a:srgbClr val="888888"/>
                 </a:solidFill>
               </a:rPr>
-              <a:t>四季体质调理</a:t>
+              <a:t>热量 App 千篇一律</a:t>
             </a:r>
             <a:endParaRPr lang="en-US" sz="1100" dirty="0"/>
           </a:p>
@@ -5998,7 +5959,7 @@
                   <a:srgbClr val="888888"/>
                 </a:solidFill>
               </a:rPr>
-              <a:t>AI 定制食疗方案</a:t>
+              <a:t>不根据个人健康状况调整</a:t>
             </a:r>
             <a:endParaRPr lang="en-US" sz="1100" dirty="0"/>
           </a:p>
@@ -6006,37 +5967,229 @@
       </p:sp>
       <p:sp>
         <p:nvSpPr>
+          <p:cNvPr id="15" name="Shape 13"/>
+          <p:cNvSpPr/>
+          <p:nvPr/>
+        </p:nvSpPr>
+        <p:spPr>
+          <a:xfrm>
+            <a:off x="3840480" y="3840480"/>
+            <a:ext cx="2468880" cy="1463040"/>
+          </a:xfrm>
+          <a:prstGeom prst="rect">
+            <a:avLst/>
+          </a:prstGeom>
+          <a:solidFill>
+            <a:srgbClr val="FFFFFF"/>
+          </a:solidFill>
+          <a:ln w="6350">
+            <a:solidFill>
+              <a:srgbClr val="E2E2E0"/>
+            </a:solidFill>
+            <a:prstDash val="solid"/>
+          </a:ln>
+        </p:spPr>
+      </p:sp>
+      <p:sp>
+        <p:nvSpPr>
           <p:cNvPr id="16" name="Text 14"/>
           <p:cNvSpPr/>
           <p:nvPr/>
         </p:nvSpPr>
         <p:spPr>
           <a:xfrm>
-            <a:off x="1097280" y="5029200"/>
-            <a:ext cx="9144000" cy="0"/>
-          </a:xfrm>
-          <a:prstGeom prst="rect">
-            <a:avLst/>
-          </a:prstGeom>
-          <a:noFill/>
-          <a:ln/>
-        </p:spPr>
-        <p:txBody>
-          <a:bodyPr wrap="square" rtlCol="0" anchor="ctr"/>
-          <a:lstStyle/>
-          <a:p>
-            <a:pPr indent="0" marL="0">
-              <a:buNone/>
-            </a:pPr>
-            <a:r>
-              <a:rPr lang="en-US" sz="1000" dirty="0">
+            <a:off x="4023360" y="3977640"/>
+            <a:ext cx="2103120" cy="365760"/>
+          </a:xfrm>
+          <a:prstGeom prst="rect">
+            <a:avLst/>
+          </a:prstGeom>
+          <a:noFill/>
+          <a:ln/>
+        </p:spPr>
+        <p:txBody>
+          <a:bodyPr wrap="square" rtlCol="0" anchor="ctr"/>
+          <a:lstStyle/>
+          <a:p>
+            <a:pPr indent="0" marL="0">
+              <a:buNone/>
+            </a:pPr>
+            <a:r>
+              <a:rPr lang="en-US" sz="1400" dirty="0">
+                <a:solidFill>
+                  <a:srgbClr val="0A0A0A"/>
+                </a:solidFill>
+                <a:latin typeface="Microsoft YaHei" pitchFamily="34" charset="0"/>
+                <a:ea typeface="Microsoft YaHei" pitchFamily="34" charset="-122"/>
+                <a:cs typeface="Microsoft YaHei" pitchFamily="34" charset="-120"/>
+              </a:rPr>
+              <a:t>中餐识别差</a:t>
+            </a:r>
+            <a:endParaRPr lang="en-US" sz="1400" dirty="0"/>
+          </a:p>
+        </p:txBody>
+      </p:sp>
+      <p:sp>
+        <p:nvSpPr>
+          <p:cNvPr id="17" name="Text 15"/>
+          <p:cNvSpPr/>
+          <p:nvPr/>
+        </p:nvSpPr>
+        <p:spPr>
+          <a:xfrm>
+            <a:off x="4023360" y="4343400"/>
+            <a:ext cx="2103120" cy="822960"/>
+          </a:xfrm>
+          <a:prstGeom prst="rect">
+            <a:avLst/>
+          </a:prstGeom>
+          <a:noFill/>
+          <a:ln/>
+        </p:spPr>
+        <p:txBody>
+          <a:bodyPr wrap="square" rtlCol="0" anchor="ctr"/>
+          <a:lstStyle/>
+          <a:p>
+            <a:pPr indent="0" marL="0">
+              <a:buNone/>
+            </a:pPr>
+            <a:r>
+              <a:rPr lang="en-US" sz="1100" dirty="0">
                 <a:solidFill>
                   <a:srgbClr val="888888"/>
                 </a:solidFill>
               </a:rPr>
-              <a:t>Next.js 全栈  ·  MiniMax-M3 多模态 AI  ·  PostgreSQL</a:t>
-            </a:r>
-            <a:endParaRPr lang="en-US" sz="1000" dirty="0"/>
+              <a:t>海外竞品西餐为主</a:t>
+            </a:r>
+            <a:endParaRPr lang="en-US" sz="1100" dirty="0"/>
+          </a:p>
+          <a:p>
+            <a:pPr indent="0" marL="0">
+              <a:buNone/>
+            </a:pPr>
+            <a:r>
+              <a:rPr lang="en-US" sz="1100" dirty="0">
+                <a:solidFill>
+                  <a:srgbClr val="888888"/>
+                </a:solidFill>
+              </a:rPr>
+              <a:t>中餐数据匮乏</a:t>
+            </a:r>
+            <a:endParaRPr lang="en-US" sz="1100" dirty="0"/>
+          </a:p>
+        </p:txBody>
+      </p:sp>
+      <p:sp>
+        <p:nvSpPr>
+          <p:cNvPr id="18" name="Shape 16"/>
+          <p:cNvSpPr/>
+          <p:nvPr/>
+        </p:nvSpPr>
+        <p:spPr>
+          <a:xfrm>
+            <a:off x="6583680" y="3840480"/>
+            <a:ext cx="2468880" cy="1463040"/>
+          </a:xfrm>
+          <a:prstGeom prst="rect">
+            <a:avLst/>
+          </a:prstGeom>
+          <a:solidFill>
+            <a:srgbClr val="FFFFFF"/>
+          </a:solidFill>
+          <a:ln w="6350">
+            <a:solidFill>
+              <a:srgbClr val="E2E2E0"/>
+            </a:solidFill>
+            <a:prstDash val="solid"/>
+          </a:ln>
+        </p:spPr>
+      </p:sp>
+      <p:sp>
+        <p:nvSpPr>
+          <p:cNvPr id="19" name="Text 17"/>
+          <p:cNvSpPr/>
+          <p:nvPr/>
+        </p:nvSpPr>
+        <p:spPr>
+          <a:xfrm>
+            <a:off x="6766560" y="3977640"/>
+            <a:ext cx="2103120" cy="365760"/>
+          </a:xfrm>
+          <a:prstGeom prst="rect">
+            <a:avLst/>
+          </a:prstGeom>
+          <a:noFill/>
+          <a:ln/>
+        </p:spPr>
+        <p:txBody>
+          <a:bodyPr wrap="square" rtlCol="0" anchor="ctr"/>
+          <a:lstStyle/>
+          <a:p>
+            <a:pPr indent="0" marL="0">
+              <a:buNone/>
+            </a:pPr>
+            <a:r>
+              <a:rPr lang="en-US" sz="1400" dirty="0">
+                <a:solidFill>
+                  <a:srgbClr val="0A0A0A"/>
+                </a:solidFill>
+                <a:latin typeface="Microsoft YaHei" pitchFamily="34" charset="0"/>
+                <a:ea typeface="Microsoft YaHei" pitchFamily="34" charset="-122"/>
+                <a:cs typeface="Microsoft YaHei" pitchFamily="34" charset="-120"/>
+              </a:rPr>
+              <a:t>缺 AI 深度</a:t>
+            </a:r>
+            <a:endParaRPr lang="en-US" sz="1400" dirty="0"/>
+          </a:p>
+        </p:txBody>
+      </p:sp>
+      <p:sp>
+        <p:nvSpPr>
+          <p:cNvPr id="20" name="Text 18"/>
+          <p:cNvSpPr/>
+          <p:nvPr/>
+        </p:nvSpPr>
+        <p:spPr>
+          <a:xfrm>
+            <a:off x="6766560" y="4343400"/>
+            <a:ext cx="2103120" cy="822960"/>
+          </a:xfrm>
+          <a:prstGeom prst="rect">
+            <a:avLst/>
+          </a:prstGeom>
+          <a:noFill/>
+          <a:ln/>
+        </p:spPr>
+        <p:txBody>
+          <a:bodyPr wrap="square" rtlCol="0" anchor="ctr"/>
+          <a:lstStyle/>
+          <a:p>
+            <a:pPr indent="0" marL="0">
+              <a:buNone/>
+            </a:pPr>
+            <a:r>
+              <a:rPr lang="en-US" sz="1100" dirty="0">
+                <a:solidFill>
+                  <a:srgbClr val="888888"/>
+                </a:solidFill>
+              </a:rPr>
+              <a:t>现有产品简单数据库查询</a:t>
+            </a:r>
+            <a:endParaRPr lang="en-US" sz="1100" dirty="0"/>
+          </a:p>
+          <a:p>
+            <a:pPr indent="0" marL="0">
+              <a:buNone/>
+            </a:pPr>
+            <a:r>
+              <a:rPr lang="en-US" sz="1100" dirty="0">
+                <a:solidFill>
+                  <a:srgbClr val="888888"/>
+                </a:solidFill>
+              </a:rPr>
+              <a:t>缺乏真正的 AI 分析能力</a:t>
+            </a:r>
+            <a:endParaRPr lang="en-US" sz="1100" dirty="0"/>
           </a:p>
         </p:txBody>
       </p:sp>
@@ -6105,7 +6258,7 @@
                 <a:ea typeface="Microsoft YaHei" pitchFamily="34" charset="-122"/>
                 <a:cs typeface="Microsoft YaHei" pitchFamily="34" charset="-120"/>
               </a:rPr>
-              <a:t>Demo 功能亮点</a:t>
+              <a:t>项目概况</a:t>
             </a:r>
             <a:endParaRPr lang="en-US" sz="1200" dirty="0"/>
           </a:p>
@@ -6119,24 +6272,24 @@
         </p:nvSpPr>
         <p:spPr>
           <a:xfrm>
-            <a:off x="1097280" y="1371600"/>
-            <a:ext cx="3657600" cy="1097280"/>
-          </a:xfrm>
-          <a:prstGeom prst="rect">
-            <a:avLst/>
-          </a:prstGeom>
-          <a:noFill/>
-          <a:ln/>
-        </p:spPr>
-        <p:txBody>
-          <a:bodyPr wrap="square" rtlCol="0" anchor="ctr"/>
-          <a:lstStyle/>
-          <a:p>
-            <a:pPr indent="0" marL="0">
-              <a:buNone/>
-            </a:pPr>
-            <a:r>
-              <a:rPr lang="en-US" sz="5600" dirty="0">
+            <a:off x="1097280" y="1097280"/>
+            <a:ext cx="9144000" cy="0"/>
+          </a:xfrm>
+          <a:prstGeom prst="rect">
+            <a:avLst/>
+          </a:prstGeom>
+          <a:noFill/>
+          <a:ln/>
+        </p:spPr>
+        <p:txBody>
+          <a:bodyPr wrap="square" rtlCol="0" anchor="ctr"/>
+          <a:lstStyle/>
+          <a:p>
+            <a:pPr indent="0" marL="0">
+              <a:buNone/>
+            </a:pPr>
+            <a:r>
+              <a:rPr lang="en-US" sz="2800" dirty="0">
                 <a:solidFill>
                   <a:srgbClr val="0A0A0A"/>
                 </a:solidFill>
@@ -6144,104 +6297,110 @@
                 <a:ea typeface="Microsoft YaHei Light" pitchFamily="34" charset="-122"/>
                 <a:cs typeface="Microsoft YaHei Light" pitchFamily="34" charset="-120"/>
               </a:rPr>
-              <a:t>5</a:t>
-            </a:r>
-            <a:endParaRPr lang="en-US" sz="5600" dirty="0"/>
-          </a:p>
-        </p:txBody>
-      </p:sp>
-      <p:sp>
-        <p:nvSpPr>
-          <p:cNvPr id="4" name="Text 2"/>
-          <p:cNvSpPr/>
-          <p:nvPr/>
-        </p:nvSpPr>
-        <p:spPr>
-          <a:xfrm>
-            <a:off x="1097280" y="2560320"/>
-            <a:ext cx="3657600" cy="365760"/>
-          </a:xfrm>
-          <a:prstGeom prst="rect">
-            <a:avLst/>
-          </a:prstGeom>
-          <a:noFill/>
-          <a:ln/>
-        </p:spPr>
-        <p:txBody>
-          <a:bodyPr wrap="square" rtlCol="0" anchor="ctr"/>
-          <a:lstStyle/>
-          <a:p>
-            <a:pPr indent="0" marL="0">
-              <a:buNone/>
-            </a:pPr>
-            <a:r>
-              <a:rPr lang="en-US" sz="1300" dirty="0">
+              <a:t>拍照即所得，AI 全流程</a:t>
+            </a:r>
+            <a:endParaRPr lang="en-US" sz="2800" dirty="0"/>
+          </a:p>
+        </p:txBody>
+      </p:sp>
+      <p:sp>
+        <p:nvSpPr>
+          <p:cNvPr id="4" name="Shape 2"/>
+          <p:cNvSpPr/>
+          <p:nvPr/>
+        </p:nvSpPr>
+        <p:spPr>
+          <a:xfrm>
+            <a:off x="1097280" y="2743200"/>
+            <a:ext cx="1920240" cy="1828800"/>
+          </a:xfrm>
+          <a:prstGeom prst="rect">
+            <a:avLst/>
+          </a:prstGeom>
+          <a:solidFill>
+            <a:srgbClr val="FFFFFF"/>
+          </a:solidFill>
+          <a:ln w="6350">
+            <a:solidFill>
+              <a:srgbClr val="E2E2E0"/>
+            </a:solidFill>
+            <a:prstDash val="solid"/>
+          </a:ln>
+        </p:spPr>
+      </p:sp>
+      <p:sp>
+        <p:nvSpPr>
+          <p:cNvPr id="5" name="Text 3"/>
+          <p:cNvSpPr/>
+          <p:nvPr/>
+        </p:nvSpPr>
+        <p:spPr>
+          <a:xfrm>
+            <a:off x="1280160" y="2880360"/>
+            <a:ext cx="1554480" cy="365760"/>
+          </a:xfrm>
+          <a:prstGeom prst="rect">
+            <a:avLst/>
+          </a:prstGeom>
+          <a:noFill/>
+          <a:ln/>
+        </p:spPr>
+        <p:txBody>
+          <a:bodyPr wrap="square" rtlCol="0" anchor="ctr"/>
+          <a:lstStyle/>
+          <a:p>
+            <a:pPr indent="0" marL="0">
+              <a:buNone/>
+            </a:pPr>
+            <a:r>
+              <a:rPr lang="en-US" sz="1400" dirty="0">
+                <a:solidFill>
+                  <a:srgbClr val="0A0A0A"/>
+                </a:solidFill>
+                <a:latin typeface="Microsoft YaHei" pitchFamily="34" charset="0"/>
+                <a:ea typeface="Microsoft YaHei" pitchFamily="34" charset="-122"/>
+                <a:cs typeface="Microsoft YaHei" pitchFamily="34" charset="-120"/>
+              </a:rPr>
+              <a:t>AI 识别</a:t>
+            </a:r>
+            <a:endParaRPr lang="en-US" sz="1400" dirty="0"/>
+          </a:p>
+        </p:txBody>
+      </p:sp>
+      <p:sp>
+        <p:nvSpPr>
+          <p:cNvPr id="6" name="Text 4"/>
+          <p:cNvSpPr/>
+          <p:nvPr/>
+        </p:nvSpPr>
+        <p:spPr>
+          <a:xfrm>
+            <a:off x="1280160" y="3246120"/>
+            <a:ext cx="1554480" cy="1188720"/>
+          </a:xfrm>
+          <a:prstGeom prst="rect">
+            <a:avLst/>
+          </a:prstGeom>
+          <a:noFill/>
+          <a:ln/>
+        </p:spPr>
+        <p:txBody>
+          <a:bodyPr wrap="square" rtlCol="0" anchor="ctr"/>
+          <a:lstStyle/>
+          <a:p>
+            <a:pPr indent="0" marL="0">
+              <a:buNone/>
+            </a:pPr>
+            <a:r>
+              <a:rPr lang="en-US" sz="1100" dirty="0">
                 <a:solidFill>
                   <a:srgbClr val="888888"/>
                 </a:solidFill>
               </a:rPr>
-              <a:t>AI 能力全面覆盖</a:t>
-            </a:r>
-            <a:endParaRPr lang="en-US" sz="1300" dirty="0"/>
-          </a:p>
-        </p:txBody>
-      </p:sp>
-      <p:sp>
-        <p:nvSpPr>
-          <p:cNvPr id="5" name="Text 3"/>
-          <p:cNvSpPr/>
-          <p:nvPr/>
-        </p:nvSpPr>
-        <p:spPr>
-          <a:xfrm>
-            <a:off x="1097280" y="3108960"/>
-            <a:ext cx="9144000" cy="0"/>
-          </a:xfrm>
-          <a:prstGeom prst="rect">
-            <a:avLst/>
-          </a:prstGeom>
-          <a:noFill/>
-          <a:ln/>
-        </p:spPr>
-        <p:txBody>
-          <a:bodyPr wrap="square" rtlCol="0" anchor="ctr"/>
-          <a:lstStyle/>
-          <a:p>
-            <a:pPr indent="0" marL="0">
-              <a:buNone/>
-            </a:pPr>
-            <a:r>
-              <a:rPr lang="en-US" sz="1300" dirty="0">
-                <a:solidFill>
-                  <a:srgbClr val="1A56DB"/>
-                </a:solidFill>
-              </a:rPr>
-              <a:t>拍照识别  ·  营养估算  ·  报告 OCR  ·  AI 分析  ·  中医食疗</a:t>
-            </a:r>
-            <a:endParaRPr lang="en-US" sz="1300" dirty="0"/>
-          </a:p>
-        </p:txBody>
-      </p:sp>
-      <p:sp>
-        <p:nvSpPr>
-          <p:cNvPr id="6" name="Text 4"/>
-          <p:cNvSpPr/>
-          <p:nvPr/>
-        </p:nvSpPr>
-        <p:spPr>
-          <a:xfrm>
-            <a:off x="1097280" y="3474720"/>
-            <a:ext cx="9144000" cy="0"/>
-          </a:xfrm>
-          <a:prstGeom prst="rect">
-            <a:avLst/>
-          </a:prstGeom>
-          <a:noFill/>
-          <a:ln/>
-        </p:spPr>
-        <p:txBody>
-          <a:bodyPr wrap="square" rtlCol="0" anchor="ctr"/>
-          <a:lstStyle/>
+              <a:t>拍照识别食物</a:t>
+            </a:r>
+            <a:endParaRPr lang="en-US" sz="1100" dirty="0"/>
+          </a:p>
           <a:p>
             <a:pPr indent="0" marL="0">
               <a:buNone/>
@@ -6252,7 +6411,7 @@
                   <a:srgbClr val="888888"/>
                 </a:solidFill>
               </a:rPr>
-              <a:t>全流程 AI 驱动：识别 → 分析 → 建议 → 食补</a:t>
+              <a:t>自动匹配营养成分</a:t>
             </a:r>
             <a:endParaRPr lang="en-US" sz="1100" dirty="0"/>
           </a:p>
@@ -6260,99 +6419,102 @@
       </p:sp>
       <p:sp>
         <p:nvSpPr>
-          <p:cNvPr id="7" name="Text 5"/>
-          <p:cNvSpPr/>
-          <p:nvPr/>
-        </p:nvSpPr>
-        <p:spPr>
-          <a:xfrm>
-            <a:off x="5029200" y="1371600"/>
-            <a:ext cx="3657600" cy="1097280"/>
-          </a:xfrm>
-          <a:prstGeom prst="rect">
-            <a:avLst/>
-          </a:prstGeom>
-          <a:noFill/>
-          <a:ln/>
-        </p:spPr>
-        <p:txBody>
-          <a:bodyPr wrap="square" rtlCol="0" anchor="ctr"/>
-          <a:lstStyle/>
-          <a:p>
-            <a:pPr indent="0" marL="0">
-              <a:buNone/>
-            </a:pPr>
-            <a:r>
-              <a:rPr lang="en-US" sz="5600" dirty="0">
+          <p:cNvPr id="7" name="Shape 5"/>
+          <p:cNvSpPr/>
+          <p:nvPr/>
+        </p:nvSpPr>
+        <p:spPr>
+          <a:xfrm>
+            <a:off x="3200400" y="2743200"/>
+            <a:ext cx="1920240" cy="1828800"/>
+          </a:xfrm>
+          <a:prstGeom prst="rect">
+            <a:avLst/>
+          </a:prstGeom>
+          <a:solidFill>
+            <a:srgbClr val="FFFFFF"/>
+          </a:solidFill>
+          <a:ln w="6350">
+            <a:solidFill>
+              <a:srgbClr val="E2E2E0"/>
+            </a:solidFill>
+            <a:prstDash val="solid"/>
+          </a:ln>
+        </p:spPr>
+      </p:sp>
+      <p:sp>
+        <p:nvSpPr>
+          <p:cNvPr id="8" name="Text 6"/>
+          <p:cNvSpPr/>
+          <p:nvPr/>
+        </p:nvSpPr>
+        <p:spPr>
+          <a:xfrm>
+            <a:off x="3383280" y="2880360"/>
+            <a:ext cx="1554480" cy="365760"/>
+          </a:xfrm>
+          <a:prstGeom prst="rect">
+            <a:avLst/>
+          </a:prstGeom>
+          <a:noFill/>
+          <a:ln/>
+        </p:spPr>
+        <p:txBody>
+          <a:bodyPr wrap="square" rtlCol="0" anchor="ctr"/>
+          <a:lstStyle/>
+          <a:p>
+            <a:pPr indent="0" marL="0">
+              <a:buNone/>
+            </a:pPr>
+            <a:r>
+              <a:rPr lang="en-US" sz="1400" dirty="0">
                 <a:solidFill>
                   <a:srgbClr val="0A0A0A"/>
                 </a:solidFill>
-                <a:latin typeface="Microsoft YaHei Light" pitchFamily="34" charset="0"/>
-                <a:ea typeface="Microsoft YaHei Light" pitchFamily="34" charset="-122"/>
-                <a:cs typeface="Microsoft YaHei Light" pitchFamily="34" charset="-120"/>
-              </a:rPr>
-              <a:t>255</a:t>
-            </a:r>
-            <a:endParaRPr lang="en-US" sz="5600" dirty="0"/>
-          </a:p>
-        </p:txBody>
-      </p:sp>
-      <p:sp>
-        <p:nvSpPr>
-          <p:cNvPr id="8" name="Text 6"/>
-          <p:cNvSpPr/>
-          <p:nvPr/>
-        </p:nvSpPr>
-        <p:spPr>
-          <a:xfrm>
-            <a:off x="5029200" y="2560320"/>
-            <a:ext cx="3657600" cy="365760"/>
-          </a:xfrm>
-          <a:prstGeom prst="rect">
-            <a:avLst/>
-          </a:prstGeom>
-          <a:noFill/>
-          <a:ln/>
-        </p:spPr>
-        <p:txBody>
-          <a:bodyPr wrap="square" rtlCol="0" anchor="ctr"/>
-          <a:lstStyle/>
-          <a:p>
-            <a:pPr indent="0" marL="0">
-              <a:buNone/>
-            </a:pPr>
-            <a:r>
-              <a:rPr lang="en-US" sz="1300" dirty="0">
+                <a:latin typeface="Microsoft YaHei" pitchFamily="34" charset="0"/>
+                <a:ea typeface="Microsoft YaHei" pitchFamily="34" charset="-122"/>
+                <a:cs typeface="Microsoft YaHei" pitchFamily="34" charset="-120"/>
+              </a:rPr>
+              <a:t>体检分析</a:t>
+            </a:r>
+            <a:endParaRPr lang="en-US" sz="1400" dirty="0"/>
+          </a:p>
+        </p:txBody>
+      </p:sp>
+      <p:sp>
+        <p:nvSpPr>
+          <p:cNvPr id="9" name="Text 7"/>
+          <p:cNvSpPr/>
+          <p:nvPr/>
+        </p:nvSpPr>
+        <p:spPr>
+          <a:xfrm>
+            <a:off x="3383280" y="3246120"/>
+            <a:ext cx="1554480" cy="1188720"/>
+          </a:xfrm>
+          <a:prstGeom prst="rect">
+            <a:avLst/>
+          </a:prstGeom>
+          <a:noFill/>
+          <a:ln/>
+        </p:spPr>
+        <p:txBody>
+          <a:bodyPr wrap="square" rtlCol="0" anchor="ctr"/>
+          <a:lstStyle/>
+          <a:p>
+            <a:pPr indent="0" marL="0">
+              <a:buNone/>
+            </a:pPr>
+            <a:r>
+              <a:rPr lang="en-US" sz="1100" dirty="0">
                 <a:solidFill>
                   <a:srgbClr val="888888"/>
                 </a:solidFill>
               </a:rPr>
-              <a:t>内置食物数据库</a:t>
-            </a:r>
-            <a:endParaRPr lang="en-US" sz="1300" dirty="0"/>
-          </a:p>
-        </p:txBody>
-      </p:sp>
-      <p:sp>
-        <p:nvSpPr>
-          <p:cNvPr id="9" name="Text 7"/>
-          <p:cNvSpPr/>
-          <p:nvPr/>
-        </p:nvSpPr>
-        <p:spPr>
-          <a:xfrm>
-            <a:off x="5029200" y="3108960"/>
-            <a:ext cx="9144000" cy="0"/>
-          </a:xfrm>
-          <a:prstGeom prst="rect">
-            <a:avLst/>
-          </a:prstGeom>
-          <a:noFill/>
-          <a:ln/>
-        </p:spPr>
-        <p:txBody>
-          <a:bodyPr wrap="square" rtlCol="0" anchor="ctr"/>
-          <a:lstStyle/>
+              <a:t>上传报告图片</a:t>
+            </a:r>
+            <a:endParaRPr lang="en-US" sz="1100" dirty="0"/>
+          </a:p>
           <a:p>
             <a:pPr indent="0" marL="0">
               <a:buNone/>
@@ -6363,10 +6525,96 @@
                   <a:srgbClr val="888888"/>
                 </a:solidFill>
               </a:rPr>
-              <a:t>覆盖主食、肉类、蔬菜、水果、饮品、菜肴</a:t>
+              <a:t>AI 提取指标并解读</a:t>
             </a:r>
             <a:endParaRPr lang="en-US" sz="1100" dirty="0"/>
           </a:p>
+        </p:txBody>
+      </p:sp>
+      <p:sp>
+        <p:nvSpPr>
+          <p:cNvPr id="10" name="Shape 8"/>
+          <p:cNvSpPr/>
+          <p:nvPr/>
+        </p:nvSpPr>
+        <p:spPr>
+          <a:xfrm>
+            <a:off x="5303520" y="2743200"/>
+            <a:ext cx="1920240" cy="1828800"/>
+          </a:xfrm>
+          <a:prstGeom prst="rect">
+            <a:avLst/>
+          </a:prstGeom>
+          <a:solidFill>
+            <a:srgbClr val="FFFFFF"/>
+          </a:solidFill>
+          <a:ln w="6350">
+            <a:solidFill>
+              <a:srgbClr val="E2E2E0"/>
+            </a:solidFill>
+            <a:prstDash val="solid"/>
+          </a:ln>
+        </p:spPr>
+      </p:sp>
+      <p:sp>
+        <p:nvSpPr>
+          <p:cNvPr id="11" name="Text 9"/>
+          <p:cNvSpPr/>
+          <p:nvPr/>
+        </p:nvSpPr>
+        <p:spPr>
+          <a:xfrm>
+            <a:off x="5486400" y="2880360"/>
+            <a:ext cx="1554480" cy="365760"/>
+          </a:xfrm>
+          <a:prstGeom prst="rect">
+            <a:avLst/>
+          </a:prstGeom>
+          <a:noFill/>
+          <a:ln/>
+        </p:spPr>
+        <p:txBody>
+          <a:bodyPr wrap="square" rtlCol="0" anchor="ctr"/>
+          <a:lstStyle/>
+          <a:p>
+            <a:pPr indent="0" marL="0">
+              <a:buNone/>
+            </a:pPr>
+            <a:r>
+              <a:rPr lang="en-US" sz="1400" dirty="0">
+                <a:solidFill>
+                  <a:srgbClr val="0A0A0A"/>
+                </a:solidFill>
+                <a:latin typeface="Microsoft YaHei" pitchFamily="34" charset="0"/>
+                <a:ea typeface="Microsoft YaHei" pitchFamily="34" charset="-122"/>
+                <a:cs typeface="Microsoft YaHei" pitchFamily="34" charset="-120"/>
+              </a:rPr>
+              <a:t>个性建议</a:t>
+            </a:r>
+            <a:endParaRPr lang="en-US" sz="1400" dirty="0"/>
+          </a:p>
+        </p:txBody>
+      </p:sp>
+      <p:sp>
+        <p:nvSpPr>
+          <p:cNvPr id="12" name="Text 10"/>
+          <p:cNvSpPr/>
+          <p:nvPr/>
+        </p:nvSpPr>
+        <p:spPr>
+          <a:xfrm>
+            <a:off x="5486400" y="3246120"/>
+            <a:ext cx="1554480" cy="1188720"/>
+          </a:xfrm>
+          <a:prstGeom prst="rect">
+            <a:avLst/>
+          </a:prstGeom>
+          <a:noFill/>
+          <a:ln/>
+        </p:spPr>
+        <p:txBody>
+          <a:bodyPr wrap="square" rtlCol="0" anchor="ctr"/>
+          <a:lstStyle/>
           <a:p>
             <a:pPr indent="0" marL="0">
               <a:buNone/>
@@ -6377,15 +6625,143 @@
                   <a:srgbClr val="888888"/>
                 </a:solidFill>
               </a:rPr>
-              <a:t>AI 识别后智能匹配，未匹配项实时创建</a:t>
+              <a:t>结合健康档案</a:t>
             </a:r>
             <a:endParaRPr lang="en-US" sz="1100" dirty="0"/>
           </a:p>
-        </p:txBody>
-      </p:sp>
-      <p:sp>
-        <p:nvSpPr>
-          <p:cNvPr id="10" name="Text 8"/>
+          <a:p>
+            <a:pPr indent="0" marL="0">
+              <a:buNone/>
+            </a:pPr>
+            <a:r>
+              <a:rPr lang="en-US" sz="1100" dirty="0">
+                <a:solidFill>
+                  <a:srgbClr val="888888"/>
+                </a:solidFill>
+              </a:rPr>
+              <a:t>实时生成饮食指导</a:t>
+            </a:r>
+            <a:endParaRPr lang="en-US" sz="1100" dirty="0"/>
+          </a:p>
+        </p:txBody>
+      </p:sp>
+      <p:sp>
+        <p:nvSpPr>
+          <p:cNvPr id="13" name="Shape 11"/>
+          <p:cNvSpPr/>
+          <p:nvPr/>
+        </p:nvSpPr>
+        <p:spPr>
+          <a:xfrm>
+            <a:off x="7406640" y="2743200"/>
+            <a:ext cx="1920240" cy="1828800"/>
+          </a:xfrm>
+          <a:prstGeom prst="rect">
+            <a:avLst/>
+          </a:prstGeom>
+          <a:solidFill>
+            <a:srgbClr val="FFFFFF"/>
+          </a:solidFill>
+          <a:ln w="6350">
+            <a:solidFill>
+              <a:srgbClr val="E2E2E0"/>
+            </a:solidFill>
+            <a:prstDash val="solid"/>
+          </a:ln>
+        </p:spPr>
+      </p:sp>
+      <p:sp>
+        <p:nvSpPr>
+          <p:cNvPr id="14" name="Text 12"/>
+          <p:cNvSpPr/>
+          <p:nvPr/>
+        </p:nvSpPr>
+        <p:spPr>
+          <a:xfrm>
+            <a:off x="7589520" y="2880360"/>
+            <a:ext cx="1554480" cy="365760"/>
+          </a:xfrm>
+          <a:prstGeom prst="rect">
+            <a:avLst/>
+          </a:prstGeom>
+          <a:noFill/>
+          <a:ln/>
+        </p:spPr>
+        <p:txBody>
+          <a:bodyPr wrap="square" rtlCol="0" anchor="ctr"/>
+          <a:lstStyle/>
+          <a:p>
+            <a:pPr indent="0" marL="0">
+              <a:buNone/>
+            </a:pPr>
+            <a:r>
+              <a:rPr lang="en-US" sz="1400" dirty="0">
+                <a:solidFill>
+                  <a:srgbClr val="0A0A0A"/>
+                </a:solidFill>
+                <a:latin typeface="Microsoft YaHei" pitchFamily="34" charset="0"/>
+                <a:ea typeface="Microsoft YaHei" pitchFamily="34" charset="-122"/>
+                <a:cs typeface="Microsoft YaHei" pitchFamily="34" charset="-120"/>
+              </a:rPr>
+              <a:t>中医食补</a:t>
+            </a:r>
+            <a:endParaRPr lang="en-US" sz="1400" dirty="0"/>
+          </a:p>
+        </p:txBody>
+      </p:sp>
+      <p:sp>
+        <p:nvSpPr>
+          <p:cNvPr id="15" name="Text 13"/>
+          <p:cNvSpPr/>
+          <p:nvPr/>
+        </p:nvSpPr>
+        <p:spPr>
+          <a:xfrm>
+            <a:off x="7589520" y="3246120"/>
+            <a:ext cx="1554480" cy="1188720"/>
+          </a:xfrm>
+          <a:prstGeom prst="rect">
+            <a:avLst/>
+          </a:prstGeom>
+          <a:noFill/>
+          <a:ln/>
+        </p:spPr>
+        <p:txBody>
+          <a:bodyPr wrap="square" rtlCol="0" anchor="ctr"/>
+          <a:lstStyle/>
+          <a:p>
+            <a:pPr indent="0" marL="0">
+              <a:buNone/>
+            </a:pPr>
+            <a:r>
+              <a:rPr lang="en-US" sz="1100" dirty="0">
+                <a:solidFill>
+                  <a:srgbClr val="888888"/>
+                </a:solidFill>
+              </a:rPr>
+              <a:t>四季体质调理</a:t>
+            </a:r>
+            <a:endParaRPr lang="en-US" sz="1100" dirty="0"/>
+          </a:p>
+          <a:p>
+            <a:pPr indent="0" marL="0">
+              <a:buNone/>
+            </a:pPr>
+            <a:r>
+              <a:rPr lang="en-US" sz="1100" dirty="0">
+                <a:solidFill>
+                  <a:srgbClr val="888888"/>
+                </a:solidFill>
+              </a:rPr>
+              <a:t>AI 定制食疗方案</a:t>
+            </a:r>
+            <a:endParaRPr lang="en-US" sz="1100" dirty="0"/>
+          </a:p>
+        </p:txBody>
+      </p:sp>
+      <p:sp>
+        <p:nvSpPr>
+          <p:cNvPr id="16" name="Text 14"/>
           <p:cNvSpPr/>
           <p:nvPr/>
         </p:nvSpPr>
@@ -6413,7 +6789,7 @@
                   <a:srgbClr val="888888"/>
                 </a:solidFill>
               </a:rPr>
-              <a:t>响应式设计  ·  手机端 + 桌面端  ·  多用户支持</a:t>
+              <a:t>Next.js 全栈  ·  MiniMax-M3 多模态 AI  ·  PostgreSQL</a:t>
             </a:r>
             <a:endParaRPr lang="en-US" sz="1000" dirty="0"/>
           </a:p>
@@ -6484,7 +6860,7 @@
                 <a:ea typeface="Microsoft YaHei" pitchFamily="34" charset="-122"/>
                 <a:cs typeface="Microsoft YaHei" pitchFamily="34" charset="-120"/>
               </a:rPr>
-              <a:t>技术架构</a:t>
+              <a:t>Demo 功能亮点</a:t>
             </a:r>
             <a:endParaRPr lang="en-US" sz="1200" dirty="0"/>
           </a:p>
@@ -6498,24 +6874,24 @@
         </p:nvSpPr>
         <p:spPr>
           <a:xfrm>
-            <a:off x="1097280" y="1188720"/>
-            <a:ext cx="7315200" cy="0"/>
-          </a:xfrm>
-          <a:prstGeom prst="rect">
-            <a:avLst/>
-          </a:prstGeom>
-          <a:noFill/>
-          <a:ln/>
-        </p:spPr>
-        <p:txBody>
-          <a:bodyPr wrap="square" rtlCol="0" anchor="ctr"/>
-          <a:lstStyle/>
-          <a:p>
-            <a:pPr indent="0" marL="0">
-              <a:buNone/>
-            </a:pPr>
-            <a:r>
-              <a:rPr lang="en-US" sz="3000" dirty="0">
+            <a:off x="1097280" y="1371600"/>
+            <a:ext cx="3657600" cy="1097280"/>
+          </a:xfrm>
+          <a:prstGeom prst="rect">
+            <a:avLst/>
+          </a:prstGeom>
+          <a:noFill/>
+          <a:ln/>
+        </p:spPr>
+        <p:txBody>
+          <a:bodyPr wrap="square" rtlCol="0" anchor="ctr"/>
+          <a:lstStyle/>
+          <a:p>
+            <a:pPr indent="0" marL="0">
+              <a:buNone/>
+            </a:pPr>
+            <a:r>
+              <a:rPr lang="en-US" sz="5600" dirty="0">
                 <a:solidFill>
                   <a:srgbClr val="0A0A0A"/>
                 </a:solidFill>
@@ -6523,24 +6899,146 @@
                 <a:ea typeface="Microsoft YaHei Light" pitchFamily="34" charset="-122"/>
                 <a:cs typeface="Microsoft YaHei Light" pitchFamily="34" charset="-120"/>
               </a:rPr>
-              <a:t>全流程 </a:t>
-            </a:r>
-            <a:pPr indent="0" marL="0">
-              <a:buNone/>
-            </a:pPr>
-            <a:r>
-              <a:rPr lang="en-US" sz="3000" dirty="0">
+              <a:t>5</a:t>
+            </a:r>
+            <a:endParaRPr lang="en-US" sz="5600" dirty="0"/>
+          </a:p>
+        </p:txBody>
+      </p:sp>
+      <p:sp>
+        <p:nvSpPr>
+          <p:cNvPr id="4" name="Text 2"/>
+          <p:cNvSpPr/>
+          <p:nvPr/>
+        </p:nvSpPr>
+        <p:spPr>
+          <a:xfrm>
+            <a:off x="1097280" y="2560320"/>
+            <a:ext cx="3657600" cy="365760"/>
+          </a:xfrm>
+          <a:prstGeom prst="rect">
+            <a:avLst/>
+          </a:prstGeom>
+          <a:noFill/>
+          <a:ln/>
+        </p:spPr>
+        <p:txBody>
+          <a:bodyPr wrap="square" rtlCol="0" anchor="ctr"/>
+          <a:lstStyle/>
+          <a:p>
+            <a:pPr indent="0" marL="0">
+              <a:buNone/>
+            </a:pPr>
+            <a:r>
+              <a:rPr lang="en-US" sz="1300" dirty="0">
+                <a:solidFill>
+                  <a:srgbClr val="888888"/>
+                </a:solidFill>
+              </a:rPr>
+              <a:t>AI 能力全面覆盖</a:t>
+            </a:r>
+            <a:endParaRPr lang="en-US" sz="1300" dirty="0"/>
+          </a:p>
+        </p:txBody>
+      </p:sp>
+      <p:sp>
+        <p:nvSpPr>
+          <p:cNvPr id="5" name="Text 3"/>
+          <p:cNvSpPr/>
+          <p:nvPr/>
+        </p:nvSpPr>
+        <p:spPr>
+          <a:xfrm>
+            <a:off x="1097280" y="3108960"/>
+            <a:ext cx="9144000" cy="0"/>
+          </a:xfrm>
+          <a:prstGeom prst="rect">
+            <a:avLst/>
+          </a:prstGeom>
+          <a:noFill/>
+          <a:ln/>
+        </p:spPr>
+        <p:txBody>
+          <a:bodyPr wrap="square" rtlCol="0" anchor="ctr"/>
+          <a:lstStyle/>
+          <a:p>
+            <a:pPr indent="0" marL="0">
+              <a:buNone/>
+            </a:pPr>
+            <a:r>
+              <a:rPr lang="en-US" sz="1300" dirty="0">
                 <a:solidFill>
                   <a:srgbClr val="1A56DB"/>
                 </a:solidFill>
               </a:rPr>
-              <a:t>AI</a:t>
-            </a:r>
-            <a:pPr indent="0" marL="0">
-              <a:buNone/>
-            </a:pPr>
-            <a:r>
-              <a:rPr lang="en-US" sz="3000" dirty="0">
+              <a:t>拍照识别  ·  营养估算  ·  报告 OCR  ·  AI 分析  ·  中医食疗</a:t>
+            </a:r>
+            <a:endParaRPr lang="en-US" sz="1300" dirty="0"/>
+          </a:p>
+        </p:txBody>
+      </p:sp>
+      <p:sp>
+        <p:nvSpPr>
+          <p:cNvPr id="6" name="Text 4"/>
+          <p:cNvSpPr/>
+          <p:nvPr/>
+        </p:nvSpPr>
+        <p:spPr>
+          <a:xfrm>
+            <a:off x="1097280" y="3474720"/>
+            <a:ext cx="9144000" cy="0"/>
+          </a:xfrm>
+          <a:prstGeom prst="rect">
+            <a:avLst/>
+          </a:prstGeom>
+          <a:noFill/>
+          <a:ln/>
+        </p:spPr>
+        <p:txBody>
+          <a:bodyPr wrap="square" rtlCol="0" anchor="ctr"/>
+          <a:lstStyle/>
+          <a:p>
+            <a:pPr indent="0" marL="0">
+              <a:buNone/>
+            </a:pPr>
+            <a:r>
+              <a:rPr lang="en-US" sz="1100" dirty="0">
+                <a:solidFill>
+                  <a:srgbClr val="888888"/>
+                </a:solidFill>
+              </a:rPr>
+              <a:t>全流程 AI 驱动：识别 → 分析 → 建议 → 食补</a:t>
+            </a:r>
+            <a:endParaRPr lang="en-US" sz="1100" dirty="0"/>
+          </a:p>
+        </p:txBody>
+      </p:sp>
+      <p:sp>
+        <p:nvSpPr>
+          <p:cNvPr id="7" name="Text 5"/>
+          <p:cNvSpPr/>
+          <p:nvPr/>
+        </p:nvSpPr>
+        <p:spPr>
+          <a:xfrm>
+            <a:off x="5029200" y="1371600"/>
+            <a:ext cx="3657600" cy="1097280"/>
+          </a:xfrm>
+          <a:prstGeom prst="rect">
+            <a:avLst/>
+          </a:prstGeom>
+          <a:noFill/>
+          <a:ln/>
+        </p:spPr>
+        <p:txBody>
+          <a:bodyPr wrap="square" rtlCol="0" anchor="ctr"/>
+          <a:lstStyle/>
+          <a:p>
+            <a:pPr indent="0" marL="0">
+              <a:buNone/>
+            </a:pPr>
+            <a:r>
+              <a:rPr lang="en-US" sz="5600" dirty="0">
                 <a:solidFill>
                   <a:srgbClr val="0A0A0A"/>
                 </a:solidFill>
@@ -6548,111 +7046,58 @@
                 <a:ea typeface="Microsoft YaHei Light" pitchFamily="34" charset="-122"/>
                 <a:cs typeface="Microsoft YaHei Light" pitchFamily="34" charset="-120"/>
               </a:rPr>
-              <a:t> 覆盖</a:t>
-            </a:r>
-            <a:endParaRPr lang="en-US" sz="3000" dirty="0"/>
-          </a:p>
-        </p:txBody>
-      </p:sp>
-      <p:sp>
-        <p:nvSpPr>
-          <p:cNvPr id="4" name="Shape 2"/>
-          <p:cNvSpPr/>
-          <p:nvPr/>
-        </p:nvSpPr>
-        <p:spPr>
-          <a:xfrm>
-            <a:off x="1097280" y="2560320"/>
-            <a:ext cx="2468880" cy="2011680"/>
-          </a:xfrm>
-          <a:prstGeom prst="rect">
-            <a:avLst/>
-          </a:prstGeom>
-          <a:solidFill>
-            <a:srgbClr val="FFFFFF"/>
-          </a:solidFill>
-          <a:ln w="19050">
-            <a:solidFill>
-              <a:srgbClr val="1A56DB"/>
-            </a:solidFill>
-            <a:prstDash val="solid"/>
-          </a:ln>
-        </p:spPr>
-      </p:sp>
-      <p:sp>
-        <p:nvSpPr>
-          <p:cNvPr id="5" name="Shape 3"/>
-          <p:cNvSpPr/>
-          <p:nvPr/>
-        </p:nvSpPr>
-        <p:spPr>
-          <a:xfrm>
-            <a:off x="1097280" y="2560320"/>
-            <a:ext cx="54864" cy="2011680"/>
-          </a:xfrm>
-          <a:prstGeom prst="rect">
-            <a:avLst/>
-          </a:prstGeom>
-          <a:solidFill>
-            <a:srgbClr val="1A56DB"/>
-          </a:solidFill>
-          <a:ln w="12700">
-            <a:solidFill>
-              <a:srgbClr val="1A56DB"/>
-            </a:solidFill>
-            <a:prstDash val="solid"/>
-          </a:ln>
-        </p:spPr>
-      </p:sp>
-      <p:sp>
-        <p:nvSpPr>
-          <p:cNvPr id="6" name="Text 4"/>
-          <p:cNvSpPr/>
-          <p:nvPr/>
-        </p:nvSpPr>
-        <p:spPr>
-          <a:xfrm>
-            <a:off x="1371600" y="2697480"/>
-            <a:ext cx="2103120" cy="365760"/>
-          </a:xfrm>
-          <a:prstGeom prst="rect">
-            <a:avLst/>
-          </a:prstGeom>
-          <a:noFill/>
-          <a:ln/>
-        </p:spPr>
-        <p:txBody>
-          <a:bodyPr wrap="square" rtlCol="0" anchor="ctr"/>
-          <a:lstStyle/>
-          <a:p>
-            <a:pPr indent="0" marL="0">
-              <a:buNone/>
-            </a:pPr>
-            <a:r>
-              <a:rPr lang="en-US" sz="1400" dirty="0">
-                <a:solidFill>
-                  <a:srgbClr val="0A0A0A"/>
-                </a:solidFill>
-                <a:latin typeface="Microsoft YaHei" pitchFamily="34" charset="0"/>
-                <a:ea typeface="Microsoft YaHei" pitchFamily="34" charset="-122"/>
-                <a:cs typeface="Microsoft YaHei" pitchFamily="34" charset="-120"/>
-              </a:rPr>
-              <a:t>视觉识别</a:t>
-            </a:r>
-            <a:endParaRPr lang="en-US" sz="1400" dirty="0"/>
-          </a:p>
-        </p:txBody>
-      </p:sp>
-      <p:sp>
-        <p:nvSpPr>
-          <p:cNvPr id="7" name="Text 5"/>
-          <p:cNvSpPr/>
-          <p:nvPr/>
-        </p:nvSpPr>
-        <p:spPr>
-          <a:xfrm>
-            <a:off x="1371600" y="3063240"/>
-            <a:ext cx="2103120" cy="1371600"/>
+              <a:t>255</a:t>
+            </a:r>
+            <a:endParaRPr lang="en-US" sz="5600" dirty="0"/>
+          </a:p>
+        </p:txBody>
+      </p:sp>
+      <p:sp>
+        <p:nvSpPr>
+          <p:cNvPr id="8" name="Text 6"/>
+          <p:cNvSpPr/>
+          <p:nvPr/>
+        </p:nvSpPr>
+        <p:spPr>
+          <a:xfrm>
+            <a:off x="5029200" y="2560320"/>
+            <a:ext cx="3657600" cy="365760"/>
+          </a:xfrm>
+          <a:prstGeom prst="rect">
+            <a:avLst/>
+          </a:prstGeom>
+          <a:noFill/>
+          <a:ln/>
+        </p:spPr>
+        <p:txBody>
+          <a:bodyPr wrap="square" rtlCol="0" anchor="ctr"/>
+          <a:lstStyle/>
+          <a:p>
+            <a:pPr indent="0" marL="0">
+              <a:buNone/>
+            </a:pPr>
+            <a:r>
+              <a:rPr lang="en-US" sz="1300" dirty="0">
+                <a:solidFill>
+                  <a:srgbClr val="888888"/>
+                </a:solidFill>
+              </a:rPr>
+              <a:t>内置食物数据库</a:t>
+            </a:r>
+            <a:endParaRPr lang="en-US" sz="1300" dirty="0"/>
+          </a:p>
+        </p:txBody>
+      </p:sp>
+      <p:sp>
+        <p:nvSpPr>
+          <p:cNvPr id="9" name="Text 7"/>
+          <p:cNvSpPr/>
+          <p:nvPr/>
+        </p:nvSpPr>
+        <p:spPr>
+          <a:xfrm>
+            <a:off x="5029200" y="3108960"/>
+            <a:ext cx="9144000" cy="0"/>
           </a:xfrm>
           <a:prstGeom prst="rect">
             <a:avLst/>
@@ -6673,7 +7118,7 @@
                   <a:srgbClr val="888888"/>
                 </a:solidFill>
               </a:rPr>
-              <a:t>MiniMax-M3 多模态模型</a:t>
+              <a:t>覆盖主食、肉类、蔬菜、水果、饮品、菜肴</a:t>
             </a:r>
             <a:endParaRPr lang="en-US" sz="1100" dirty="0"/>
           </a:p>
@@ -6687,335 +7132,15 @@
                   <a:srgbClr val="888888"/>
                 </a:solidFill>
               </a:rPr>
-              <a:t>温度 0 确定性输出</a:t>
+              <a:t>AI 识别后智能匹配，未匹配项实时创建</a:t>
             </a:r>
             <a:endParaRPr lang="en-US" sz="1100" dirty="0"/>
           </a:p>
-          <a:p>
-            <a:pPr indent="0" marL="0">
-              <a:buNone/>
-            </a:pPr>
-            <a:r>
-              <a:rPr lang="en-US" sz="1100" dirty="0">
-                <a:solidFill>
-                  <a:srgbClr val="888888"/>
-                </a:solidFill>
-              </a:rPr>
-              <a:t>3 次测试一致率 100%</a:t>
-            </a:r>
-            <a:endParaRPr lang="en-US" sz="1100" dirty="0"/>
-          </a:p>
-        </p:txBody>
-      </p:sp>
-      <p:sp>
-        <p:nvSpPr>
-          <p:cNvPr id="8" name="Shape 6"/>
-          <p:cNvSpPr/>
-          <p:nvPr/>
-        </p:nvSpPr>
-        <p:spPr>
-          <a:xfrm>
-            <a:off x="3840480" y="2560320"/>
-            <a:ext cx="2468880" cy="2011680"/>
-          </a:xfrm>
-          <a:prstGeom prst="rect">
-            <a:avLst/>
-          </a:prstGeom>
-          <a:solidFill>
-            <a:srgbClr val="FFFFFF"/>
-          </a:solidFill>
-          <a:ln w="19050">
-            <a:solidFill>
-              <a:srgbClr val="1A56DB"/>
-            </a:solidFill>
-            <a:prstDash val="solid"/>
-          </a:ln>
-        </p:spPr>
-      </p:sp>
-      <p:sp>
-        <p:nvSpPr>
-          <p:cNvPr id="9" name="Shape 7"/>
-          <p:cNvSpPr/>
-          <p:nvPr/>
-        </p:nvSpPr>
-        <p:spPr>
-          <a:xfrm>
-            <a:off x="3840480" y="2560320"/>
-            <a:ext cx="54864" cy="2011680"/>
-          </a:xfrm>
-          <a:prstGeom prst="rect">
-            <a:avLst/>
-          </a:prstGeom>
-          <a:solidFill>
-            <a:srgbClr val="1A56DB"/>
-          </a:solidFill>
-          <a:ln w="12700">
-            <a:solidFill>
-              <a:srgbClr val="1A56DB"/>
-            </a:solidFill>
-            <a:prstDash val="solid"/>
-          </a:ln>
-        </p:spPr>
+        </p:txBody>
       </p:sp>
       <p:sp>
         <p:nvSpPr>
           <p:cNvPr id="10" name="Text 8"/>
-          <p:cNvSpPr/>
-          <p:nvPr/>
-        </p:nvSpPr>
-        <p:spPr>
-          <a:xfrm>
-            <a:off x="4114800" y="2697480"/>
-            <a:ext cx="2103120" cy="365760"/>
-          </a:xfrm>
-          <a:prstGeom prst="rect">
-            <a:avLst/>
-          </a:prstGeom>
-          <a:noFill/>
-          <a:ln/>
-        </p:spPr>
-        <p:txBody>
-          <a:bodyPr wrap="square" rtlCol="0" anchor="ctr"/>
-          <a:lstStyle/>
-          <a:p>
-            <a:pPr indent="0" marL="0">
-              <a:buNone/>
-            </a:pPr>
-            <a:r>
-              <a:rPr lang="en-US" sz="1400" dirty="0">
-                <a:solidFill>
-                  <a:srgbClr val="0A0A0A"/>
-                </a:solidFill>
-                <a:latin typeface="Microsoft YaHei" pitchFamily="34" charset="0"/>
-                <a:ea typeface="Microsoft YaHei" pitchFamily="34" charset="-122"/>
-                <a:cs typeface="Microsoft YaHei" pitchFamily="34" charset="-120"/>
-              </a:rPr>
-              <a:t>营养估算</a:t>
-            </a:r>
-            <a:endParaRPr lang="en-US" sz="1400" dirty="0"/>
-          </a:p>
-        </p:txBody>
-      </p:sp>
-      <p:sp>
-        <p:nvSpPr>
-          <p:cNvPr id="11" name="Text 9"/>
-          <p:cNvSpPr/>
-          <p:nvPr/>
-        </p:nvSpPr>
-        <p:spPr>
-          <a:xfrm>
-            <a:off x="4114800" y="3063240"/>
-            <a:ext cx="2103120" cy="1371600"/>
-          </a:xfrm>
-          <a:prstGeom prst="rect">
-            <a:avLst/>
-          </a:prstGeom>
-          <a:noFill/>
-          <a:ln/>
-        </p:spPr>
-        <p:txBody>
-          <a:bodyPr wrap="square" rtlCol="0" anchor="ctr"/>
-          <a:lstStyle/>
-          <a:p>
-            <a:pPr indent="0" marL="0">
-              <a:buNone/>
-            </a:pPr>
-            <a:r>
-              <a:rPr lang="en-US" sz="1100" dirty="0">
-                <a:solidFill>
-                  <a:srgbClr val="888888"/>
-                </a:solidFill>
-              </a:rPr>
-              <a:t>输入食物名 + 克数</a:t>
-            </a:r>
-            <a:endParaRPr lang="en-US" sz="1100" dirty="0"/>
-          </a:p>
-          <a:p>
-            <a:pPr indent="0" marL="0">
-              <a:buNone/>
-            </a:pPr>
-            <a:r>
-              <a:rPr lang="en-US" sz="1100" dirty="0">
-                <a:solidFill>
-                  <a:srgbClr val="888888"/>
-                </a:solidFill>
-              </a:rPr>
-              <a:t>AI 实时返回热量、蛋白</a:t>
-            </a:r>
-            <a:endParaRPr lang="en-US" sz="1100" dirty="0"/>
-          </a:p>
-          <a:p>
-            <a:pPr indent="0" marL="0">
-              <a:buNone/>
-            </a:pPr>
-            <a:r>
-              <a:rPr lang="en-US" sz="1100" dirty="0">
-                <a:solidFill>
-                  <a:srgbClr val="888888"/>
-                </a:solidFill>
-              </a:rPr>
-              <a:t>脂肪、碳水、纤维、糖</a:t>
-            </a:r>
-            <a:endParaRPr lang="en-US" sz="1100" dirty="0"/>
-          </a:p>
-        </p:txBody>
-      </p:sp>
-      <p:sp>
-        <p:nvSpPr>
-          <p:cNvPr id="12" name="Shape 10"/>
-          <p:cNvSpPr/>
-          <p:nvPr/>
-        </p:nvSpPr>
-        <p:spPr>
-          <a:xfrm>
-            <a:off x="6583680" y="2560320"/>
-            <a:ext cx="2468880" cy="2011680"/>
-          </a:xfrm>
-          <a:prstGeom prst="rect">
-            <a:avLst/>
-          </a:prstGeom>
-          <a:solidFill>
-            <a:srgbClr val="FFFFFF"/>
-          </a:solidFill>
-          <a:ln w="19050">
-            <a:solidFill>
-              <a:srgbClr val="1A56DB"/>
-            </a:solidFill>
-            <a:prstDash val="solid"/>
-          </a:ln>
-        </p:spPr>
-      </p:sp>
-      <p:sp>
-        <p:nvSpPr>
-          <p:cNvPr id="13" name="Shape 11"/>
-          <p:cNvSpPr/>
-          <p:nvPr/>
-        </p:nvSpPr>
-        <p:spPr>
-          <a:xfrm>
-            <a:off x="6583680" y="2560320"/>
-            <a:ext cx="54864" cy="2011680"/>
-          </a:xfrm>
-          <a:prstGeom prst="rect">
-            <a:avLst/>
-          </a:prstGeom>
-          <a:solidFill>
-            <a:srgbClr val="1A56DB"/>
-          </a:solidFill>
-          <a:ln w="12700">
-            <a:solidFill>
-              <a:srgbClr val="1A56DB"/>
-            </a:solidFill>
-            <a:prstDash val="solid"/>
-          </a:ln>
-        </p:spPr>
-      </p:sp>
-      <p:sp>
-        <p:nvSpPr>
-          <p:cNvPr id="14" name="Text 12"/>
-          <p:cNvSpPr/>
-          <p:nvPr/>
-        </p:nvSpPr>
-        <p:spPr>
-          <a:xfrm>
-            <a:off x="6858000" y="2697480"/>
-            <a:ext cx="2103120" cy="365760"/>
-          </a:xfrm>
-          <a:prstGeom prst="rect">
-            <a:avLst/>
-          </a:prstGeom>
-          <a:noFill/>
-          <a:ln/>
-        </p:spPr>
-        <p:txBody>
-          <a:bodyPr wrap="square" rtlCol="0" anchor="ctr"/>
-          <a:lstStyle/>
-          <a:p>
-            <a:pPr indent="0" marL="0">
-              <a:buNone/>
-            </a:pPr>
-            <a:r>
-              <a:rPr lang="en-US" sz="1400" dirty="0">
-                <a:solidFill>
-                  <a:srgbClr val="0A0A0A"/>
-                </a:solidFill>
-                <a:latin typeface="Microsoft YaHei" pitchFamily="34" charset="0"/>
-                <a:ea typeface="Microsoft YaHei" pitchFamily="34" charset="-122"/>
-                <a:cs typeface="Microsoft YaHei" pitchFamily="34" charset="-120"/>
-              </a:rPr>
-              <a:t>报告分析</a:t>
-            </a:r>
-            <a:endParaRPr lang="en-US" sz="1400" dirty="0"/>
-          </a:p>
-        </p:txBody>
-      </p:sp>
-      <p:sp>
-        <p:nvSpPr>
-          <p:cNvPr id="15" name="Text 13"/>
-          <p:cNvSpPr/>
-          <p:nvPr/>
-        </p:nvSpPr>
-        <p:spPr>
-          <a:xfrm>
-            <a:off x="6858000" y="3063240"/>
-            <a:ext cx="2103120" cy="1371600"/>
-          </a:xfrm>
-          <a:prstGeom prst="rect">
-            <a:avLst/>
-          </a:prstGeom>
-          <a:noFill/>
-          <a:ln/>
-        </p:spPr>
-        <p:txBody>
-          <a:bodyPr wrap="square" rtlCol="0" anchor="ctr"/>
-          <a:lstStyle/>
-          <a:p>
-            <a:pPr indent="0" marL="0">
-              <a:buNone/>
-            </a:pPr>
-            <a:r>
-              <a:rPr lang="en-US" sz="1100" dirty="0">
-                <a:solidFill>
-                  <a:srgbClr val="888888"/>
-                </a:solidFill>
-              </a:rPr>
-              <a:t>上传体检报告图片</a:t>
-            </a:r>
-            <a:endParaRPr lang="en-US" sz="1100" dirty="0"/>
-          </a:p>
-          <a:p>
-            <a:pPr indent="0" marL="0">
-              <a:buNone/>
-            </a:pPr>
-            <a:r>
-              <a:rPr lang="en-US" sz="1100" dirty="0">
-                <a:solidFill>
-                  <a:srgbClr val="888888"/>
-                </a:solidFill>
-              </a:rPr>
-              <a:t>AI 三段式输出</a:t>
-            </a:r>
-            <a:endParaRPr lang="en-US" sz="1100" dirty="0"/>
-          </a:p>
-          <a:p>
-            <a:pPr indent="0" marL="0">
-              <a:buNone/>
-            </a:pPr>
-            <a:r>
-              <a:rPr lang="en-US" sz="1100" dirty="0">
-                <a:solidFill>
-                  <a:srgbClr val="888888"/>
-                </a:solidFill>
-              </a:rPr>
-              <a:t>指标提取 → 风险评估 → 饮食建议</a:t>
-            </a:r>
-            <a:endParaRPr lang="en-US" sz="1100" dirty="0"/>
-          </a:p>
-        </p:txBody>
-      </p:sp>
-      <p:sp>
-        <p:nvSpPr>
-          <p:cNvPr id="16" name="Text 14"/>
           <p:cNvSpPr/>
           <p:nvPr/>
         </p:nvSpPr>
@@ -7043,7 +7168,7 @@
                   <a:srgbClr val="888888"/>
                 </a:solidFill>
               </a:rPr>
-              <a:t>OCR 指标提取  ·  规则引擎 + AI 双通道建议  ·  中医食补 AI</a:t>
+              <a:t>响应式设计  ·  手机端 + 桌面端  ·  多用户支持</a:t>
             </a:r>
             <a:endParaRPr lang="en-US" sz="1000" dirty="0"/>
           </a:p>
@@ -7114,7 +7239,7 @@
                 <a:ea typeface="Microsoft YaHei" pitchFamily="34" charset="-122"/>
                 <a:cs typeface="Microsoft YaHei" pitchFamily="34" charset="-120"/>
               </a:rPr>
-              <a:t>市场痛点</a:t>
+              <a:t>技术架构</a:t>
             </a:r>
             <a:endParaRPr lang="en-US" sz="1200" dirty="0"/>
           </a:p>
@@ -7122,14 +7247,78 @@
       </p:sp>
       <p:sp>
         <p:nvSpPr>
-          <p:cNvPr id="3" name="Shape 1"/>
-          <p:cNvSpPr/>
-          <p:nvPr/>
-        </p:nvSpPr>
-        <p:spPr>
-          <a:xfrm>
-            <a:off x="1097280" y="2011680"/>
-            <a:ext cx="2468880" cy="1463040"/>
+          <p:cNvPr id="3" name="Text 1"/>
+          <p:cNvSpPr/>
+          <p:nvPr/>
+        </p:nvSpPr>
+        <p:spPr>
+          <a:xfrm>
+            <a:off x="1097280" y="1188720"/>
+            <a:ext cx="7315200" cy="0"/>
+          </a:xfrm>
+          <a:prstGeom prst="rect">
+            <a:avLst/>
+          </a:prstGeom>
+          <a:noFill/>
+          <a:ln/>
+        </p:spPr>
+        <p:txBody>
+          <a:bodyPr wrap="square" rtlCol="0" anchor="ctr"/>
+          <a:lstStyle/>
+          <a:p>
+            <a:pPr indent="0" marL="0">
+              <a:buNone/>
+            </a:pPr>
+            <a:r>
+              <a:rPr lang="en-US" sz="3000" dirty="0">
+                <a:solidFill>
+                  <a:srgbClr val="0A0A0A"/>
+                </a:solidFill>
+                <a:latin typeface="Microsoft YaHei Light" pitchFamily="34" charset="0"/>
+                <a:ea typeface="Microsoft YaHei Light" pitchFamily="34" charset="-122"/>
+                <a:cs typeface="Microsoft YaHei Light" pitchFamily="34" charset="-120"/>
+              </a:rPr>
+              <a:t>全流程 </a:t>
+            </a:r>
+            <a:pPr indent="0" marL="0">
+              <a:buNone/>
+            </a:pPr>
+            <a:r>
+              <a:rPr lang="en-US" sz="3000" dirty="0">
+                <a:solidFill>
+                  <a:srgbClr val="1A56DB"/>
+                </a:solidFill>
+              </a:rPr>
+              <a:t>AI</a:t>
+            </a:r>
+            <a:pPr indent="0" marL="0">
+              <a:buNone/>
+            </a:pPr>
+            <a:r>
+              <a:rPr lang="en-US" sz="3000" dirty="0">
+                <a:solidFill>
+                  <a:srgbClr val="0A0A0A"/>
+                </a:solidFill>
+                <a:latin typeface="Microsoft YaHei Light" pitchFamily="34" charset="0"/>
+                <a:ea typeface="Microsoft YaHei Light" pitchFamily="34" charset="-122"/>
+                <a:cs typeface="Microsoft YaHei Light" pitchFamily="34" charset="-120"/>
+              </a:rPr>
+              <a:t> 覆盖</a:t>
+            </a:r>
+            <a:endParaRPr lang="en-US" sz="3000" dirty="0"/>
+          </a:p>
+        </p:txBody>
+      </p:sp>
+      <p:sp>
+        <p:nvSpPr>
+          <p:cNvPr id="4" name="Shape 2"/>
+          <p:cNvSpPr/>
+          <p:nvPr/>
+        </p:nvSpPr>
+        <p:spPr>
+          <a:xfrm>
+            <a:off x="1097280" y="2560320"/>
+            <a:ext cx="2468880" cy="2011680"/>
           </a:xfrm>
           <a:prstGeom prst="rect">
             <a:avLst/>
@@ -7137,9 +7326,9 @@
           <a:solidFill>
             <a:srgbClr val="FFFFFF"/>
           </a:solidFill>
-          <a:ln w="6350">
+          <a:ln w="19050">
             <a:solidFill>
-              <a:srgbClr val="E2E2E0"/>
+              <a:srgbClr val="1A56DB"/>
             </a:solidFill>
             <a:prstDash val="solid"/>
           </a:ln>
@@ -7147,13 +7336,38 @@
       </p:sp>
       <p:sp>
         <p:nvSpPr>
-          <p:cNvPr id="4" name="Text 2"/>
-          <p:cNvSpPr/>
-          <p:nvPr/>
-        </p:nvSpPr>
-        <p:spPr>
-          <a:xfrm>
-            <a:off x="1280160" y="2148840"/>
+          <p:cNvPr id="5" name="Shape 3"/>
+          <p:cNvSpPr/>
+          <p:nvPr/>
+        </p:nvSpPr>
+        <p:spPr>
+          <a:xfrm>
+            <a:off x="1097280" y="2560320"/>
+            <a:ext cx="54864" cy="2011680"/>
+          </a:xfrm>
+          <a:prstGeom prst="rect">
+            <a:avLst/>
+          </a:prstGeom>
+          <a:solidFill>
+            <a:srgbClr val="1A56DB"/>
+          </a:solidFill>
+          <a:ln w="12700">
+            <a:solidFill>
+              <a:srgbClr val="1A56DB"/>
+            </a:solidFill>
+            <a:prstDash val="solid"/>
+          </a:ln>
+        </p:spPr>
+      </p:sp>
+      <p:sp>
+        <p:nvSpPr>
+          <p:cNvPr id="6" name="Text 4"/>
+          <p:cNvSpPr/>
+          <p:nvPr/>
+        </p:nvSpPr>
+        <p:spPr>
+          <a:xfrm>
+            <a:off x="1371600" y="2697480"/>
             <a:ext cx="2103120" cy="365760"/>
           </a:xfrm>
           <a:prstGeom prst="rect">
@@ -7178,7 +7392,7 @@
                 <a:ea typeface="Microsoft YaHei" pitchFamily="34" charset="-122"/>
                 <a:cs typeface="Microsoft YaHei" pitchFamily="34" charset="-120"/>
               </a:rPr>
-              <a:t>记录太麻烦</a:t>
+              <a:t>视觉识别</a:t>
             </a:r>
             <a:endParaRPr lang="en-US" sz="1400" dirty="0"/>
           </a:p>
@@ -7186,14 +7400,14 @@
       </p:sp>
       <p:sp>
         <p:nvSpPr>
-          <p:cNvPr id="5" name="Text 3"/>
-          <p:cNvSpPr/>
-          <p:nvPr/>
-        </p:nvSpPr>
-        <p:spPr>
-          <a:xfrm>
-            <a:off x="1280160" y="2514600"/>
-            <a:ext cx="2103120" cy="822960"/>
+          <p:cNvPr id="7" name="Text 5"/>
+          <p:cNvSpPr/>
+          <p:nvPr/>
+        </p:nvSpPr>
+        <p:spPr>
+          <a:xfrm>
+            <a:off x="1371600" y="3063240"/>
+            <a:ext cx="2103120" cy="1371600"/>
           </a:xfrm>
           <a:prstGeom prst="rect">
             <a:avLst/>
@@ -7214,7 +7428,7 @@
                   <a:srgbClr val="888888"/>
                 </a:solidFill>
               </a:rPr>
-              <a:t>手动查热量表效率极低</a:t>
+              <a:t>MiniMax-M3 多模态模型</a:t>
             </a:r>
             <a:endParaRPr lang="en-US" sz="1100" dirty="0"/>
           </a:p>
@@ -7228,22 +7442,36 @@
                   <a:srgbClr val="888888"/>
                 </a:solidFill>
               </a:rPr>
-              <a:t>AI 拍照一秒完成</a:t>
+              <a:t>温度 0 确定性输出</a:t>
             </a:r>
             <a:endParaRPr lang="en-US" sz="1100" dirty="0"/>
           </a:p>
-        </p:txBody>
-      </p:sp>
-      <p:sp>
-        <p:nvSpPr>
-          <p:cNvPr id="6" name="Shape 4"/>
-          <p:cNvSpPr/>
-          <p:nvPr/>
-        </p:nvSpPr>
-        <p:spPr>
-          <a:xfrm>
-            <a:off x="3840480" y="2011680"/>
-            <a:ext cx="2468880" cy="1463040"/>
+          <a:p>
+            <a:pPr indent="0" marL="0">
+              <a:buNone/>
+            </a:pPr>
+            <a:r>
+              <a:rPr lang="en-US" sz="1100" dirty="0">
+                <a:solidFill>
+                  <a:srgbClr val="888888"/>
+                </a:solidFill>
+              </a:rPr>
+              <a:t>3 次测试一致率 100%</a:t>
+            </a:r>
+            <a:endParaRPr lang="en-US" sz="1100" dirty="0"/>
+          </a:p>
+        </p:txBody>
+      </p:sp>
+      <p:sp>
+        <p:nvSpPr>
+          <p:cNvPr id="8" name="Shape 6"/>
+          <p:cNvSpPr/>
+          <p:nvPr/>
+        </p:nvSpPr>
+        <p:spPr>
+          <a:xfrm>
+            <a:off x="3840480" y="2560320"/>
+            <a:ext cx="2468880" cy="2011680"/>
           </a:xfrm>
           <a:prstGeom prst="rect">
             <a:avLst/>
@@ -7251,9 +7479,9 @@
           <a:solidFill>
             <a:srgbClr val="FFFFFF"/>
           </a:solidFill>
-          <a:ln w="6350">
+          <a:ln w="19050">
             <a:solidFill>
-              <a:srgbClr val="E2E2E0"/>
+              <a:srgbClr val="1A56DB"/>
             </a:solidFill>
             <a:prstDash val="solid"/>
           </a:ln>
@@ -7261,13 +7489,38 @@
       </p:sp>
       <p:sp>
         <p:nvSpPr>
-          <p:cNvPr id="7" name="Text 5"/>
-          <p:cNvSpPr/>
-          <p:nvPr/>
-        </p:nvSpPr>
-        <p:spPr>
-          <a:xfrm>
-            <a:off x="4023360" y="2148840"/>
+          <p:cNvPr id="9" name="Shape 7"/>
+          <p:cNvSpPr/>
+          <p:nvPr/>
+        </p:nvSpPr>
+        <p:spPr>
+          <a:xfrm>
+            <a:off x="3840480" y="2560320"/>
+            <a:ext cx="54864" cy="2011680"/>
+          </a:xfrm>
+          <a:prstGeom prst="rect">
+            <a:avLst/>
+          </a:prstGeom>
+          <a:solidFill>
+            <a:srgbClr val="1A56DB"/>
+          </a:solidFill>
+          <a:ln w="12700">
+            <a:solidFill>
+              <a:srgbClr val="1A56DB"/>
+            </a:solidFill>
+            <a:prstDash val="solid"/>
+          </a:ln>
+        </p:spPr>
+      </p:sp>
+      <p:sp>
+        <p:nvSpPr>
+          <p:cNvPr id="10" name="Text 8"/>
+          <p:cNvSpPr/>
+          <p:nvPr/>
+        </p:nvSpPr>
+        <p:spPr>
+          <a:xfrm>
+            <a:off x="4114800" y="2697480"/>
             <a:ext cx="2103120" cy="365760"/>
           </a:xfrm>
           <a:prstGeom prst="rect">
@@ -7292,7 +7545,7 @@
                 <a:ea typeface="Microsoft YaHei" pitchFamily="34" charset="-122"/>
                 <a:cs typeface="Microsoft YaHei" pitchFamily="34" charset="-120"/>
               </a:rPr>
-              <a:t>不知道该吃什么</a:t>
+              <a:t>营养估算</a:t>
             </a:r>
             <a:endParaRPr lang="en-US" sz="1400" dirty="0"/>
           </a:p>
@@ -7300,14 +7553,14 @@
       </p:sp>
       <p:sp>
         <p:nvSpPr>
-          <p:cNvPr id="8" name="Text 6"/>
-          <p:cNvSpPr/>
-          <p:nvPr/>
-        </p:nvSpPr>
-        <p:spPr>
-          <a:xfrm>
-            <a:off x="4023360" y="2514600"/>
-            <a:ext cx="2103120" cy="822960"/>
+          <p:cNvPr id="11" name="Text 9"/>
+          <p:cNvSpPr/>
+          <p:nvPr/>
+        </p:nvSpPr>
+        <p:spPr>
+          <a:xfrm>
+            <a:off x="4114800" y="3063240"/>
+            <a:ext cx="2103120" cy="1371600"/>
           </a:xfrm>
           <a:prstGeom prst="rect">
             <a:avLst/>
@@ -7328,7 +7581,7 @@
                   <a:srgbClr val="888888"/>
                 </a:solidFill>
               </a:rPr>
-              <a:t>知道有高血糖</a:t>
+              <a:t>输入食物名 + 克数</a:t>
             </a:r>
             <a:endParaRPr lang="en-US" sz="1100" dirty="0"/>
           </a:p>
@@ -7342,22 +7595,36 @@
                   <a:srgbClr val="888888"/>
                 </a:solidFill>
               </a:rPr>
-              <a:t>不知道这盘菜能不能吃</a:t>
+              <a:t>AI 实时返回热量、蛋白</a:t>
             </a:r>
             <a:endParaRPr lang="en-US" sz="1100" dirty="0"/>
           </a:p>
-        </p:txBody>
-      </p:sp>
-      <p:sp>
-        <p:nvSpPr>
-          <p:cNvPr id="9" name="Shape 7"/>
-          <p:cNvSpPr/>
-          <p:nvPr/>
-        </p:nvSpPr>
-        <p:spPr>
-          <a:xfrm>
-            <a:off x="6583680" y="2011680"/>
-            <a:ext cx="2468880" cy="1463040"/>
+          <a:p>
+            <a:pPr indent="0" marL="0">
+              <a:buNone/>
+            </a:pPr>
+            <a:r>
+              <a:rPr lang="en-US" sz="1100" dirty="0">
+                <a:solidFill>
+                  <a:srgbClr val="888888"/>
+                </a:solidFill>
+              </a:rPr>
+              <a:t>脂肪、碳水、纤维、糖</a:t>
+            </a:r>
+            <a:endParaRPr lang="en-US" sz="1100" dirty="0"/>
+          </a:p>
+        </p:txBody>
+      </p:sp>
+      <p:sp>
+        <p:nvSpPr>
+          <p:cNvPr id="12" name="Shape 10"/>
+          <p:cNvSpPr/>
+          <p:nvPr/>
+        </p:nvSpPr>
+        <p:spPr>
+          <a:xfrm>
+            <a:off x="6583680" y="2560320"/>
+            <a:ext cx="2468880" cy="2011680"/>
           </a:xfrm>
           <a:prstGeom prst="rect">
             <a:avLst/>
@@ -7365,9 +7632,9 @@
           <a:solidFill>
             <a:srgbClr val="FFFFFF"/>
           </a:solidFill>
-          <a:ln w="6350">
+          <a:ln w="19050">
             <a:solidFill>
-              <a:srgbClr val="E2E2E0"/>
+              <a:srgbClr val="1A56DB"/>
             </a:solidFill>
             <a:prstDash val="solid"/>
           </a:ln>
@@ -7375,13 +7642,38 @@
       </p:sp>
       <p:sp>
         <p:nvSpPr>
-          <p:cNvPr id="10" name="Text 8"/>
-          <p:cNvSpPr/>
-          <p:nvPr/>
-        </p:nvSpPr>
-        <p:spPr>
-          <a:xfrm>
-            <a:off x="6766560" y="2148840"/>
+          <p:cNvPr id="13" name="Shape 11"/>
+          <p:cNvSpPr/>
+          <p:nvPr/>
+        </p:nvSpPr>
+        <p:spPr>
+          <a:xfrm>
+            <a:off x="6583680" y="2560320"/>
+            <a:ext cx="54864" cy="2011680"/>
+          </a:xfrm>
+          <a:prstGeom prst="rect">
+            <a:avLst/>
+          </a:prstGeom>
+          <a:solidFill>
+            <a:srgbClr val="1A56DB"/>
+          </a:solidFill>
+          <a:ln w="12700">
+            <a:solidFill>
+              <a:srgbClr val="1A56DB"/>
+            </a:solidFill>
+            <a:prstDash val="solid"/>
+          </a:ln>
+        </p:spPr>
+      </p:sp>
+      <p:sp>
+        <p:nvSpPr>
+          <p:cNvPr id="14" name="Text 12"/>
+          <p:cNvSpPr/>
+          <p:nvPr/>
+        </p:nvSpPr>
+        <p:spPr>
+          <a:xfrm>
+            <a:off x="6858000" y="2697480"/>
             <a:ext cx="2103120" cy="365760"/>
           </a:xfrm>
           <a:prstGeom prst="rect">
@@ -7406,7 +7698,7 @@
                 <a:ea typeface="Microsoft YaHei" pitchFamily="34" charset="-122"/>
                 <a:cs typeface="Microsoft YaHei" pitchFamily="34" charset="-120"/>
               </a:rPr>
-              <a:t>体检报告看不懂</a:t>
+              <a:t>报告分析</a:t>
             </a:r>
             <a:endParaRPr lang="en-US" sz="1400" dirty="0"/>
           </a:p>
@@ -7414,14 +7706,14 @@
       </p:sp>
       <p:sp>
         <p:nvSpPr>
-          <p:cNvPr id="11" name="Text 9"/>
-          <p:cNvSpPr/>
-          <p:nvPr/>
-        </p:nvSpPr>
-        <p:spPr>
-          <a:xfrm>
-            <a:off x="6766560" y="2514600"/>
-            <a:ext cx="2103120" cy="822960"/>
+          <p:cNvPr id="15" name="Text 13"/>
+          <p:cNvSpPr/>
+          <p:nvPr/>
+        </p:nvSpPr>
+        <p:spPr>
+          <a:xfrm>
+            <a:off x="6858000" y="3063240"/>
+            <a:ext cx="2103120" cy="1371600"/>
           </a:xfrm>
           <a:prstGeom prst="rect">
             <a:avLst/>
@@ -7442,7 +7734,7 @@
                   <a:srgbClr val="888888"/>
                 </a:solidFill>
               </a:rPr>
-              <a:t>拿了报告不知指标含义</a:t>
+              <a:t>上传体检报告图片</a:t>
             </a:r>
             <a:endParaRPr lang="en-US" sz="1100" dirty="0"/>
           </a:p>
@@ -7456,96 +7748,10 @@
                   <a:srgbClr val="888888"/>
                 </a:solidFill>
               </a:rPr>
-              <a:t>不知怎么调整饮食</a:t>
+              <a:t>AI 三段式输出</a:t>
             </a:r>
             <a:endParaRPr lang="en-US" sz="1100" dirty="0"/>
           </a:p>
-        </p:txBody>
-      </p:sp>
-      <p:sp>
-        <p:nvSpPr>
-          <p:cNvPr id="12" name="Shape 10"/>
-          <p:cNvSpPr/>
-          <p:nvPr/>
-        </p:nvSpPr>
-        <p:spPr>
-          <a:xfrm>
-            <a:off x="1097280" y="3840480"/>
-            <a:ext cx="2468880" cy="1463040"/>
-          </a:xfrm>
-          <a:prstGeom prst="rect">
-            <a:avLst/>
-          </a:prstGeom>
-          <a:solidFill>
-            <a:srgbClr val="FFFFFF"/>
-          </a:solidFill>
-          <a:ln w="6350">
-            <a:solidFill>
-              <a:srgbClr val="E2E2E0"/>
-            </a:solidFill>
-            <a:prstDash val="solid"/>
-          </a:ln>
-        </p:spPr>
-      </p:sp>
-      <p:sp>
-        <p:nvSpPr>
-          <p:cNvPr id="13" name="Text 11"/>
-          <p:cNvSpPr/>
-          <p:nvPr/>
-        </p:nvSpPr>
-        <p:spPr>
-          <a:xfrm>
-            <a:off x="1280160" y="3977640"/>
-            <a:ext cx="2103120" cy="365760"/>
-          </a:xfrm>
-          <a:prstGeom prst="rect">
-            <a:avLst/>
-          </a:prstGeom>
-          <a:noFill/>
-          <a:ln/>
-        </p:spPr>
-        <p:txBody>
-          <a:bodyPr wrap="square" rtlCol="0" anchor="ctr"/>
-          <a:lstStyle/>
-          <a:p>
-            <a:pPr indent="0" marL="0">
-              <a:buNone/>
-            </a:pPr>
-            <a:r>
-              <a:rPr lang="en-US" sz="1400" dirty="0">
-                <a:solidFill>
-                  <a:srgbClr val="0A0A0A"/>
-                </a:solidFill>
-                <a:latin typeface="Microsoft YaHei" pitchFamily="34" charset="0"/>
-                <a:ea typeface="Microsoft YaHei" pitchFamily="34" charset="-122"/>
-                <a:cs typeface="Microsoft YaHei" pitchFamily="34" charset="-120"/>
-              </a:rPr>
-              <a:t>缺乏个性化</a:t>
-            </a:r>
-            <a:endParaRPr lang="en-US" sz="1400" dirty="0"/>
-          </a:p>
-        </p:txBody>
-      </p:sp>
-      <p:sp>
-        <p:nvSpPr>
-          <p:cNvPr id="14" name="Text 12"/>
-          <p:cNvSpPr/>
-          <p:nvPr/>
-        </p:nvSpPr>
-        <p:spPr>
-          <a:xfrm>
-            <a:off x="1280160" y="4343400"/>
-            <a:ext cx="2103120" cy="822960"/>
-          </a:xfrm>
-          <a:prstGeom prst="rect">
-            <a:avLst/>
-          </a:prstGeom>
-          <a:noFill/>
-          <a:ln/>
-        </p:spPr>
-        <p:txBody>
-          <a:bodyPr wrap="square" rtlCol="0" anchor="ctr"/>
-          <a:lstStyle/>
           <a:p>
             <a:pPr indent="0" marL="0">
               <a:buNone/>
@@ -7556,251 +7762,45 @@
                   <a:srgbClr val="888888"/>
                 </a:solidFill>
               </a:rPr>
-              <a:t>热量 App 千篇一律</a:t>
+              <a:t>指标提取 → 风险评估 → 饮食建议</a:t>
             </a:r>
             <a:endParaRPr lang="en-US" sz="1100" dirty="0"/>
           </a:p>
-          <a:p>
-            <a:pPr indent="0" marL="0">
-              <a:buNone/>
-            </a:pPr>
-            <a:r>
-              <a:rPr lang="en-US" sz="1100" dirty="0">
+        </p:txBody>
+      </p:sp>
+      <p:sp>
+        <p:nvSpPr>
+          <p:cNvPr id="16" name="Text 14"/>
+          <p:cNvSpPr/>
+          <p:nvPr/>
+        </p:nvSpPr>
+        <p:spPr>
+          <a:xfrm>
+            <a:off x="1097280" y="5029200"/>
+            <a:ext cx="9144000" cy="0"/>
+          </a:xfrm>
+          <a:prstGeom prst="rect">
+            <a:avLst/>
+          </a:prstGeom>
+          <a:noFill/>
+          <a:ln/>
+        </p:spPr>
+        <p:txBody>
+          <a:bodyPr wrap="square" rtlCol="0" anchor="ctr"/>
+          <a:lstStyle/>
+          <a:p>
+            <a:pPr indent="0" marL="0">
+              <a:buNone/>
+            </a:pPr>
+            <a:r>
+              <a:rPr lang="en-US" sz="1000" dirty="0">
                 <a:solidFill>
                   <a:srgbClr val="888888"/>
                 </a:solidFill>
               </a:rPr>
-              <a:t>不根据个人健康状况调整</a:t>
-            </a:r>
-            <a:endParaRPr lang="en-US" sz="1100" dirty="0"/>
-          </a:p>
-        </p:txBody>
-      </p:sp>
-      <p:sp>
-        <p:nvSpPr>
-          <p:cNvPr id="15" name="Shape 13"/>
-          <p:cNvSpPr/>
-          <p:nvPr/>
-        </p:nvSpPr>
-        <p:spPr>
-          <a:xfrm>
-            <a:off x="3840480" y="3840480"/>
-            <a:ext cx="2468880" cy="1463040"/>
-          </a:xfrm>
-          <a:prstGeom prst="rect">
-            <a:avLst/>
-          </a:prstGeom>
-          <a:solidFill>
-            <a:srgbClr val="FFFFFF"/>
-          </a:solidFill>
-          <a:ln w="6350">
-            <a:solidFill>
-              <a:srgbClr val="E2E2E0"/>
-            </a:solidFill>
-            <a:prstDash val="solid"/>
-          </a:ln>
-        </p:spPr>
-      </p:sp>
-      <p:sp>
-        <p:nvSpPr>
-          <p:cNvPr id="16" name="Text 14"/>
-          <p:cNvSpPr/>
-          <p:nvPr/>
-        </p:nvSpPr>
-        <p:spPr>
-          <a:xfrm>
-            <a:off x="4023360" y="3977640"/>
-            <a:ext cx="2103120" cy="365760"/>
-          </a:xfrm>
-          <a:prstGeom prst="rect">
-            <a:avLst/>
-          </a:prstGeom>
-          <a:noFill/>
-          <a:ln/>
-        </p:spPr>
-        <p:txBody>
-          <a:bodyPr wrap="square" rtlCol="0" anchor="ctr"/>
-          <a:lstStyle/>
-          <a:p>
-            <a:pPr indent="0" marL="0">
-              <a:buNone/>
-            </a:pPr>
-            <a:r>
-              <a:rPr lang="en-US" sz="1400" dirty="0">
-                <a:solidFill>
-                  <a:srgbClr val="0A0A0A"/>
-                </a:solidFill>
-                <a:latin typeface="Microsoft YaHei" pitchFamily="34" charset="0"/>
-                <a:ea typeface="Microsoft YaHei" pitchFamily="34" charset="-122"/>
-                <a:cs typeface="Microsoft YaHei" pitchFamily="34" charset="-120"/>
-              </a:rPr>
-              <a:t>中餐识别差</a:t>
-            </a:r>
-            <a:endParaRPr lang="en-US" sz="1400" dirty="0"/>
-          </a:p>
-        </p:txBody>
-      </p:sp>
-      <p:sp>
-        <p:nvSpPr>
-          <p:cNvPr id="17" name="Text 15"/>
-          <p:cNvSpPr/>
-          <p:nvPr/>
-        </p:nvSpPr>
-        <p:spPr>
-          <a:xfrm>
-            <a:off x="4023360" y="4343400"/>
-            <a:ext cx="2103120" cy="822960"/>
-          </a:xfrm>
-          <a:prstGeom prst="rect">
-            <a:avLst/>
-          </a:prstGeom>
-          <a:noFill/>
-          <a:ln/>
-        </p:spPr>
-        <p:txBody>
-          <a:bodyPr wrap="square" rtlCol="0" anchor="ctr"/>
-          <a:lstStyle/>
-          <a:p>
-            <a:pPr indent="0" marL="0">
-              <a:buNone/>
-            </a:pPr>
-            <a:r>
-              <a:rPr lang="en-US" sz="1100" dirty="0">
-                <a:solidFill>
-                  <a:srgbClr val="888888"/>
-                </a:solidFill>
-              </a:rPr>
-              <a:t>海外竞品西餐为主</a:t>
-            </a:r>
-            <a:endParaRPr lang="en-US" sz="1100" dirty="0"/>
-          </a:p>
-          <a:p>
-            <a:pPr indent="0" marL="0">
-              <a:buNone/>
-            </a:pPr>
-            <a:r>
-              <a:rPr lang="en-US" sz="1100" dirty="0">
-                <a:solidFill>
-                  <a:srgbClr val="888888"/>
-                </a:solidFill>
-              </a:rPr>
-              <a:t>中餐数据匮乏</a:t>
-            </a:r>
-            <a:endParaRPr lang="en-US" sz="1100" dirty="0"/>
-          </a:p>
-        </p:txBody>
-      </p:sp>
-      <p:sp>
-        <p:nvSpPr>
-          <p:cNvPr id="18" name="Shape 16"/>
-          <p:cNvSpPr/>
-          <p:nvPr/>
-        </p:nvSpPr>
-        <p:spPr>
-          <a:xfrm>
-            <a:off x="6583680" y="3840480"/>
-            <a:ext cx="2468880" cy="1463040"/>
-          </a:xfrm>
-          <a:prstGeom prst="rect">
-            <a:avLst/>
-          </a:prstGeom>
-          <a:solidFill>
-            <a:srgbClr val="FFFFFF"/>
-          </a:solidFill>
-          <a:ln w="6350">
-            <a:solidFill>
-              <a:srgbClr val="E2E2E0"/>
-            </a:solidFill>
-            <a:prstDash val="solid"/>
-          </a:ln>
-        </p:spPr>
-      </p:sp>
-      <p:sp>
-        <p:nvSpPr>
-          <p:cNvPr id="19" name="Text 17"/>
-          <p:cNvSpPr/>
-          <p:nvPr/>
-        </p:nvSpPr>
-        <p:spPr>
-          <a:xfrm>
-            <a:off x="6766560" y="3977640"/>
-            <a:ext cx="2103120" cy="365760"/>
-          </a:xfrm>
-          <a:prstGeom prst="rect">
-            <a:avLst/>
-          </a:prstGeom>
-          <a:noFill/>
-          <a:ln/>
-        </p:spPr>
-        <p:txBody>
-          <a:bodyPr wrap="square" rtlCol="0" anchor="ctr"/>
-          <a:lstStyle/>
-          <a:p>
-            <a:pPr indent="0" marL="0">
-              <a:buNone/>
-            </a:pPr>
-            <a:r>
-              <a:rPr lang="en-US" sz="1400" dirty="0">
-                <a:solidFill>
-                  <a:srgbClr val="0A0A0A"/>
-                </a:solidFill>
-                <a:latin typeface="Microsoft YaHei" pitchFamily="34" charset="0"/>
-                <a:ea typeface="Microsoft YaHei" pitchFamily="34" charset="-122"/>
-                <a:cs typeface="Microsoft YaHei" pitchFamily="34" charset="-120"/>
-              </a:rPr>
-              <a:t>缺 AI 深度</a:t>
-            </a:r>
-            <a:endParaRPr lang="en-US" sz="1400" dirty="0"/>
-          </a:p>
-        </p:txBody>
-      </p:sp>
-      <p:sp>
-        <p:nvSpPr>
-          <p:cNvPr id="20" name="Text 18"/>
-          <p:cNvSpPr/>
-          <p:nvPr/>
-        </p:nvSpPr>
-        <p:spPr>
-          <a:xfrm>
-            <a:off x="6766560" y="4343400"/>
-            <a:ext cx="2103120" cy="822960"/>
-          </a:xfrm>
-          <a:prstGeom prst="rect">
-            <a:avLst/>
-          </a:prstGeom>
-          <a:noFill/>
-          <a:ln/>
-        </p:spPr>
-        <p:txBody>
-          <a:bodyPr wrap="square" rtlCol="0" anchor="ctr"/>
-          <a:lstStyle/>
-          <a:p>
-            <a:pPr indent="0" marL="0">
-              <a:buNone/>
-            </a:pPr>
-            <a:r>
-              <a:rPr lang="en-US" sz="1100" dirty="0">
-                <a:solidFill>
-                  <a:srgbClr val="888888"/>
-                </a:solidFill>
-              </a:rPr>
-              <a:t>现有产品简单数据库查询</a:t>
-            </a:r>
-            <a:endParaRPr lang="en-US" sz="1100" dirty="0"/>
-          </a:p>
-          <a:p>
-            <a:pPr indent="0" marL="0">
-              <a:buNone/>
-            </a:pPr>
-            <a:r>
-              <a:rPr lang="en-US" sz="1100" dirty="0">
-                <a:solidFill>
-                  <a:srgbClr val="888888"/>
-                </a:solidFill>
-              </a:rPr>
-              <a:t>缺乏真正的 AI 分析能力</a:t>
-            </a:r>
-            <a:endParaRPr lang="en-US" sz="1100" dirty="0"/>
+              <a:t>OCR 指标提取  ·  规则引擎 + AI 双通道建议  ·  中医食补 AI</a:t>
+            </a:r>
+            <a:endParaRPr lang="en-US" sz="1000" dirty="0"/>
           </a:p>
         </p:txBody>
       </p:sp>

</xml_diff>

<commit_message>
fix: force dynamic rendering on dashboard for real-time date
</commit_message>
<xml_diff>
--- a/ppt/健康追踪-商业计划书.pptx
+++ b/ppt/健康追踪-商业计划书.pptx
@@ -19,9 +19,10 @@
     <p:sldId id="267" r:id="rId13"/>
     <p:sldId id="268" r:id="rId14"/>
     <p:sldId id="269" r:id="rId15"/>
+    <p:sldId id="270" r:id="rId16"/>
   </p:sldIdLst>
   <p:notesMasterIdLst>
-    <p:notesMasterId r:id="rId16"/>
+    <p:notesMasterId r:id="rId17"/>
   </p:notesMasterIdLst>
   <p:sldSz cx="12192000" cy="6858000"/>
   <p:notesSz cx="6858000" cy="12192000"/>
@@ -979,6 +980,94 @@
             <a:fld id="{F7021451-1387-4CA6-816F-3879F97B5CBC}" type="slidenum">
               <a:rPr lang="en-US"/>
               <a:t>14</a:t>
+            </a:fld>
+            <a:endParaRPr lang="en-US"/>
+          </a:p>
+        </p:txBody>
+      </p:sp>
+    </p:spTree>
+    <p:extLst>
+      <p:ext uri="{BB962C8B-B14F-4D97-AF65-F5344CB8AC3E}">
+        <p14:creationId xmlns:p14="http://schemas.microsoft.com/office/powerpoint/2010/main" val="1024086991"/>
+      </p:ext>
+    </p:extLst>
+  </p:cSld>
+  <p:clrMapOvr>
+    <a:masterClrMapping/>
+  </p:clrMapOvr>
+</p:notes>
+</file>
+
+<file path=ppt/notesSlides/notesSlide15.xml><?xml version="1.0" encoding="utf-8"?>
+<p:notes xmlns:a="http://schemas.openxmlformats.org/drawingml/2006/main" xmlns:r="http://schemas.openxmlformats.org/officeDocument/2006/relationships" xmlns:p="http://schemas.openxmlformats.org/presentationml/2006/main">
+  <p:cSld>
+    <p:spTree>
+      <p:nvGrpSpPr>
+        <p:cNvPr id="1" name=""/>
+        <p:cNvGrpSpPr/>
+        <p:nvPr/>
+      </p:nvGrpSpPr>
+      <p:grpSpPr>
+        <a:xfrm>
+          <a:off x="0" y="0"/>
+          <a:ext cx="0" cy="0"/>
+          <a:chOff x="0" y="0"/>
+          <a:chExt cx="0" cy="0"/>
+        </a:xfrm>
+      </p:grpSpPr>
+      <p:sp>
+        <p:nvSpPr>
+          <p:cNvPr id="2" name="Slide Image Placeholder 1"/>
+          <p:cNvSpPr>
+            <a:spLocks noGrp="1" noRot="1" noChangeAspect="1"/>
+          </p:cNvSpPr>
+          <p:nvPr>
+            <p:ph type="sldImg"/>
+          </p:nvPr>
+        </p:nvSpPr>
+        <p:spPr/>
+      </p:sp>
+      <p:sp>
+        <p:nvSpPr>
+          <p:cNvPr id="3" name="Notes Placeholder 2"/>
+          <p:cNvSpPr>
+            <a:spLocks noGrp="1"/>
+          </p:cNvSpPr>
+          <p:nvPr>
+            <p:ph type="body" idx="1"/>
+          </p:nvPr>
+        </p:nvSpPr>
+        <p:spPr/>
+        <p:txBody>
+          <a:bodyPr/>
+          <a:lstStyle/>
+          <a:p>
+            <a:r>
+              <a:rPr lang="en-US" dirty="0"/>
+              <a:t/>
+            </a:r>
+            <a:endParaRPr lang="en-US" dirty="0"/>
+          </a:p>
+        </p:txBody>
+      </p:sp>
+      <p:sp>
+        <p:nvSpPr>
+          <p:cNvPr id="4" name="Slide Number Placeholder 3"/>
+          <p:cNvSpPr>
+            <a:spLocks noGrp="1"/>
+          </p:cNvSpPr>
+          <p:nvPr>
+            <p:ph type="sldNum" sz="quarter" idx="10"/>
+          </p:nvPr>
+        </p:nvSpPr>
+        <p:spPr/>
+        <p:txBody>
+          <a:bodyPr/>
+          <a:lstStyle/>
+          <a:p>
+            <a:fld id="{F7021451-1387-4CA6-816F-3879F97B5CBC}" type="slidenum">
+              <a:rPr lang="en-US"/>
+              <a:t>15</a:t>
             </a:fld>
             <a:endParaRPr lang="en-US"/>
           </a:p>
@@ -2065,7 +2154,7 @@
                 <a:ea typeface="Microsoft YaHei Light" pitchFamily="34" charset="-122"/>
                 <a:cs typeface="Microsoft YaHei Light" pitchFamily="34" charset="-120"/>
               </a:rPr>
-              <a:t>健康追踪</a:t>
+              <a:t>轻舟 · 健康追踪</a:t>
             </a:r>
             <a:endParaRPr lang="en-US" sz="5800" dirty="0"/>
           </a:p>
@@ -2671,7 +2760,7 @@
                 <a:ea typeface="Microsoft YaHei" pitchFamily="34" charset="-122"/>
                 <a:cs typeface="Microsoft YaHei" pitchFamily="34" charset="-120"/>
               </a:rPr>
-              <a:t>财务预测（第一年）</a:t>
+              <a:t>团队</a:t>
             </a:r>
             <a:endParaRPr lang="en-US" sz="1200" dirty="0"/>
           </a:p>
@@ -2685,8 +2774,8 @@
         </p:nvSpPr>
         <p:spPr>
           <a:xfrm>
-            <a:off x="1097280" y="1828800"/>
-            <a:ext cx="2468880" cy="2560320"/>
+            <a:off x="1097280" y="2286000"/>
+            <a:ext cx="2468880" cy="2743200"/>
           </a:xfrm>
           <a:prstGeom prst="rect">
             <a:avLst/>
@@ -2710,8 +2799,8 @@
         </p:nvSpPr>
         <p:spPr>
           <a:xfrm>
-            <a:off x="1097280" y="2011680"/>
-            <a:ext cx="2468880" cy="914400"/>
+            <a:off x="1097280" y="2468880"/>
+            <a:ext cx="2468880" cy="0"/>
           </a:xfrm>
           <a:prstGeom prst="rect">
             <a:avLst/>
@@ -2727,30 +2816,63 @@
               <a:buNone/>
             </a:pPr>
             <a:r>
-              <a:rPr lang="en-US" sz="3800" dirty="0">
+              <a:rPr lang="en-US" sz="1300" b="1" dirty="0">
+                <a:solidFill>
+                  <a:srgbClr val="1A56DB"/>
+                </a:solidFill>
+              </a:rPr>
+              <a:t>官网负责人</a:t>
+            </a:r>
+            <a:endParaRPr lang="en-US" sz="1300" dirty="0"/>
+          </a:p>
+        </p:txBody>
+      </p:sp>
+      <p:sp>
+        <p:nvSpPr>
+          <p:cNvPr id="5" name="Text 3"/>
+          <p:cNvSpPr/>
+          <p:nvPr/>
+        </p:nvSpPr>
+        <p:spPr>
+          <a:xfrm>
+            <a:off x="1097280" y="3017520"/>
+            <a:ext cx="2468880" cy="0"/>
+          </a:xfrm>
+          <a:prstGeom prst="rect">
+            <a:avLst/>
+          </a:prstGeom>
+          <a:noFill/>
+          <a:ln/>
+        </p:spPr>
+        <p:txBody>
+          <a:bodyPr wrap="square" rtlCol="0" anchor="ctr"/>
+          <a:lstStyle/>
+          <a:p>
+            <a:pPr algn="ctr" indent="0" marL="0">
+              <a:buNone/>
+            </a:pPr>
+            <a:r>
+              <a:rPr lang="en-US" sz="2200" dirty="0">
                 <a:solidFill>
                   <a:srgbClr val="0A0A0A"/>
                 </a:solidFill>
-                <a:latin typeface="Microsoft YaHei Light" pitchFamily="34" charset="0"/>
-                <a:ea typeface="Microsoft YaHei Light" pitchFamily="34" charset="-122"/>
-                <a:cs typeface="Microsoft YaHei Light" pitchFamily="34" charset="-120"/>
-              </a:rPr>
-              <a:t>¥5 万</a:t>
-            </a:r>
-            <a:endParaRPr lang="en-US" sz="3800" dirty="0"/>
-          </a:p>
-        </p:txBody>
-      </p:sp>
-      <p:sp>
-        <p:nvSpPr>
-          <p:cNvPr id="5" name="Text 3"/>
-          <p:cNvSpPr/>
-          <p:nvPr/>
-        </p:nvSpPr>
-        <p:spPr>
-          <a:xfrm>
-            <a:off x="1097280" y="3017520"/>
-            <a:ext cx="2468880" cy="457200"/>
+              </a:rPr>
+              <a:t>丁玥文</a:t>
+            </a:r>
+            <a:endParaRPr lang="en-US" sz="2200" dirty="0"/>
+          </a:p>
+        </p:txBody>
+      </p:sp>
+      <p:sp>
+        <p:nvSpPr>
+          <p:cNvPr id="6" name="Text 4"/>
+          <p:cNvSpPr/>
+          <p:nvPr/>
+        </p:nvSpPr>
+        <p:spPr>
+          <a:xfrm>
+            <a:off x="1097280" y="3657600"/>
+            <a:ext cx="2468880" cy="0"/>
           </a:xfrm>
           <a:prstGeom prst="rect">
             <a:avLst/>
@@ -2766,37 +2888,15 @@
               <a:buNone/>
             </a:pPr>
             <a:r>
-              <a:rPr lang="en-US" sz="1600" dirty="0">
-                <a:solidFill>
-                  <a:srgbClr val="0A0A0A"/>
-                </a:solidFill>
-              </a:rPr>
-              <a:t>保守</a:t>
-            </a:r>
-            <a:endParaRPr lang="en-US" sz="1600" dirty="0"/>
-          </a:p>
-        </p:txBody>
-      </p:sp>
-      <p:sp>
-        <p:nvSpPr>
-          <p:cNvPr id="6" name="Text 4"/>
-          <p:cNvSpPr/>
-          <p:nvPr/>
-        </p:nvSpPr>
-        <p:spPr>
-          <a:xfrm>
-            <a:off x="1097280" y="3474720"/>
-            <a:ext cx="2468880" cy="457200"/>
-          </a:xfrm>
-          <a:prstGeom prst="rect">
-            <a:avLst/>
-          </a:prstGeom>
-          <a:noFill/>
-          <a:ln/>
-        </p:spPr>
-        <p:txBody>
-          <a:bodyPr wrap="square" rtlCol="0" anchor="ctr"/>
-          <a:lstStyle/>
+              <a:rPr lang="en-US" sz="1100" dirty="0">
+                <a:solidFill>
+                  <a:srgbClr val="888888"/>
+                </a:solidFill>
+              </a:rPr>
+              <a:t>官网设计制作</a:t>
+            </a:r>
+            <a:endParaRPr lang="en-US" sz="1100" dirty="0"/>
+          </a:p>
           <a:p>
             <a:pPr algn="ctr" indent="0" marL="0">
               <a:buNone/>
@@ -2807,7 +2907,7 @@
                   <a:srgbClr val="888888"/>
                 </a:solidFill>
               </a:rPr>
-              <a:t>1 万人  ·  3% 付费</a:t>
+              <a:t>在线 Demo 展示</a:t>
             </a:r>
             <a:endParaRPr lang="en-US" sz="1100" dirty="0"/>
           </a:p>
@@ -2821,8 +2921,8 @@
         </p:nvSpPr>
         <p:spPr>
           <a:xfrm>
-            <a:off x="3840480" y="1828800"/>
-            <a:ext cx="2468880" cy="2560320"/>
+            <a:off x="3840480" y="2286000"/>
+            <a:ext cx="2468880" cy="2743200"/>
           </a:xfrm>
           <a:prstGeom prst="rect">
             <a:avLst/>
@@ -2846,8 +2946,8 @@
         </p:nvSpPr>
         <p:spPr>
           <a:xfrm>
-            <a:off x="3840480" y="2011680"/>
-            <a:ext cx="2468880" cy="914400"/>
+            <a:off x="3840480" y="2468880"/>
+            <a:ext cx="2468880" cy="0"/>
           </a:xfrm>
           <a:prstGeom prst="rect">
             <a:avLst/>
@@ -2863,30 +2963,63 @@
               <a:buNone/>
             </a:pPr>
             <a:r>
-              <a:rPr lang="en-US" sz="3800" dirty="0">
+              <a:rPr lang="en-US" sz="1300" b="1" dirty="0">
+                <a:solidFill>
+                  <a:srgbClr val="1A56DB"/>
+                </a:solidFill>
+              </a:rPr>
+              <a:t>产品负责人</a:t>
+            </a:r>
+            <a:endParaRPr lang="en-US" sz="1300" dirty="0"/>
+          </a:p>
+        </p:txBody>
+      </p:sp>
+      <p:sp>
+        <p:nvSpPr>
+          <p:cNvPr id="9" name="Text 7"/>
+          <p:cNvSpPr/>
+          <p:nvPr/>
+        </p:nvSpPr>
+        <p:spPr>
+          <a:xfrm>
+            <a:off x="3840480" y="3017520"/>
+            <a:ext cx="2468880" cy="0"/>
+          </a:xfrm>
+          <a:prstGeom prst="rect">
+            <a:avLst/>
+          </a:prstGeom>
+          <a:noFill/>
+          <a:ln/>
+        </p:spPr>
+        <p:txBody>
+          <a:bodyPr wrap="square" rtlCol="0" anchor="ctr"/>
+          <a:lstStyle/>
+          <a:p>
+            <a:pPr algn="ctr" indent="0" marL="0">
+              <a:buNone/>
+            </a:pPr>
+            <a:r>
+              <a:rPr lang="en-US" sz="2200" dirty="0">
                 <a:solidFill>
                   <a:srgbClr val="0A0A0A"/>
                 </a:solidFill>
-                <a:latin typeface="Microsoft YaHei Light" pitchFamily="34" charset="0"/>
-                <a:ea typeface="Microsoft YaHei Light" pitchFamily="34" charset="-122"/>
-                <a:cs typeface="Microsoft YaHei Light" pitchFamily="34" charset="-120"/>
-              </a:rPr>
-              <a:t>¥42 万</a:t>
-            </a:r>
-            <a:endParaRPr lang="en-US" sz="3800" dirty="0"/>
-          </a:p>
-        </p:txBody>
-      </p:sp>
-      <p:sp>
-        <p:nvSpPr>
-          <p:cNvPr id="9" name="Text 7"/>
-          <p:cNvSpPr/>
-          <p:nvPr/>
-        </p:nvSpPr>
-        <p:spPr>
-          <a:xfrm>
-            <a:off x="3840480" y="3017520"/>
-            <a:ext cx="2468880" cy="457200"/>
+              </a:rPr>
+              <a:t>方雅琪</a:t>
+            </a:r>
+            <a:endParaRPr lang="en-US" sz="2200" dirty="0"/>
+          </a:p>
+        </p:txBody>
+      </p:sp>
+      <p:sp>
+        <p:nvSpPr>
+          <p:cNvPr id="10" name="Text 8"/>
+          <p:cNvSpPr/>
+          <p:nvPr/>
+        </p:nvSpPr>
+        <p:spPr>
+          <a:xfrm>
+            <a:off x="3840480" y="3657600"/>
+            <a:ext cx="2468880" cy="0"/>
           </a:xfrm>
           <a:prstGeom prst="rect">
             <a:avLst/>
@@ -2902,37 +3035,15 @@
               <a:buNone/>
             </a:pPr>
             <a:r>
-              <a:rPr lang="en-US" sz="1600" dirty="0">
-                <a:solidFill>
-                  <a:srgbClr val="0A0A0A"/>
-                </a:solidFill>
-              </a:rPr>
-              <a:t>中等</a:t>
-            </a:r>
-            <a:endParaRPr lang="en-US" sz="1600" dirty="0"/>
-          </a:p>
-        </p:txBody>
-      </p:sp>
-      <p:sp>
-        <p:nvSpPr>
-          <p:cNvPr id="10" name="Text 8"/>
-          <p:cNvSpPr/>
-          <p:nvPr/>
-        </p:nvSpPr>
-        <p:spPr>
-          <a:xfrm>
-            <a:off x="3840480" y="3474720"/>
-            <a:ext cx="2468880" cy="457200"/>
-          </a:xfrm>
-          <a:prstGeom prst="rect">
-            <a:avLst/>
-          </a:prstGeom>
-          <a:noFill/>
-          <a:ln/>
-        </p:spPr>
-        <p:txBody>
-          <a:bodyPr wrap="square" rtlCol="0" anchor="ctr"/>
-          <a:lstStyle/>
+              <a:rPr lang="en-US" sz="1100" dirty="0">
+                <a:solidFill>
+                  <a:srgbClr val="888888"/>
+                </a:solidFill>
+              </a:rPr>
+              <a:t>全栈开发 · AI 集成</a:t>
+            </a:r>
+            <a:endParaRPr lang="en-US" sz="1100" dirty="0"/>
+          </a:p>
           <a:p>
             <a:pPr algn="ctr" indent="0" marL="0">
               <a:buNone/>
@@ -2943,7 +3054,7 @@
                   <a:srgbClr val="888888"/>
                 </a:solidFill>
               </a:rPr>
-              <a:t>5 万人  ·  5% 付费</a:t>
+              <a:t>产品设计</a:t>
             </a:r>
             <a:endParaRPr lang="en-US" sz="1100" dirty="0"/>
           </a:p>
@@ -2957,8 +3068,8 @@
         </p:nvSpPr>
         <p:spPr>
           <a:xfrm>
-            <a:off x="6583680" y="1828800"/>
-            <a:ext cx="2468880" cy="2560320"/>
+            <a:off x="6583680" y="2286000"/>
+            <a:ext cx="2468880" cy="2743200"/>
           </a:xfrm>
           <a:prstGeom prst="rect">
             <a:avLst/>
@@ -2982,8 +3093,8 @@
         </p:nvSpPr>
         <p:spPr>
           <a:xfrm>
-            <a:off x="6583680" y="2011680"/>
-            <a:ext cx="2468880" cy="914400"/>
+            <a:off x="6583680" y="2468880"/>
+            <a:ext cx="2468880" cy="0"/>
           </a:xfrm>
           <a:prstGeom prst="rect">
             <a:avLst/>
@@ -2999,30 +3110,63 @@
               <a:buNone/>
             </a:pPr>
             <a:r>
-              <a:rPr lang="en-US" sz="3800" dirty="0">
+              <a:rPr lang="en-US" sz="1300" b="1" dirty="0">
+                <a:solidFill>
+                  <a:srgbClr val="1A56DB"/>
+                </a:solidFill>
+              </a:rPr>
+              <a:t>运营支持</a:t>
+            </a:r>
+            <a:endParaRPr lang="en-US" sz="1300" dirty="0"/>
+          </a:p>
+        </p:txBody>
+      </p:sp>
+      <p:sp>
+        <p:nvSpPr>
+          <p:cNvPr id="13" name="Text 11"/>
+          <p:cNvSpPr/>
+          <p:nvPr/>
+        </p:nvSpPr>
+        <p:spPr>
+          <a:xfrm>
+            <a:off x="6583680" y="3017520"/>
+            <a:ext cx="2468880" cy="0"/>
+          </a:xfrm>
+          <a:prstGeom prst="rect">
+            <a:avLst/>
+          </a:prstGeom>
+          <a:noFill/>
+          <a:ln/>
+        </p:spPr>
+        <p:txBody>
+          <a:bodyPr wrap="square" rtlCol="0" anchor="ctr"/>
+          <a:lstStyle/>
+          <a:p>
+            <a:pPr algn="ctr" indent="0" marL="0">
+              <a:buNone/>
+            </a:pPr>
+            <a:r>
+              <a:rPr lang="en-US" sz="2200" dirty="0">
                 <a:solidFill>
                   <a:srgbClr val="0A0A0A"/>
                 </a:solidFill>
-                <a:latin typeface="Microsoft YaHei Light" pitchFamily="34" charset="0"/>
-                <a:ea typeface="Microsoft YaHei Light" pitchFamily="34" charset="-122"/>
-                <a:cs typeface="Microsoft YaHei Light" pitchFamily="34" charset="-120"/>
-              </a:rPr>
-              <a:t>¥269 万</a:t>
-            </a:r>
-            <a:endParaRPr lang="en-US" sz="3800" dirty="0"/>
-          </a:p>
-        </p:txBody>
-      </p:sp>
-      <p:sp>
-        <p:nvSpPr>
-          <p:cNvPr id="13" name="Text 11"/>
-          <p:cNvSpPr/>
-          <p:nvPr/>
-        </p:nvSpPr>
-        <p:spPr>
-          <a:xfrm>
-            <a:off x="6583680" y="3017520"/>
-            <a:ext cx="2468880" cy="457200"/>
+              </a:rPr>
+              <a:t>王琰若</a:t>
+            </a:r>
+            <a:endParaRPr lang="en-US" sz="2200" dirty="0"/>
+          </a:p>
+        </p:txBody>
+      </p:sp>
+      <p:sp>
+        <p:nvSpPr>
+          <p:cNvPr id="14" name="Text 12"/>
+          <p:cNvSpPr/>
+          <p:nvPr/>
+        </p:nvSpPr>
+        <p:spPr>
+          <a:xfrm>
+            <a:off x="6583680" y="3657600"/>
+            <a:ext cx="2468880" cy="0"/>
           </a:xfrm>
           <a:prstGeom prst="rect">
             <a:avLst/>
@@ -3038,37 +3182,15 @@
               <a:buNone/>
             </a:pPr>
             <a:r>
-              <a:rPr lang="en-US" sz="1600" dirty="0">
-                <a:solidFill>
-                  <a:srgbClr val="0A0A0A"/>
-                </a:solidFill>
-              </a:rPr>
-              <a:t>乐观</a:t>
-            </a:r>
-            <a:endParaRPr lang="en-US" sz="1600" dirty="0"/>
-          </a:p>
-        </p:txBody>
-      </p:sp>
-      <p:sp>
-        <p:nvSpPr>
-          <p:cNvPr id="14" name="Text 12"/>
-          <p:cNvSpPr/>
-          <p:nvPr/>
-        </p:nvSpPr>
-        <p:spPr>
-          <a:xfrm>
-            <a:off x="6583680" y="3474720"/>
-            <a:ext cx="2468880" cy="457200"/>
-          </a:xfrm>
-          <a:prstGeom prst="rect">
-            <a:avLst/>
-          </a:prstGeom>
-          <a:noFill/>
-          <a:ln/>
-        </p:spPr>
-        <p:txBody>
-          <a:bodyPr wrap="square" rtlCol="0" anchor="ctr"/>
-          <a:lstStyle/>
+              <a:rPr lang="en-US" sz="1100" dirty="0">
+                <a:solidFill>
+                  <a:srgbClr val="888888"/>
+                </a:solidFill>
+              </a:rPr>
+              <a:t>体质健康自检问卷</a:t>
+            </a:r>
+            <a:endParaRPr lang="en-US" sz="1100" dirty="0"/>
+          </a:p>
           <a:p>
             <a:pPr algn="ctr" indent="0" marL="0">
               <a:buNone/>
@@ -3079,45 +3201,9 @@
                   <a:srgbClr val="888888"/>
                 </a:solidFill>
               </a:rPr>
-              <a:t>20 万人  ·  8% 付费</a:t>
+              <a:t>官网嵌入 · 运营辅助</a:t>
             </a:r>
             <a:endParaRPr lang="en-US" sz="1100" dirty="0"/>
-          </a:p>
-        </p:txBody>
-      </p:sp>
-      <p:sp>
-        <p:nvSpPr>
-          <p:cNvPr id="15" name="Text 13"/>
-          <p:cNvSpPr/>
-          <p:nvPr/>
-        </p:nvSpPr>
-        <p:spPr>
-          <a:xfrm>
-            <a:off x="1097280" y="5029200"/>
-            <a:ext cx="9144000" cy="0"/>
-          </a:xfrm>
-          <a:prstGeom prst="rect">
-            <a:avLst/>
-          </a:prstGeom>
-          <a:noFill/>
-          <a:ln/>
-        </p:spPr>
-        <p:txBody>
-          <a:bodyPr wrap="square" rtlCol="0" anchor="ctr"/>
-          <a:lstStyle/>
-          <a:p>
-            <a:pPr indent="0" marL="0">
-              <a:buNone/>
-            </a:pPr>
-            <a:r>
-              <a:rPr lang="en-US" sz="1000" dirty="0">
-                <a:solidFill>
-                  <a:srgbClr val="888888"/>
-                </a:solidFill>
-              </a:rPr>
-              <a:t>年运营成本 ¥4,320 - ¥10,320  ·  AI API + 服务器 + 域名</a:t>
-            </a:r>
-            <a:endParaRPr lang="en-US" sz="1000" dirty="0"/>
           </a:p>
         </p:txBody>
       </p:sp>
@@ -3186,7 +3272,7 @@
                 <a:ea typeface="Microsoft YaHei" pitchFamily="34" charset="-122"/>
                 <a:cs typeface="Microsoft YaHei" pitchFamily="34" charset="-120"/>
               </a:rPr>
-              <a:t>风险与应对</a:t>
+              <a:t>财务预测（第一年）</a:t>
             </a:r>
             <a:endParaRPr lang="en-US" sz="1200" dirty="0"/>
           </a:p>
@@ -3200,39 +3286,14 @@
         </p:nvSpPr>
         <p:spPr>
           <a:xfrm>
-            <a:off x="1097280" y="2011680"/>
-            <a:ext cx="2468880" cy="1554480"/>
+            <a:off x="1097280" y="1828800"/>
+            <a:ext cx="2468880" cy="2560320"/>
           </a:xfrm>
           <a:prstGeom prst="rect">
             <a:avLst/>
           </a:prstGeom>
           <a:solidFill>
             <a:srgbClr val="FFFFFF"/>
-          </a:solidFill>
-          <a:ln w="19050">
-            <a:solidFill>
-              <a:srgbClr val="1A56DB"/>
-            </a:solidFill>
-            <a:prstDash val="solid"/>
-          </a:ln>
-        </p:spPr>
-      </p:sp>
-      <p:sp>
-        <p:nvSpPr>
-          <p:cNvPr id="4" name="Shape 2"/>
-          <p:cNvSpPr/>
-          <p:nvPr/>
-        </p:nvSpPr>
-        <p:spPr>
-          <a:xfrm>
-            <a:off x="1097280" y="2011680"/>
-            <a:ext cx="54864" cy="1554480"/>
-          </a:xfrm>
-          <a:prstGeom prst="rect">
-            <a:avLst/>
-          </a:prstGeom>
-          <a:solidFill>
-            <a:srgbClr val="1A56DB"/>
           </a:solidFill>
           <a:ln w="12700">
             <a:solidFill>
@@ -3244,40 +3305,76 @@
       </p:sp>
       <p:sp>
         <p:nvSpPr>
+          <p:cNvPr id="4" name="Text 2"/>
+          <p:cNvSpPr/>
+          <p:nvPr/>
+        </p:nvSpPr>
+        <p:spPr>
+          <a:xfrm>
+            <a:off x="1097280" y="2011680"/>
+            <a:ext cx="2468880" cy="914400"/>
+          </a:xfrm>
+          <a:prstGeom prst="rect">
+            <a:avLst/>
+          </a:prstGeom>
+          <a:noFill/>
+          <a:ln/>
+        </p:spPr>
+        <p:txBody>
+          <a:bodyPr wrap="square" rtlCol="0" anchor="ctr"/>
+          <a:lstStyle/>
+          <a:p>
+            <a:pPr algn="ctr" indent="0" marL="0">
+              <a:buNone/>
+            </a:pPr>
+            <a:r>
+              <a:rPr lang="en-US" sz="3800" dirty="0">
+                <a:solidFill>
+                  <a:srgbClr val="0A0A0A"/>
+                </a:solidFill>
+                <a:latin typeface="Microsoft YaHei Light" pitchFamily="34" charset="0"/>
+                <a:ea typeface="Microsoft YaHei Light" pitchFamily="34" charset="-122"/>
+                <a:cs typeface="Microsoft YaHei Light" pitchFamily="34" charset="-120"/>
+              </a:rPr>
+              <a:t>¥1.5 万</a:t>
+            </a:r>
+            <a:endParaRPr lang="en-US" sz="3800" dirty="0"/>
+          </a:p>
+        </p:txBody>
+      </p:sp>
+      <p:sp>
+        <p:nvSpPr>
           <p:cNvPr id="5" name="Text 3"/>
           <p:cNvSpPr/>
           <p:nvPr/>
         </p:nvSpPr>
         <p:spPr>
           <a:xfrm>
-            <a:off x="1371600" y="2148840"/>
-            <a:ext cx="2103120" cy="365760"/>
-          </a:xfrm>
-          <a:prstGeom prst="rect">
-            <a:avLst/>
-          </a:prstGeom>
-          <a:noFill/>
-          <a:ln/>
-        </p:spPr>
-        <p:txBody>
-          <a:bodyPr wrap="square" rtlCol="0" anchor="ctr"/>
-          <a:lstStyle/>
-          <a:p>
-            <a:pPr indent="0" marL="0">
-              <a:buNone/>
-            </a:pPr>
-            <a:r>
-              <a:rPr lang="en-US" sz="1400" dirty="0">
+            <a:off x="1097280" y="3017520"/>
+            <a:ext cx="2468880" cy="457200"/>
+          </a:xfrm>
+          <a:prstGeom prst="rect">
+            <a:avLst/>
+          </a:prstGeom>
+          <a:noFill/>
+          <a:ln/>
+        </p:spPr>
+        <p:txBody>
+          <a:bodyPr wrap="square" rtlCol="0" anchor="ctr"/>
+          <a:lstStyle/>
+          <a:p>
+            <a:pPr algn="ctr" indent="0" marL="0">
+              <a:buNone/>
+            </a:pPr>
+            <a:r>
+              <a:rPr lang="en-US" sz="1600" dirty="0">
                 <a:solidFill>
                   <a:srgbClr val="0A0A0A"/>
                 </a:solidFill>
-                <a:latin typeface="Microsoft YaHei" pitchFamily="34" charset="0"/>
-                <a:ea typeface="Microsoft YaHei" pitchFamily="34" charset="-122"/>
-                <a:cs typeface="Microsoft YaHei" pitchFamily="34" charset="-120"/>
-              </a:rPr>
-              <a:t>AI 准确率不足</a:t>
-            </a:r>
-            <a:endParaRPr lang="en-US" sz="1400" dirty="0"/>
+              </a:rPr>
+              <a:t>保守</a:t>
+            </a:r>
+            <a:endParaRPr lang="en-US" sz="1600" dirty="0"/>
           </a:p>
         </p:txBody>
       </p:sp>
@@ -3289,20 +3386,20 @@
         </p:nvSpPr>
         <p:spPr>
           <a:xfrm>
-            <a:off x="1371600" y="2514600"/>
-            <a:ext cx="2103120" cy="914400"/>
-          </a:xfrm>
-          <a:prstGeom prst="rect">
-            <a:avLst/>
-          </a:prstGeom>
-          <a:noFill/>
-          <a:ln/>
-        </p:spPr>
-        <p:txBody>
-          <a:bodyPr wrap="square" rtlCol="0" anchor="ctr"/>
-          <a:lstStyle/>
-          <a:p>
-            <a:pPr indent="0" marL="0">
+            <a:off x="1097280" y="3474720"/>
+            <a:ext cx="2468880" cy="457200"/>
+          </a:xfrm>
+          <a:prstGeom prst="rect">
+            <a:avLst/>
+          </a:prstGeom>
+          <a:noFill/>
+          <a:ln/>
+        </p:spPr>
+        <p:txBody>
+          <a:bodyPr wrap="square" rtlCol="0" anchor="ctr"/>
+          <a:lstStyle/>
+          <a:p>
+            <a:pPr algn="ctr" indent="0" marL="0">
               <a:buNone/>
             </a:pPr>
             <a:r>
@@ -3311,24 +3408,10 @@
                   <a:srgbClr val="888888"/>
                 </a:solidFill>
               </a:rPr>
-              <a:t>支持手动修正</a:t>
+              <a:t>3000 人  ·  3% 付费</a:t>
             </a:r>
             <a:endParaRPr lang="en-US" sz="1100" dirty="0"/>
           </a:p>
-          <a:p>
-            <a:pPr indent="0" marL="0">
-              <a:buNone/>
-            </a:pPr>
-            <a:r>
-              <a:rPr lang="en-US" sz="1100" dirty="0">
-                <a:solidFill>
-                  <a:srgbClr val="888888"/>
-                </a:solidFill>
-              </a:rPr>
-              <a:t>持续优化 prompt</a:t>
-            </a:r>
-            <a:endParaRPr lang="en-US" sz="1100" dirty="0"/>
-          </a:p>
         </p:txBody>
       </p:sp>
       <p:sp>
@@ -3339,39 +3422,14 @@
         </p:nvSpPr>
         <p:spPr>
           <a:xfrm>
-            <a:off x="3840480" y="2011680"/>
-            <a:ext cx="2468880" cy="1554480"/>
+            <a:off x="3840480" y="1828800"/>
+            <a:ext cx="2468880" cy="2560320"/>
           </a:xfrm>
           <a:prstGeom prst="rect">
             <a:avLst/>
           </a:prstGeom>
           <a:solidFill>
             <a:srgbClr val="FFFFFF"/>
-          </a:solidFill>
-          <a:ln w="19050">
-            <a:solidFill>
-              <a:srgbClr val="1A56DB"/>
-            </a:solidFill>
-            <a:prstDash val="solid"/>
-          </a:ln>
-        </p:spPr>
-      </p:sp>
-      <p:sp>
-        <p:nvSpPr>
-          <p:cNvPr id="8" name="Shape 6"/>
-          <p:cNvSpPr/>
-          <p:nvPr/>
-        </p:nvSpPr>
-        <p:spPr>
-          <a:xfrm>
-            <a:off x="3840480" y="2011680"/>
-            <a:ext cx="54864" cy="1554480"/>
-          </a:xfrm>
-          <a:prstGeom prst="rect">
-            <a:avLst/>
-          </a:prstGeom>
-          <a:solidFill>
-            <a:srgbClr val="1A56DB"/>
           </a:solidFill>
           <a:ln w="12700">
             <a:solidFill>
@@ -3383,40 +3441,76 @@
       </p:sp>
       <p:sp>
         <p:nvSpPr>
+          <p:cNvPr id="8" name="Text 6"/>
+          <p:cNvSpPr/>
+          <p:nvPr/>
+        </p:nvSpPr>
+        <p:spPr>
+          <a:xfrm>
+            <a:off x="3840480" y="2011680"/>
+            <a:ext cx="2468880" cy="914400"/>
+          </a:xfrm>
+          <a:prstGeom prst="rect">
+            <a:avLst/>
+          </a:prstGeom>
+          <a:noFill/>
+          <a:ln/>
+        </p:spPr>
+        <p:txBody>
+          <a:bodyPr wrap="square" rtlCol="0" anchor="ctr"/>
+          <a:lstStyle/>
+          <a:p>
+            <a:pPr algn="ctr" indent="0" marL="0">
+              <a:buNone/>
+            </a:pPr>
+            <a:r>
+              <a:rPr lang="en-US" sz="3800" dirty="0">
+                <a:solidFill>
+                  <a:srgbClr val="0A0A0A"/>
+                </a:solidFill>
+                <a:latin typeface="Microsoft YaHei Light" pitchFamily="34" charset="0"/>
+                <a:ea typeface="Microsoft YaHei Light" pitchFamily="34" charset="-122"/>
+                <a:cs typeface="Microsoft YaHei Light" pitchFamily="34" charset="-120"/>
+              </a:rPr>
+              <a:t>¥8.4 万</a:t>
+            </a:r>
+            <a:endParaRPr lang="en-US" sz="3800" dirty="0"/>
+          </a:p>
+        </p:txBody>
+      </p:sp>
+      <p:sp>
+        <p:nvSpPr>
           <p:cNvPr id="9" name="Text 7"/>
           <p:cNvSpPr/>
           <p:nvPr/>
         </p:nvSpPr>
         <p:spPr>
           <a:xfrm>
-            <a:off x="4114800" y="2148840"/>
-            <a:ext cx="2103120" cy="365760"/>
-          </a:xfrm>
-          <a:prstGeom prst="rect">
-            <a:avLst/>
-          </a:prstGeom>
-          <a:noFill/>
-          <a:ln/>
-        </p:spPr>
-        <p:txBody>
-          <a:bodyPr wrap="square" rtlCol="0" anchor="ctr"/>
-          <a:lstStyle/>
-          <a:p>
-            <a:pPr indent="0" marL="0">
-              <a:buNone/>
-            </a:pPr>
-            <a:r>
-              <a:rPr lang="en-US" sz="1400" dirty="0">
+            <a:off x="3840480" y="3017520"/>
+            <a:ext cx="2468880" cy="457200"/>
+          </a:xfrm>
+          <a:prstGeom prst="rect">
+            <a:avLst/>
+          </a:prstGeom>
+          <a:noFill/>
+          <a:ln/>
+        </p:spPr>
+        <p:txBody>
+          <a:bodyPr wrap="square" rtlCol="0" anchor="ctr"/>
+          <a:lstStyle/>
+          <a:p>
+            <a:pPr algn="ctr" indent="0" marL="0">
+              <a:buNone/>
+            </a:pPr>
+            <a:r>
+              <a:rPr lang="en-US" sz="1600" dirty="0">
                 <a:solidFill>
                   <a:srgbClr val="0A0A0A"/>
                 </a:solidFill>
-                <a:latin typeface="Microsoft YaHei" pitchFamily="34" charset="0"/>
-                <a:ea typeface="Microsoft YaHei" pitchFamily="34" charset="-122"/>
-                <a:cs typeface="Microsoft YaHei" pitchFamily="34" charset="-120"/>
-              </a:rPr>
-              <a:t>用户留存低</a:t>
-            </a:r>
-            <a:endParaRPr lang="en-US" sz="1400" dirty="0"/>
+              </a:rPr>
+              <a:t>中等</a:t>
+            </a:r>
+            <a:endParaRPr lang="en-US" sz="1600" dirty="0"/>
           </a:p>
         </p:txBody>
       </p:sp>
@@ -3428,20 +3522,20 @@
         </p:nvSpPr>
         <p:spPr>
           <a:xfrm>
-            <a:off x="4114800" y="2514600"/>
-            <a:ext cx="2103120" cy="914400"/>
-          </a:xfrm>
-          <a:prstGeom prst="rect">
-            <a:avLst/>
-          </a:prstGeom>
-          <a:noFill/>
-          <a:ln/>
-        </p:spPr>
-        <p:txBody>
-          <a:bodyPr wrap="square" rtlCol="0" anchor="ctr"/>
-          <a:lstStyle/>
-          <a:p>
-            <a:pPr indent="0" marL="0">
+            <a:off x="3840480" y="3474720"/>
+            <a:ext cx="2468880" cy="457200"/>
+          </a:xfrm>
+          <a:prstGeom prst="rect">
+            <a:avLst/>
+          </a:prstGeom>
+          <a:noFill/>
+          <a:ln/>
+        </p:spPr>
+        <p:txBody>
+          <a:bodyPr wrap="square" rtlCol="0" anchor="ctr"/>
+          <a:lstStyle/>
+          <a:p>
+            <a:pPr algn="ctr" indent="0" marL="0">
               <a:buNone/>
             </a:pPr>
             <a:r>
@@ -3450,24 +3544,10 @@
                   <a:srgbClr val="888888"/>
                 </a:solidFill>
               </a:rPr>
-              <a:t>体检→分析闭环</a:t>
+              <a:t>1 万人  ·  5% 付费</a:t>
             </a:r>
             <a:endParaRPr lang="en-US" sz="1100" dirty="0"/>
           </a:p>
-          <a:p>
-            <a:pPr indent="0" marL="0">
-              <a:buNone/>
-            </a:pPr>
-            <a:r>
-              <a:rPr lang="en-US" sz="1100" dirty="0">
-                <a:solidFill>
-                  <a:srgbClr val="888888"/>
-                </a:solidFill>
-              </a:rPr>
-              <a:t>饮食打卡 + 成就系统</a:t>
-            </a:r>
-            <a:endParaRPr lang="en-US" sz="1100" dirty="0"/>
-          </a:p>
         </p:txBody>
       </p:sp>
       <p:sp>
@@ -3478,39 +3558,14 @@
         </p:nvSpPr>
         <p:spPr>
           <a:xfrm>
-            <a:off x="6583680" y="2011680"/>
-            <a:ext cx="2468880" cy="1554480"/>
+            <a:off x="6583680" y="1828800"/>
+            <a:ext cx="2468880" cy="2560320"/>
           </a:xfrm>
           <a:prstGeom prst="rect">
             <a:avLst/>
           </a:prstGeom>
           <a:solidFill>
             <a:srgbClr val="FFFFFF"/>
-          </a:solidFill>
-          <a:ln w="19050">
-            <a:solidFill>
-              <a:srgbClr val="1A56DB"/>
-            </a:solidFill>
-            <a:prstDash val="solid"/>
-          </a:ln>
-        </p:spPr>
-      </p:sp>
-      <p:sp>
-        <p:nvSpPr>
-          <p:cNvPr id="12" name="Shape 10"/>
-          <p:cNvSpPr/>
-          <p:nvPr/>
-        </p:nvSpPr>
-        <p:spPr>
-          <a:xfrm>
-            <a:off x="6583680" y="2011680"/>
-            <a:ext cx="54864" cy="1554480"/>
-          </a:xfrm>
-          <a:prstGeom prst="rect">
-            <a:avLst/>
-          </a:prstGeom>
-          <a:solidFill>
-            <a:srgbClr val="1A56DB"/>
           </a:solidFill>
           <a:ln w="12700">
             <a:solidFill>
@@ -3522,40 +3577,76 @@
       </p:sp>
       <p:sp>
         <p:nvSpPr>
+          <p:cNvPr id="12" name="Text 10"/>
+          <p:cNvSpPr/>
+          <p:nvPr/>
+        </p:nvSpPr>
+        <p:spPr>
+          <a:xfrm>
+            <a:off x="6583680" y="2011680"/>
+            <a:ext cx="2468880" cy="914400"/>
+          </a:xfrm>
+          <a:prstGeom prst="rect">
+            <a:avLst/>
+          </a:prstGeom>
+          <a:noFill/>
+          <a:ln/>
+        </p:spPr>
+        <p:txBody>
+          <a:bodyPr wrap="square" rtlCol="0" anchor="ctr"/>
+          <a:lstStyle/>
+          <a:p>
+            <a:pPr algn="ctr" indent="0" marL="0">
+              <a:buNone/>
+            </a:pPr>
+            <a:r>
+              <a:rPr lang="en-US" sz="3800" dirty="0">
+                <a:solidFill>
+                  <a:srgbClr val="0A0A0A"/>
+                </a:solidFill>
+                <a:latin typeface="Microsoft YaHei Light" pitchFamily="34" charset="0"/>
+                <a:ea typeface="Microsoft YaHei Light" pitchFamily="34" charset="-122"/>
+                <a:cs typeface="Microsoft YaHei Light" pitchFamily="34" charset="-120"/>
+              </a:rPr>
+              <a:t>¥67 万</a:t>
+            </a:r>
+            <a:endParaRPr lang="en-US" sz="3800" dirty="0"/>
+          </a:p>
+        </p:txBody>
+      </p:sp>
+      <p:sp>
+        <p:nvSpPr>
           <p:cNvPr id="13" name="Text 11"/>
           <p:cNvSpPr/>
           <p:nvPr/>
         </p:nvSpPr>
         <p:spPr>
           <a:xfrm>
-            <a:off x="6858000" y="2148840"/>
-            <a:ext cx="2103120" cy="365760"/>
-          </a:xfrm>
-          <a:prstGeom prst="rect">
-            <a:avLst/>
-          </a:prstGeom>
-          <a:noFill/>
-          <a:ln/>
-        </p:spPr>
-        <p:txBody>
-          <a:bodyPr wrap="square" rtlCol="0" anchor="ctr"/>
-          <a:lstStyle/>
-          <a:p>
-            <a:pPr indent="0" marL="0">
-              <a:buNone/>
-            </a:pPr>
-            <a:r>
-              <a:rPr lang="en-US" sz="1400" dirty="0">
+            <a:off x="6583680" y="3017520"/>
+            <a:ext cx="2468880" cy="457200"/>
+          </a:xfrm>
+          <a:prstGeom prst="rect">
+            <a:avLst/>
+          </a:prstGeom>
+          <a:noFill/>
+          <a:ln/>
+        </p:spPr>
+        <p:txBody>
+          <a:bodyPr wrap="square" rtlCol="0" anchor="ctr"/>
+          <a:lstStyle/>
+          <a:p>
+            <a:pPr algn="ctr" indent="0" marL="0">
+              <a:buNone/>
+            </a:pPr>
+            <a:r>
+              <a:rPr lang="en-US" sz="1600" dirty="0">
                 <a:solidFill>
                   <a:srgbClr val="0A0A0A"/>
                 </a:solidFill>
-                <a:latin typeface="Microsoft YaHei" pitchFamily="34" charset="0"/>
-                <a:ea typeface="Microsoft YaHei" pitchFamily="34" charset="-122"/>
-                <a:cs typeface="Microsoft YaHei" pitchFamily="34" charset="-120"/>
-              </a:rPr>
-              <a:t>竞品跟进</a:t>
-            </a:r>
-            <a:endParaRPr lang="en-US" sz="1400" dirty="0"/>
+              </a:rPr>
+              <a:t>乐观</a:t>
+            </a:r>
+            <a:endParaRPr lang="en-US" sz="1600" dirty="0"/>
           </a:p>
         </p:txBody>
       </p:sp>
@@ -3567,20 +3658,20 @@
         </p:nvSpPr>
         <p:spPr>
           <a:xfrm>
-            <a:off x="6858000" y="2514600"/>
-            <a:ext cx="2103120" cy="914400"/>
-          </a:xfrm>
-          <a:prstGeom prst="rect">
-            <a:avLst/>
-          </a:prstGeom>
-          <a:noFill/>
-          <a:ln/>
-        </p:spPr>
-        <p:txBody>
-          <a:bodyPr wrap="square" rtlCol="0" anchor="ctr"/>
-          <a:lstStyle/>
-          <a:p>
-            <a:pPr indent="0" marL="0">
+            <a:off x="6583680" y="3474720"/>
+            <a:ext cx="2468880" cy="457200"/>
+          </a:xfrm>
+          <a:prstGeom prst="rect">
+            <a:avLst/>
+          </a:prstGeom>
+          <a:noFill/>
+          <a:ln/>
+        </p:spPr>
+        <p:txBody>
+          <a:bodyPr wrap="square" rtlCol="0" anchor="ctr"/>
+          <a:lstStyle/>
+          <a:p>
+            <a:pPr algn="ctr" indent="0" marL="0">
               <a:buNone/>
             </a:pPr>
             <a:r>
@@ -3589,440 +3680,45 @@
                   <a:srgbClr val="888888"/>
                 </a:solidFill>
               </a:rPr>
-              <a:t>聚焦全流程 AI</a:t>
+              <a:t>5 万人  ·  8% 付费</a:t>
             </a:r>
             <a:endParaRPr lang="en-US" sz="1100" dirty="0"/>
           </a:p>
-          <a:p>
-            <a:pPr indent="0" marL="0">
-              <a:buNone/>
-            </a:pPr>
-            <a:r>
-              <a:rPr lang="en-US" sz="1100" dirty="0">
+        </p:txBody>
+      </p:sp>
+      <p:sp>
+        <p:nvSpPr>
+          <p:cNvPr id="15" name="Text 13"/>
+          <p:cNvSpPr/>
+          <p:nvPr/>
+        </p:nvSpPr>
+        <p:spPr>
+          <a:xfrm>
+            <a:off x="1097280" y="5029200"/>
+            <a:ext cx="9144000" cy="0"/>
+          </a:xfrm>
+          <a:prstGeom prst="rect">
+            <a:avLst/>
+          </a:prstGeom>
+          <a:noFill/>
+          <a:ln/>
+        </p:spPr>
+        <p:txBody>
+          <a:bodyPr wrap="square" rtlCol="0" anchor="ctr"/>
+          <a:lstStyle/>
+          <a:p>
+            <a:pPr indent="0" marL="0">
+              <a:buNone/>
+            </a:pPr>
+            <a:r>
+              <a:rPr lang="en-US" sz="1000" dirty="0">
                 <a:solidFill>
                   <a:srgbClr val="888888"/>
                 </a:solidFill>
               </a:rPr>
-              <a:t>+ 体检联动差异化</a:t>
-            </a:r>
-            <a:endParaRPr lang="en-US" sz="1100" dirty="0"/>
-          </a:p>
-        </p:txBody>
-      </p:sp>
-      <p:sp>
-        <p:nvSpPr>
-          <p:cNvPr id="15" name="Shape 13"/>
-          <p:cNvSpPr/>
-          <p:nvPr/>
-        </p:nvSpPr>
-        <p:spPr>
-          <a:xfrm>
-            <a:off x="1097280" y="3840480"/>
-            <a:ext cx="2468880" cy="1554480"/>
-          </a:xfrm>
-          <a:prstGeom prst="rect">
-            <a:avLst/>
-          </a:prstGeom>
-          <a:solidFill>
-            <a:srgbClr val="FFFFFF"/>
-          </a:solidFill>
-          <a:ln w="19050">
-            <a:solidFill>
-              <a:srgbClr val="1A56DB"/>
-            </a:solidFill>
-            <a:prstDash val="solid"/>
-          </a:ln>
-        </p:spPr>
-      </p:sp>
-      <p:sp>
-        <p:nvSpPr>
-          <p:cNvPr id="16" name="Shape 14"/>
-          <p:cNvSpPr/>
-          <p:nvPr/>
-        </p:nvSpPr>
-        <p:spPr>
-          <a:xfrm>
-            <a:off x="1097280" y="3840480"/>
-            <a:ext cx="54864" cy="1554480"/>
-          </a:xfrm>
-          <a:prstGeom prst="rect">
-            <a:avLst/>
-          </a:prstGeom>
-          <a:solidFill>
-            <a:srgbClr val="1A56DB"/>
-          </a:solidFill>
-          <a:ln w="12700">
-            <a:solidFill>
-              <a:srgbClr val="1A56DB"/>
-            </a:solidFill>
-            <a:prstDash val="solid"/>
-          </a:ln>
-        </p:spPr>
-      </p:sp>
-      <p:sp>
-        <p:nvSpPr>
-          <p:cNvPr id="17" name="Text 15"/>
-          <p:cNvSpPr/>
-          <p:nvPr/>
-        </p:nvSpPr>
-        <p:spPr>
-          <a:xfrm>
-            <a:off x="1371600" y="3977640"/>
-            <a:ext cx="2103120" cy="365760"/>
-          </a:xfrm>
-          <a:prstGeom prst="rect">
-            <a:avLst/>
-          </a:prstGeom>
-          <a:noFill/>
-          <a:ln/>
-        </p:spPr>
-        <p:txBody>
-          <a:bodyPr wrap="square" rtlCol="0" anchor="ctr"/>
-          <a:lstStyle/>
-          <a:p>
-            <a:pPr indent="0" marL="0">
-              <a:buNone/>
-            </a:pPr>
-            <a:r>
-              <a:rPr lang="en-US" sz="1400" dirty="0">
-                <a:solidFill>
-                  <a:srgbClr val="0A0A0A"/>
-                </a:solidFill>
-                <a:latin typeface="Microsoft YaHei" pitchFamily="34" charset="0"/>
-                <a:ea typeface="Microsoft YaHei" pitchFamily="34" charset="-122"/>
-                <a:cs typeface="Microsoft YaHei" pitchFamily="34" charset="-120"/>
-              </a:rPr>
-              <a:t>健康建议合规</a:t>
-            </a:r>
-            <a:endParaRPr lang="en-US" sz="1400" dirty="0"/>
-          </a:p>
-        </p:txBody>
-      </p:sp>
-      <p:sp>
-        <p:nvSpPr>
-          <p:cNvPr id="18" name="Text 16"/>
-          <p:cNvSpPr/>
-          <p:nvPr/>
-        </p:nvSpPr>
-        <p:spPr>
-          <a:xfrm>
-            <a:off x="1371600" y="4343400"/>
-            <a:ext cx="2103120" cy="914400"/>
-          </a:xfrm>
-          <a:prstGeom prst="rect">
-            <a:avLst/>
-          </a:prstGeom>
-          <a:noFill/>
-          <a:ln/>
-        </p:spPr>
-        <p:txBody>
-          <a:bodyPr wrap="square" rtlCol="0" anchor="ctr"/>
-          <a:lstStyle/>
-          <a:p>
-            <a:pPr indent="0" marL="0">
-              <a:buNone/>
-            </a:pPr>
-            <a:r>
-              <a:rPr lang="en-US" sz="1100" dirty="0">
-                <a:solidFill>
-                  <a:srgbClr val="888888"/>
-                </a:solidFill>
-              </a:rPr>
-              <a:t>免责声明</a:t>
-            </a:r>
-            <a:endParaRPr lang="en-US" sz="1100" dirty="0"/>
-          </a:p>
-          <a:p>
-            <a:pPr indent="0" marL="0">
-              <a:buNone/>
-            </a:pPr>
-            <a:r>
-              <a:rPr lang="en-US" sz="1100" dirty="0">
-                <a:solidFill>
-                  <a:srgbClr val="888888"/>
-                </a:solidFill>
-              </a:rPr>
-              <a:t>医学顾问审核</a:t>
-            </a:r>
-            <a:endParaRPr lang="en-US" sz="1100" dirty="0"/>
-          </a:p>
-        </p:txBody>
-      </p:sp>
-      <p:sp>
-        <p:nvSpPr>
-          <p:cNvPr id="19" name="Shape 17"/>
-          <p:cNvSpPr/>
-          <p:nvPr/>
-        </p:nvSpPr>
-        <p:spPr>
-          <a:xfrm>
-            <a:off x="3840480" y="3840480"/>
-            <a:ext cx="2468880" cy="1554480"/>
-          </a:xfrm>
-          <a:prstGeom prst="rect">
-            <a:avLst/>
-          </a:prstGeom>
-          <a:solidFill>
-            <a:srgbClr val="FFFFFF"/>
-          </a:solidFill>
-          <a:ln w="19050">
-            <a:solidFill>
-              <a:srgbClr val="1A56DB"/>
-            </a:solidFill>
-            <a:prstDash val="solid"/>
-          </a:ln>
-        </p:spPr>
-      </p:sp>
-      <p:sp>
-        <p:nvSpPr>
-          <p:cNvPr id="20" name="Shape 18"/>
-          <p:cNvSpPr/>
-          <p:nvPr/>
-        </p:nvSpPr>
-        <p:spPr>
-          <a:xfrm>
-            <a:off x="3840480" y="3840480"/>
-            <a:ext cx="54864" cy="1554480"/>
-          </a:xfrm>
-          <a:prstGeom prst="rect">
-            <a:avLst/>
-          </a:prstGeom>
-          <a:solidFill>
-            <a:srgbClr val="1A56DB"/>
-          </a:solidFill>
-          <a:ln w="12700">
-            <a:solidFill>
-              <a:srgbClr val="1A56DB"/>
-            </a:solidFill>
-            <a:prstDash val="solid"/>
-          </a:ln>
-        </p:spPr>
-      </p:sp>
-      <p:sp>
-        <p:nvSpPr>
-          <p:cNvPr id="21" name="Text 19"/>
-          <p:cNvSpPr/>
-          <p:nvPr/>
-        </p:nvSpPr>
-        <p:spPr>
-          <a:xfrm>
-            <a:off x="4114800" y="3977640"/>
-            <a:ext cx="2103120" cy="365760"/>
-          </a:xfrm>
-          <a:prstGeom prst="rect">
-            <a:avLst/>
-          </a:prstGeom>
-          <a:noFill/>
-          <a:ln/>
-        </p:spPr>
-        <p:txBody>
-          <a:bodyPr wrap="square" rtlCol="0" anchor="ctr"/>
-          <a:lstStyle/>
-          <a:p>
-            <a:pPr indent="0" marL="0">
-              <a:buNone/>
-            </a:pPr>
-            <a:r>
-              <a:rPr lang="en-US" sz="1400" dirty="0">
-                <a:solidFill>
-                  <a:srgbClr val="0A0A0A"/>
-                </a:solidFill>
-                <a:latin typeface="Microsoft YaHei" pitchFamily="34" charset="0"/>
-                <a:ea typeface="Microsoft YaHei" pitchFamily="34" charset="-122"/>
-                <a:cs typeface="Microsoft YaHei" pitchFamily="34" charset="-120"/>
-              </a:rPr>
-              <a:t>盈利不清晰</a:t>
-            </a:r>
-            <a:endParaRPr lang="en-US" sz="1400" dirty="0"/>
-          </a:p>
-        </p:txBody>
-      </p:sp>
-      <p:sp>
-        <p:nvSpPr>
-          <p:cNvPr id="22" name="Text 20"/>
-          <p:cNvSpPr/>
-          <p:nvPr/>
-        </p:nvSpPr>
-        <p:spPr>
-          <a:xfrm>
-            <a:off x="4114800" y="4343400"/>
-            <a:ext cx="2103120" cy="914400"/>
-          </a:xfrm>
-          <a:prstGeom prst="rect">
-            <a:avLst/>
-          </a:prstGeom>
-          <a:noFill/>
-          <a:ln/>
-        </p:spPr>
-        <p:txBody>
-          <a:bodyPr wrap="square" rtlCol="0" anchor="ctr"/>
-          <a:lstStyle/>
-          <a:p>
-            <a:pPr indent="0" marL="0">
-              <a:buNone/>
-            </a:pPr>
-            <a:r>
-              <a:rPr lang="en-US" sz="1100" dirty="0">
-                <a:solidFill>
-                  <a:srgbClr val="888888"/>
-                </a:solidFill>
-              </a:rPr>
-              <a:t>先免费验证 PMF</a:t>
-            </a:r>
-            <a:endParaRPr lang="en-US" sz="1100" dirty="0"/>
-          </a:p>
-          <a:p>
-            <a:pPr indent="0" marL="0">
-              <a:buNone/>
-            </a:pPr>
-            <a:r>
-              <a:rPr lang="en-US" sz="1100" dirty="0">
-                <a:solidFill>
-                  <a:srgbClr val="888888"/>
-                </a:solidFill>
-              </a:rPr>
-              <a:t>1 万 MAU 再订阅</a:t>
-            </a:r>
-            <a:endParaRPr lang="en-US" sz="1100" dirty="0"/>
-          </a:p>
-        </p:txBody>
-      </p:sp>
-      <p:sp>
-        <p:nvSpPr>
-          <p:cNvPr id="23" name="Shape 21"/>
-          <p:cNvSpPr/>
-          <p:nvPr/>
-        </p:nvSpPr>
-        <p:spPr>
-          <a:xfrm>
-            <a:off x="6583680" y="3840480"/>
-            <a:ext cx="2468880" cy="1554480"/>
-          </a:xfrm>
-          <a:prstGeom prst="rect">
-            <a:avLst/>
-          </a:prstGeom>
-          <a:solidFill>
-            <a:srgbClr val="FFFFFF"/>
-          </a:solidFill>
-          <a:ln w="19050">
-            <a:solidFill>
-              <a:srgbClr val="1A56DB"/>
-            </a:solidFill>
-            <a:prstDash val="solid"/>
-          </a:ln>
-        </p:spPr>
-      </p:sp>
-      <p:sp>
-        <p:nvSpPr>
-          <p:cNvPr id="24" name="Shape 22"/>
-          <p:cNvSpPr/>
-          <p:nvPr/>
-        </p:nvSpPr>
-        <p:spPr>
-          <a:xfrm>
-            <a:off x="6583680" y="3840480"/>
-            <a:ext cx="54864" cy="1554480"/>
-          </a:xfrm>
-          <a:prstGeom prst="rect">
-            <a:avLst/>
-          </a:prstGeom>
-          <a:solidFill>
-            <a:srgbClr val="1A56DB"/>
-          </a:solidFill>
-          <a:ln w="12700">
-            <a:solidFill>
-              <a:srgbClr val="1A56DB"/>
-            </a:solidFill>
-            <a:prstDash val="solid"/>
-          </a:ln>
-        </p:spPr>
-      </p:sp>
-      <p:sp>
-        <p:nvSpPr>
-          <p:cNvPr id="25" name="Text 23"/>
-          <p:cNvSpPr/>
-          <p:nvPr/>
-        </p:nvSpPr>
-        <p:spPr>
-          <a:xfrm>
-            <a:off x="6858000" y="3977640"/>
-            <a:ext cx="2103120" cy="365760"/>
-          </a:xfrm>
-          <a:prstGeom prst="rect">
-            <a:avLst/>
-          </a:prstGeom>
-          <a:noFill/>
-          <a:ln/>
-        </p:spPr>
-        <p:txBody>
-          <a:bodyPr wrap="square" rtlCol="0" anchor="ctr"/>
-          <a:lstStyle/>
-          <a:p>
-            <a:pPr indent="0" marL="0">
-              <a:buNone/>
-            </a:pPr>
-            <a:r>
-              <a:rPr lang="en-US" sz="1400" dirty="0">
-                <a:solidFill>
-                  <a:srgbClr val="0A0A0A"/>
-                </a:solidFill>
-                <a:latin typeface="Microsoft YaHei" pitchFamily="34" charset="0"/>
-                <a:ea typeface="Microsoft YaHei" pitchFamily="34" charset="-122"/>
-                <a:cs typeface="Microsoft YaHei" pitchFamily="34" charset="-120"/>
-              </a:rPr>
-              <a:t>数据隐私</a:t>
-            </a:r>
-            <a:endParaRPr lang="en-US" sz="1400" dirty="0"/>
-          </a:p>
-        </p:txBody>
-      </p:sp>
-      <p:sp>
-        <p:nvSpPr>
-          <p:cNvPr id="26" name="Text 24"/>
-          <p:cNvSpPr/>
-          <p:nvPr/>
-        </p:nvSpPr>
-        <p:spPr>
-          <a:xfrm>
-            <a:off x="6858000" y="4343400"/>
-            <a:ext cx="2103120" cy="914400"/>
-          </a:xfrm>
-          <a:prstGeom prst="rect">
-            <a:avLst/>
-          </a:prstGeom>
-          <a:noFill/>
-          <a:ln/>
-        </p:spPr>
-        <p:txBody>
-          <a:bodyPr wrap="square" rtlCol="0" anchor="ctr"/>
-          <a:lstStyle/>
-          <a:p>
-            <a:pPr indent="0" marL="0">
-              <a:buNone/>
-            </a:pPr>
-            <a:r>
-              <a:rPr lang="en-US" sz="1100" dirty="0">
-                <a:solidFill>
-                  <a:srgbClr val="888888"/>
-                </a:solidFill>
-              </a:rPr>
-              <a:t>行业标准加密</a:t>
-            </a:r>
-            <a:endParaRPr lang="en-US" sz="1100" dirty="0"/>
-          </a:p>
-          <a:p>
-            <a:pPr indent="0" marL="0">
-              <a:buNone/>
-            </a:pPr>
-            <a:r>
-              <a:rPr lang="en-US" sz="1100" dirty="0">
-                <a:solidFill>
-                  <a:srgbClr val="888888"/>
-                </a:solidFill>
-              </a:rPr>
-              <a:t>用户数据不出境</a:t>
-            </a:r>
-            <a:endParaRPr lang="en-US" sz="1100" dirty="0"/>
+              <a:t>年运营成本 ¥2,400 - ¥1.6万  ·  AI API + 服务器 + 域名</a:t>
+            </a:r>
+            <a:endParaRPr lang="en-US" sz="1000" dirty="0"/>
           </a:p>
         </p:txBody>
       </p:sp>
@@ -4091,7 +3787,7 @@
                 <a:ea typeface="Microsoft YaHei" pitchFamily="34" charset="-122"/>
                 <a:cs typeface="Microsoft YaHei" pitchFamily="34" charset="-120"/>
               </a:rPr>
-              <a:t>下一步</a:t>
+              <a:t>风险与应对</a:t>
             </a:r>
             <a:endParaRPr lang="en-US" sz="1200" dirty="0"/>
           </a:p>
@@ -4105,8 +3801,33 @@
         </p:nvSpPr>
         <p:spPr>
           <a:xfrm>
-            <a:off x="1097280" y="1828800"/>
-            <a:ext cx="457200" cy="457200"/>
+            <a:off x="1097280" y="2011680"/>
+            <a:ext cx="2468880" cy="1554480"/>
+          </a:xfrm>
+          <a:prstGeom prst="rect">
+            <a:avLst/>
+          </a:prstGeom>
+          <a:solidFill>
+            <a:srgbClr val="FFFFFF"/>
+          </a:solidFill>
+          <a:ln w="19050">
+            <a:solidFill>
+              <a:srgbClr val="1A56DB"/>
+            </a:solidFill>
+            <a:prstDash val="solid"/>
+          </a:ln>
+        </p:spPr>
+      </p:sp>
+      <p:sp>
+        <p:nvSpPr>
+          <p:cNvPr id="4" name="Shape 2"/>
+          <p:cNvSpPr/>
+          <p:nvPr/>
+        </p:nvSpPr>
+        <p:spPr>
+          <a:xfrm>
+            <a:off x="1097280" y="2011680"/>
+            <a:ext cx="54864" cy="1554480"/>
           </a:xfrm>
           <a:prstGeom prst="rect">
             <a:avLst/>
@@ -4114,40 +3835,48 @@
           <a:solidFill>
             <a:srgbClr val="1A56DB"/>
           </a:solidFill>
-          <a:ln/>
-        </p:spPr>
-      </p:sp>
-      <p:sp>
-        <p:nvSpPr>
-          <p:cNvPr id="4" name="Text 2"/>
-          <p:cNvSpPr/>
-          <p:nvPr/>
-        </p:nvSpPr>
-        <p:spPr>
-          <a:xfrm>
-            <a:off x="1097280" y="1874520"/>
-            <a:ext cx="457200" cy="457200"/>
-          </a:xfrm>
-          <a:prstGeom prst="rect">
-            <a:avLst/>
-          </a:prstGeom>
-          <a:noFill/>
-          <a:ln/>
-        </p:spPr>
-        <p:txBody>
-          <a:bodyPr wrap="square" rtlCol="0" anchor="ctr"/>
-          <a:lstStyle/>
-          <a:p>
-            <a:pPr algn="ctr" indent="0" marL="0">
+          <a:ln w="12700">
+            <a:solidFill>
+              <a:srgbClr val="1A56DB"/>
+            </a:solidFill>
+            <a:prstDash val="solid"/>
+          </a:ln>
+        </p:spPr>
+      </p:sp>
+      <p:sp>
+        <p:nvSpPr>
+          <p:cNvPr id="5" name="Text 3"/>
+          <p:cNvSpPr/>
+          <p:nvPr/>
+        </p:nvSpPr>
+        <p:spPr>
+          <a:xfrm>
+            <a:off x="1371600" y="2148840"/>
+            <a:ext cx="2103120" cy="365760"/>
+          </a:xfrm>
+          <a:prstGeom prst="rect">
+            <a:avLst/>
+          </a:prstGeom>
+          <a:noFill/>
+          <a:ln/>
+        </p:spPr>
+        <p:txBody>
+          <a:bodyPr wrap="square" rtlCol="0" anchor="ctr"/>
+          <a:lstStyle/>
+          <a:p>
+            <a:pPr indent="0" marL="0">
               <a:buNone/>
             </a:pPr>
             <a:r>
               <a:rPr lang="en-US" sz="1400" dirty="0">
                 <a:solidFill>
-                  <a:srgbClr val="FFFFFF"/>
-                </a:solidFill>
-              </a:rPr>
-              <a:t>1</a:t>
+                  <a:srgbClr val="0A0A0A"/>
+                </a:solidFill>
+                <a:latin typeface="Microsoft YaHei" pitchFamily="34" charset="0"/>
+                <a:ea typeface="Microsoft YaHei" pitchFamily="34" charset="-122"/>
+                <a:cs typeface="Microsoft YaHei" pitchFamily="34" charset="-120"/>
+              </a:rPr>
+              <a:t>AI 准确率不足</a:t>
             </a:r>
             <a:endParaRPr lang="en-US" sz="1400" dirty="0"/>
           </a:p>
@@ -4155,50 +3884,89 @@
       </p:sp>
       <p:sp>
         <p:nvSpPr>
-          <p:cNvPr id="5" name="Text 3"/>
-          <p:cNvSpPr/>
-          <p:nvPr/>
-        </p:nvSpPr>
-        <p:spPr>
-          <a:xfrm>
-            <a:off x="1828800" y="1828800"/>
-            <a:ext cx="9144000" cy="0"/>
-          </a:xfrm>
-          <a:prstGeom prst="rect">
-            <a:avLst/>
-          </a:prstGeom>
-          <a:noFill/>
-          <a:ln/>
-        </p:spPr>
-        <p:txBody>
-          <a:bodyPr wrap="square" rtlCol="0" anchor="ctr"/>
-          <a:lstStyle/>
-          <a:p>
-            <a:pPr indent="0" marL="0">
-              <a:buNone/>
-            </a:pPr>
-            <a:r>
-              <a:rPr lang="en-US" sz="1500" dirty="0">
-                <a:solidFill>
-                  <a:srgbClr val="0A0A0A"/>
-                </a:solidFill>
-              </a:rPr>
-              <a:t>找到 10-20 个真实用户，进行为期 2 周的测试</a:t>
-            </a:r>
-            <a:endParaRPr lang="en-US" sz="1500" dirty="0"/>
-          </a:p>
-        </p:txBody>
-      </p:sp>
-      <p:sp>
-        <p:nvSpPr>
-          <p:cNvPr id="6" name="Shape 4"/>
-          <p:cNvSpPr/>
-          <p:nvPr/>
-        </p:nvSpPr>
-        <p:spPr>
-          <a:xfrm>
-            <a:off x="1097280" y="2834640"/>
-            <a:ext cx="457200" cy="457200"/>
+          <p:cNvPr id="6" name="Text 4"/>
+          <p:cNvSpPr/>
+          <p:nvPr/>
+        </p:nvSpPr>
+        <p:spPr>
+          <a:xfrm>
+            <a:off x="1371600" y="2514600"/>
+            <a:ext cx="2103120" cy="914400"/>
+          </a:xfrm>
+          <a:prstGeom prst="rect">
+            <a:avLst/>
+          </a:prstGeom>
+          <a:noFill/>
+          <a:ln/>
+        </p:spPr>
+        <p:txBody>
+          <a:bodyPr wrap="square" rtlCol="0" anchor="ctr"/>
+          <a:lstStyle/>
+          <a:p>
+            <a:pPr indent="0" marL="0">
+              <a:buNone/>
+            </a:pPr>
+            <a:r>
+              <a:rPr lang="en-US" sz="1100" dirty="0">
+                <a:solidFill>
+                  <a:srgbClr val="888888"/>
+                </a:solidFill>
+              </a:rPr>
+              <a:t>支持手动修正</a:t>
+            </a:r>
+            <a:endParaRPr lang="en-US" sz="1100" dirty="0"/>
+          </a:p>
+          <a:p>
+            <a:pPr indent="0" marL="0">
+              <a:buNone/>
+            </a:pPr>
+            <a:r>
+              <a:rPr lang="en-US" sz="1100" dirty="0">
+                <a:solidFill>
+                  <a:srgbClr val="888888"/>
+                </a:solidFill>
+              </a:rPr>
+              <a:t>持续优化 prompt</a:t>
+            </a:r>
+            <a:endParaRPr lang="en-US" sz="1100" dirty="0"/>
+          </a:p>
+        </p:txBody>
+      </p:sp>
+      <p:sp>
+        <p:nvSpPr>
+          <p:cNvPr id="7" name="Shape 5"/>
+          <p:cNvSpPr/>
+          <p:nvPr/>
+        </p:nvSpPr>
+        <p:spPr>
+          <a:xfrm>
+            <a:off x="3840480" y="2011680"/>
+            <a:ext cx="2468880" cy="1554480"/>
+          </a:xfrm>
+          <a:prstGeom prst="rect">
+            <a:avLst/>
+          </a:prstGeom>
+          <a:solidFill>
+            <a:srgbClr val="FFFFFF"/>
+          </a:solidFill>
+          <a:ln w="19050">
+            <a:solidFill>
+              <a:srgbClr val="1A56DB"/>
+            </a:solidFill>
+            <a:prstDash val="solid"/>
+          </a:ln>
+        </p:spPr>
+      </p:sp>
+      <p:sp>
+        <p:nvSpPr>
+          <p:cNvPr id="8" name="Shape 6"/>
+          <p:cNvSpPr/>
+          <p:nvPr/>
+        </p:nvSpPr>
+        <p:spPr>
+          <a:xfrm>
+            <a:off x="3840480" y="2011680"/>
+            <a:ext cx="54864" cy="1554480"/>
           </a:xfrm>
           <a:prstGeom prst="rect">
             <a:avLst/>
@@ -4206,40 +3974,48 @@
           <a:solidFill>
             <a:srgbClr val="1A56DB"/>
           </a:solidFill>
-          <a:ln/>
-        </p:spPr>
-      </p:sp>
-      <p:sp>
-        <p:nvSpPr>
-          <p:cNvPr id="7" name="Text 5"/>
-          <p:cNvSpPr/>
-          <p:nvPr/>
-        </p:nvSpPr>
-        <p:spPr>
-          <a:xfrm>
-            <a:off x="1097280" y="2880360"/>
-            <a:ext cx="457200" cy="457200"/>
-          </a:xfrm>
-          <a:prstGeom prst="rect">
-            <a:avLst/>
-          </a:prstGeom>
-          <a:noFill/>
-          <a:ln/>
-        </p:spPr>
-        <p:txBody>
-          <a:bodyPr wrap="square" rtlCol="0" anchor="ctr"/>
-          <a:lstStyle/>
-          <a:p>
-            <a:pPr algn="ctr" indent="0" marL="0">
+          <a:ln w="12700">
+            <a:solidFill>
+              <a:srgbClr val="1A56DB"/>
+            </a:solidFill>
+            <a:prstDash val="solid"/>
+          </a:ln>
+        </p:spPr>
+      </p:sp>
+      <p:sp>
+        <p:nvSpPr>
+          <p:cNvPr id="9" name="Text 7"/>
+          <p:cNvSpPr/>
+          <p:nvPr/>
+        </p:nvSpPr>
+        <p:spPr>
+          <a:xfrm>
+            <a:off x="4114800" y="2148840"/>
+            <a:ext cx="2103120" cy="365760"/>
+          </a:xfrm>
+          <a:prstGeom prst="rect">
+            <a:avLst/>
+          </a:prstGeom>
+          <a:noFill/>
+          <a:ln/>
+        </p:spPr>
+        <p:txBody>
+          <a:bodyPr wrap="square" rtlCol="0" anchor="ctr"/>
+          <a:lstStyle/>
+          <a:p>
+            <a:pPr indent="0" marL="0">
               <a:buNone/>
             </a:pPr>
             <a:r>
               <a:rPr lang="en-US" sz="1400" dirty="0">
                 <a:solidFill>
-                  <a:srgbClr val="FFFFFF"/>
-                </a:solidFill>
-              </a:rPr>
-              <a:t>2</a:t>
+                  <a:srgbClr val="0A0A0A"/>
+                </a:solidFill>
+                <a:latin typeface="Microsoft YaHei" pitchFamily="34" charset="0"/>
+                <a:ea typeface="Microsoft YaHei" pitchFamily="34" charset="-122"/>
+                <a:cs typeface="Microsoft YaHei" pitchFamily="34" charset="-120"/>
+              </a:rPr>
+              <a:t>用户留存低</a:t>
             </a:r>
             <a:endParaRPr lang="en-US" sz="1400" dirty="0"/>
           </a:p>
@@ -4247,50 +4023,89 @@
       </p:sp>
       <p:sp>
         <p:nvSpPr>
-          <p:cNvPr id="8" name="Text 6"/>
-          <p:cNvSpPr/>
-          <p:nvPr/>
-        </p:nvSpPr>
-        <p:spPr>
-          <a:xfrm>
-            <a:off x="1828800" y="2834640"/>
-            <a:ext cx="9144000" cy="0"/>
-          </a:xfrm>
-          <a:prstGeom prst="rect">
-            <a:avLst/>
-          </a:prstGeom>
-          <a:noFill/>
-          <a:ln/>
-        </p:spPr>
-        <p:txBody>
-          <a:bodyPr wrap="square" rtlCol="0" anchor="ctr"/>
-          <a:lstStyle/>
-          <a:p>
-            <a:pPr indent="0" marL="0">
-              <a:buNone/>
-            </a:pPr>
-            <a:r>
-              <a:rPr lang="en-US" sz="1500" dirty="0">
-                <a:solidFill>
-                  <a:srgbClr val="0A0A0A"/>
-                </a:solidFill>
-              </a:rPr>
-              <a:t>收集 AI 识别准确率和用户满意度数据</a:t>
-            </a:r>
-            <a:endParaRPr lang="en-US" sz="1500" dirty="0"/>
-          </a:p>
-        </p:txBody>
-      </p:sp>
-      <p:sp>
-        <p:nvSpPr>
-          <p:cNvPr id="9" name="Shape 7"/>
-          <p:cNvSpPr/>
-          <p:nvPr/>
-        </p:nvSpPr>
-        <p:spPr>
-          <a:xfrm>
-            <a:off x="1097280" y="3840480"/>
-            <a:ext cx="457200" cy="457200"/>
+          <p:cNvPr id="10" name="Text 8"/>
+          <p:cNvSpPr/>
+          <p:nvPr/>
+        </p:nvSpPr>
+        <p:spPr>
+          <a:xfrm>
+            <a:off x="4114800" y="2514600"/>
+            <a:ext cx="2103120" cy="914400"/>
+          </a:xfrm>
+          <a:prstGeom prst="rect">
+            <a:avLst/>
+          </a:prstGeom>
+          <a:noFill/>
+          <a:ln/>
+        </p:spPr>
+        <p:txBody>
+          <a:bodyPr wrap="square" rtlCol="0" anchor="ctr"/>
+          <a:lstStyle/>
+          <a:p>
+            <a:pPr indent="0" marL="0">
+              <a:buNone/>
+            </a:pPr>
+            <a:r>
+              <a:rPr lang="en-US" sz="1100" dirty="0">
+                <a:solidFill>
+                  <a:srgbClr val="888888"/>
+                </a:solidFill>
+              </a:rPr>
+              <a:t>体检→分析闭环</a:t>
+            </a:r>
+            <a:endParaRPr lang="en-US" sz="1100" dirty="0"/>
+          </a:p>
+          <a:p>
+            <a:pPr indent="0" marL="0">
+              <a:buNone/>
+            </a:pPr>
+            <a:r>
+              <a:rPr lang="en-US" sz="1100" dirty="0">
+                <a:solidFill>
+                  <a:srgbClr val="888888"/>
+                </a:solidFill>
+              </a:rPr>
+              <a:t>饮食打卡 + 成就系统</a:t>
+            </a:r>
+            <a:endParaRPr lang="en-US" sz="1100" dirty="0"/>
+          </a:p>
+        </p:txBody>
+      </p:sp>
+      <p:sp>
+        <p:nvSpPr>
+          <p:cNvPr id="11" name="Shape 9"/>
+          <p:cNvSpPr/>
+          <p:nvPr/>
+        </p:nvSpPr>
+        <p:spPr>
+          <a:xfrm>
+            <a:off x="6583680" y="2011680"/>
+            <a:ext cx="2468880" cy="1554480"/>
+          </a:xfrm>
+          <a:prstGeom prst="rect">
+            <a:avLst/>
+          </a:prstGeom>
+          <a:solidFill>
+            <a:srgbClr val="FFFFFF"/>
+          </a:solidFill>
+          <a:ln w="19050">
+            <a:solidFill>
+              <a:srgbClr val="1A56DB"/>
+            </a:solidFill>
+            <a:prstDash val="solid"/>
+          </a:ln>
+        </p:spPr>
+      </p:sp>
+      <p:sp>
+        <p:nvSpPr>
+          <p:cNvPr id="12" name="Shape 10"/>
+          <p:cNvSpPr/>
+          <p:nvPr/>
+        </p:nvSpPr>
+        <p:spPr>
+          <a:xfrm>
+            <a:off x="6583680" y="2011680"/>
+            <a:ext cx="54864" cy="1554480"/>
           </a:xfrm>
           <a:prstGeom prst="rect">
             <a:avLst/>
@@ -4298,40 +4113,48 @@
           <a:solidFill>
             <a:srgbClr val="1A56DB"/>
           </a:solidFill>
-          <a:ln/>
-        </p:spPr>
-      </p:sp>
-      <p:sp>
-        <p:nvSpPr>
-          <p:cNvPr id="10" name="Text 8"/>
-          <p:cNvSpPr/>
-          <p:nvPr/>
-        </p:nvSpPr>
-        <p:spPr>
-          <a:xfrm>
-            <a:off x="1097280" y="3886200"/>
-            <a:ext cx="457200" cy="457200"/>
-          </a:xfrm>
-          <a:prstGeom prst="rect">
-            <a:avLst/>
-          </a:prstGeom>
-          <a:noFill/>
-          <a:ln/>
-        </p:spPr>
-        <p:txBody>
-          <a:bodyPr wrap="square" rtlCol="0" anchor="ctr"/>
-          <a:lstStyle/>
-          <a:p>
-            <a:pPr algn="ctr" indent="0" marL="0">
+          <a:ln w="12700">
+            <a:solidFill>
+              <a:srgbClr val="1A56DB"/>
+            </a:solidFill>
+            <a:prstDash val="solid"/>
+          </a:ln>
+        </p:spPr>
+      </p:sp>
+      <p:sp>
+        <p:nvSpPr>
+          <p:cNvPr id="13" name="Text 11"/>
+          <p:cNvSpPr/>
+          <p:nvPr/>
+        </p:nvSpPr>
+        <p:spPr>
+          <a:xfrm>
+            <a:off x="6858000" y="2148840"/>
+            <a:ext cx="2103120" cy="365760"/>
+          </a:xfrm>
+          <a:prstGeom prst="rect">
+            <a:avLst/>
+          </a:prstGeom>
+          <a:noFill/>
+          <a:ln/>
+        </p:spPr>
+        <p:txBody>
+          <a:bodyPr wrap="square" rtlCol="0" anchor="ctr"/>
+          <a:lstStyle/>
+          <a:p>
+            <a:pPr indent="0" marL="0">
               <a:buNone/>
             </a:pPr>
             <a:r>
               <a:rPr lang="en-US" sz="1400" dirty="0">
                 <a:solidFill>
-                  <a:srgbClr val="FFFFFF"/>
-                </a:solidFill>
-              </a:rPr>
-              <a:t>3</a:t>
+                  <a:srgbClr val="0A0A0A"/>
+                </a:solidFill>
+                <a:latin typeface="Microsoft YaHei" pitchFamily="34" charset="0"/>
+                <a:ea typeface="Microsoft YaHei" pitchFamily="34" charset="-122"/>
+                <a:cs typeface="Microsoft YaHei" pitchFamily="34" charset="-120"/>
+              </a:rPr>
+              <a:t>竞品跟进</a:t>
             </a:r>
             <a:endParaRPr lang="en-US" sz="1400" dirty="0"/>
           </a:p>
@@ -4339,50 +4162,89 @@
       </p:sp>
       <p:sp>
         <p:nvSpPr>
-          <p:cNvPr id="11" name="Text 9"/>
-          <p:cNvSpPr/>
-          <p:nvPr/>
-        </p:nvSpPr>
-        <p:spPr>
-          <a:xfrm>
-            <a:off x="1828800" y="3840480"/>
-            <a:ext cx="9144000" cy="0"/>
-          </a:xfrm>
-          <a:prstGeom prst="rect">
-            <a:avLst/>
-          </a:prstGeom>
-          <a:noFill/>
-          <a:ln/>
-        </p:spPr>
-        <p:txBody>
-          <a:bodyPr wrap="square" rtlCol="0" anchor="ctr"/>
-          <a:lstStyle/>
-          <a:p>
-            <a:pPr indent="0" marL="0">
-              <a:buNone/>
-            </a:pPr>
-            <a:r>
-              <a:rPr lang="en-US" sz="1500" dirty="0">
-                <a:solidFill>
-                  <a:srgbClr val="0A0A0A"/>
-                </a:solidFill>
-              </a:rPr>
-              <a:t>验证体检报告 → AI 分析 → 饮食建议需求强度</a:t>
-            </a:r>
-            <a:endParaRPr lang="en-US" sz="1500" dirty="0"/>
-          </a:p>
-        </p:txBody>
-      </p:sp>
-      <p:sp>
-        <p:nvSpPr>
-          <p:cNvPr id="12" name="Shape 10"/>
-          <p:cNvSpPr/>
-          <p:nvPr/>
-        </p:nvSpPr>
-        <p:spPr>
-          <a:xfrm>
-            <a:off x="1097280" y="4846320"/>
-            <a:ext cx="457200" cy="457200"/>
+          <p:cNvPr id="14" name="Text 12"/>
+          <p:cNvSpPr/>
+          <p:nvPr/>
+        </p:nvSpPr>
+        <p:spPr>
+          <a:xfrm>
+            <a:off x="6858000" y="2514600"/>
+            <a:ext cx="2103120" cy="914400"/>
+          </a:xfrm>
+          <a:prstGeom prst="rect">
+            <a:avLst/>
+          </a:prstGeom>
+          <a:noFill/>
+          <a:ln/>
+        </p:spPr>
+        <p:txBody>
+          <a:bodyPr wrap="square" rtlCol="0" anchor="ctr"/>
+          <a:lstStyle/>
+          <a:p>
+            <a:pPr indent="0" marL="0">
+              <a:buNone/>
+            </a:pPr>
+            <a:r>
+              <a:rPr lang="en-US" sz="1100" dirty="0">
+                <a:solidFill>
+                  <a:srgbClr val="888888"/>
+                </a:solidFill>
+              </a:rPr>
+              <a:t>聚焦全流程 AI</a:t>
+            </a:r>
+            <a:endParaRPr lang="en-US" sz="1100" dirty="0"/>
+          </a:p>
+          <a:p>
+            <a:pPr indent="0" marL="0">
+              <a:buNone/>
+            </a:pPr>
+            <a:r>
+              <a:rPr lang="en-US" sz="1100" dirty="0">
+                <a:solidFill>
+                  <a:srgbClr val="888888"/>
+                </a:solidFill>
+              </a:rPr>
+              <a:t>+ 体检联动差异化</a:t>
+            </a:r>
+            <a:endParaRPr lang="en-US" sz="1100" dirty="0"/>
+          </a:p>
+        </p:txBody>
+      </p:sp>
+      <p:sp>
+        <p:nvSpPr>
+          <p:cNvPr id="15" name="Shape 13"/>
+          <p:cNvSpPr/>
+          <p:nvPr/>
+        </p:nvSpPr>
+        <p:spPr>
+          <a:xfrm>
+            <a:off x="1097280" y="3840480"/>
+            <a:ext cx="2468880" cy="1554480"/>
+          </a:xfrm>
+          <a:prstGeom prst="rect">
+            <a:avLst/>
+          </a:prstGeom>
+          <a:solidFill>
+            <a:srgbClr val="FFFFFF"/>
+          </a:solidFill>
+          <a:ln w="19050">
+            <a:solidFill>
+              <a:srgbClr val="1A56DB"/>
+            </a:solidFill>
+            <a:prstDash val="solid"/>
+          </a:ln>
+        </p:spPr>
+      </p:sp>
+      <p:sp>
+        <p:nvSpPr>
+          <p:cNvPr id="16" name="Shape 14"/>
+          <p:cNvSpPr/>
+          <p:nvPr/>
+        </p:nvSpPr>
+        <p:spPr>
+          <a:xfrm>
+            <a:off x="1097280" y="3840480"/>
+            <a:ext cx="54864" cy="1554480"/>
           </a:xfrm>
           <a:prstGeom prst="rect">
             <a:avLst/>
@@ -4390,40 +4252,48 @@
           <a:solidFill>
             <a:srgbClr val="1A56DB"/>
           </a:solidFill>
-          <a:ln/>
-        </p:spPr>
-      </p:sp>
-      <p:sp>
-        <p:nvSpPr>
-          <p:cNvPr id="13" name="Text 11"/>
-          <p:cNvSpPr/>
-          <p:nvPr/>
-        </p:nvSpPr>
-        <p:spPr>
-          <a:xfrm>
-            <a:off x="1097280" y="4892040"/>
-            <a:ext cx="457200" cy="457200"/>
-          </a:xfrm>
-          <a:prstGeom prst="rect">
-            <a:avLst/>
-          </a:prstGeom>
-          <a:noFill/>
-          <a:ln/>
-        </p:spPr>
-        <p:txBody>
-          <a:bodyPr wrap="square" rtlCol="0" anchor="ctr"/>
-          <a:lstStyle/>
-          <a:p>
-            <a:pPr algn="ctr" indent="0" marL="0">
+          <a:ln w="12700">
+            <a:solidFill>
+              <a:srgbClr val="1A56DB"/>
+            </a:solidFill>
+            <a:prstDash val="solid"/>
+          </a:ln>
+        </p:spPr>
+      </p:sp>
+      <p:sp>
+        <p:nvSpPr>
+          <p:cNvPr id="17" name="Text 15"/>
+          <p:cNvSpPr/>
+          <p:nvPr/>
+        </p:nvSpPr>
+        <p:spPr>
+          <a:xfrm>
+            <a:off x="1371600" y="3977640"/>
+            <a:ext cx="2103120" cy="365760"/>
+          </a:xfrm>
+          <a:prstGeom prst="rect">
+            <a:avLst/>
+          </a:prstGeom>
+          <a:noFill/>
+          <a:ln/>
+        </p:spPr>
+        <p:txBody>
+          <a:bodyPr wrap="square" rtlCol="0" anchor="ctr"/>
+          <a:lstStyle/>
+          <a:p>
+            <a:pPr indent="0" marL="0">
               <a:buNone/>
             </a:pPr>
             <a:r>
               <a:rPr lang="en-US" sz="1400" dirty="0">
                 <a:solidFill>
-                  <a:srgbClr val="FFFFFF"/>
-                </a:solidFill>
-              </a:rPr>
-              <a:t>4</a:t>
+                  <a:srgbClr val="0A0A0A"/>
+                </a:solidFill>
+                <a:latin typeface="Microsoft YaHei" pitchFamily="34" charset="0"/>
+                <a:ea typeface="Microsoft YaHei" pitchFamily="34" charset="-122"/>
+                <a:cs typeface="Microsoft YaHei" pitchFamily="34" charset="-120"/>
+              </a:rPr>
+              <a:t>健康建议合规</a:t>
             </a:r>
             <a:endParaRPr lang="en-US" sz="1400" dirty="0"/>
           </a:p>
@@ -4431,37 +4301,329 @@
       </p:sp>
       <p:sp>
         <p:nvSpPr>
-          <p:cNvPr id="14" name="Text 12"/>
-          <p:cNvSpPr/>
-          <p:nvPr/>
-        </p:nvSpPr>
-        <p:spPr>
-          <a:xfrm>
-            <a:off x="1828800" y="4846320"/>
-            <a:ext cx="9144000" cy="0"/>
-          </a:xfrm>
-          <a:prstGeom prst="rect">
-            <a:avLst/>
-          </a:prstGeom>
-          <a:noFill/>
-          <a:ln/>
-        </p:spPr>
-        <p:txBody>
-          <a:bodyPr wrap="square" rtlCol="0" anchor="ctr"/>
-          <a:lstStyle/>
-          <a:p>
-            <a:pPr indent="0" marL="0">
-              <a:buNone/>
-            </a:pPr>
-            <a:r>
-              <a:rPr lang="en-US" sz="1500" dirty="0">
+          <p:cNvPr id="18" name="Text 16"/>
+          <p:cNvSpPr/>
+          <p:nvPr/>
+        </p:nvSpPr>
+        <p:spPr>
+          <a:xfrm>
+            <a:off x="1371600" y="4343400"/>
+            <a:ext cx="2103120" cy="914400"/>
+          </a:xfrm>
+          <a:prstGeom prst="rect">
+            <a:avLst/>
+          </a:prstGeom>
+          <a:noFill/>
+          <a:ln/>
+        </p:spPr>
+        <p:txBody>
+          <a:bodyPr wrap="square" rtlCol="0" anchor="ctr"/>
+          <a:lstStyle/>
+          <a:p>
+            <a:pPr indent="0" marL="0">
+              <a:buNone/>
+            </a:pPr>
+            <a:r>
+              <a:rPr lang="en-US" sz="1100" dirty="0">
+                <a:solidFill>
+                  <a:srgbClr val="888888"/>
+                </a:solidFill>
+              </a:rPr>
+              <a:t>免责声明</a:t>
+            </a:r>
+            <a:endParaRPr lang="en-US" sz="1100" dirty="0"/>
+          </a:p>
+          <a:p>
+            <a:pPr indent="0" marL="0">
+              <a:buNone/>
+            </a:pPr>
+            <a:r>
+              <a:rPr lang="en-US" sz="1100" dirty="0">
+                <a:solidFill>
+                  <a:srgbClr val="888888"/>
+                </a:solidFill>
+              </a:rPr>
+              <a:t>医学顾问审核</a:t>
+            </a:r>
+            <a:endParaRPr lang="en-US" sz="1100" dirty="0"/>
+          </a:p>
+        </p:txBody>
+      </p:sp>
+      <p:sp>
+        <p:nvSpPr>
+          <p:cNvPr id="19" name="Shape 17"/>
+          <p:cNvSpPr/>
+          <p:nvPr/>
+        </p:nvSpPr>
+        <p:spPr>
+          <a:xfrm>
+            <a:off x="3840480" y="3840480"/>
+            <a:ext cx="2468880" cy="1554480"/>
+          </a:xfrm>
+          <a:prstGeom prst="rect">
+            <a:avLst/>
+          </a:prstGeom>
+          <a:solidFill>
+            <a:srgbClr val="FFFFFF"/>
+          </a:solidFill>
+          <a:ln w="19050">
+            <a:solidFill>
+              <a:srgbClr val="1A56DB"/>
+            </a:solidFill>
+            <a:prstDash val="solid"/>
+          </a:ln>
+        </p:spPr>
+      </p:sp>
+      <p:sp>
+        <p:nvSpPr>
+          <p:cNvPr id="20" name="Shape 18"/>
+          <p:cNvSpPr/>
+          <p:nvPr/>
+        </p:nvSpPr>
+        <p:spPr>
+          <a:xfrm>
+            <a:off x="3840480" y="3840480"/>
+            <a:ext cx="54864" cy="1554480"/>
+          </a:xfrm>
+          <a:prstGeom prst="rect">
+            <a:avLst/>
+          </a:prstGeom>
+          <a:solidFill>
+            <a:srgbClr val="1A56DB"/>
+          </a:solidFill>
+          <a:ln w="12700">
+            <a:solidFill>
+              <a:srgbClr val="1A56DB"/>
+            </a:solidFill>
+            <a:prstDash val="solid"/>
+          </a:ln>
+        </p:spPr>
+      </p:sp>
+      <p:sp>
+        <p:nvSpPr>
+          <p:cNvPr id="21" name="Text 19"/>
+          <p:cNvSpPr/>
+          <p:nvPr/>
+        </p:nvSpPr>
+        <p:spPr>
+          <a:xfrm>
+            <a:off x="4114800" y="3977640"/>
+            <a:ext cx="2103120" cy="365760"/>
+          </a:xfrm>
+          <a:prstGeom prst="rect">
+            <a:avLst/>
+          </a:prstGeom>
+          <a:noFill/>
+          <a:ln/>
+        </p:spPr>
+        <p:txBody>
+          <a:bodyPr wrap="square" rtlCol="0" anchor="ctr"/>
+          <a:lstStyle/>
+          <a:p>
+            <a:pPr indent="0" marL="0">
+              <a:buNone/>
+            </a:pPr>
+            <a:r>
+              <a:rPr lang="en-US" sz="1400" dirty="0">
                 <a:solidFill>
                   <a:srgbClr val="0A0A0A"/>
                 </a:solidFill>
-              </a:rPr>
-              <a:t>确定国内部署方案，迭代产品</a:t>
-            </a:r>
-            <a:endParaRPr lang="en-US" sz="1500" dirty="0"/>
+                <a:latin typeface="Microsoft YaHei" pitchFamily="34" charset="0"/>
+                <a:ea typeface="Microsoft YaHei" pitchFamily="34" charset="-122"/>
+                <a:cs typeface="Microsoft YaHei" pitchFamily="34" charset="-120"/>
+              </a:rPr>
+              <a:t>盈利不清晰</a:t>
+            </a:r>
+            <a:endParaRPr lang="en-US" sz="1400" dirty="0"/>
+          </a:p>
+        </p:txBody>
+      </p:sp>
+      <p:sp>
+        <p:nvSpPr>
+          <p:cNvPr id="22" name="Text 20"/>
+          <p:cNvSpPr/>
+          <p:nvPr/>
+        </p:nvSpPr>
+        <p:spPr>
+          <a:xfrm>
+            <a:off x="4114800" y="4343400"/>
+            <a:ext cx="2103120" cy="914400"/>
+          </a:xfrm>
+          <a:prstGeom prst="rect">
+            <a:avLst/>
+          </a:prstGeom>
+          <a:noFill/>
+          <a:ln/>
+        </p:spPr>
+        <p:txBody>
+          <a:bodyPr wrap="square" rtlCol="0" anchor="ctr"/>
+          <a:lstStyle/>
+          <a:p>
+            <a:pPr indent="0" marL="0">
+              <a:buNone/>
+            </a:pPr>
+            <a:r>
+              <a:rPr lang="en-US" sz="1100" dirty="0">
+                <a:solidFill>
+                  <a:srgbClr val="888888"/>
+                </a:solidFill>
+              </a:rPr>
+              <a:t>先免费验证 PMF</a:t>
+            </a:r>
+            <a:endParaRPr lang="en-US" sz="1100" dirty="0"/>
+          </a:p>
+          <a:p>
+            <a:pPr indent="0" marL="0">
+              <a:buNone/>
+            </a:pPr>
+            <a:r>
+              <a:rPr lang="en-US" sz="1100" dirty="0">
+                <a:solidFill>
+                  <a:srgbClr val="888888"/>
+                </a:solidFill>
+              </a:rPr>
+              <a:t>1 万 MAU 再订阅</a:t>
+            </a:r>
+            <a:endParaRPr lang="en-US" sz="1100" dirty="0"/>
+          </a:p>
+        </p:txBody>
+      </p:sp>
+      <p:sp>
+        <p:nvSpPr>
+          <p:cNvPr id="23" name="Shape 21"/>
+          <p:cNvSpPr/>
+          <p:nvPr/>
+        </p:nvSpPr>
+        <p:spPr>
+          <a:xfrm>
+            <a:off x="6583680" y="3840480"/>
+            <a:ext cx="2468880" cy="1554480"/>
+          </a:xfrm>
+          <a:prstGeom prst="rect">
+            <a:avLst/>
+          </a:prstGeom>
+          <a:solidFill>
+            <a:srgbClr val="FFFFFF"/>
+          </a:solidFill>
+          <a:ln w="19050">
+            <a:solidFill>
+              <a:srgbClr val="1A56DB"/>
+            </a:solidFill>
+            <a:prstDash val="solid"/>
+          </a:ln>
+        </p:spPr>
+      </p:sp>
+      <p:sp>
+        <p:nvSpPr>
+          <p:cNvPr id="24" name="Shape 22"/>
+          <p:cNvSpPr/>
+          <p:nvPr/>
+        </p:nvSpPr>
+        <p:spPr>
+          <a:xfrm>
+            <a:off x="6583680" y="3840480"/>
+            <a:ext cx="54864" cy="1554480"/>
+          </a:xfrm>
+          <a:prstGeom prst="rect">
+            <a:avLst/>
+          </a:prstGeom>
+          <a:solidFill>
+            <a:srgbClr val="1A56DB"/>
+          </a:solidFill>
+          <a:ln w="12700">
+            <a:solidFill>
+              <a:srgbClr val="1A56DB"/>
+            </a:solidFill>
+            <a:prstDash val="solid"/>
+          </a:ln>
+        </p:spPr>
+      </p:sp>
+      <p:sp>
+        <p:nvSpPr>
+          <p:cNvPr id="25" name="Text 23"/>
+          <p:cNvSpPr/>
+          <p:nvPr/>
+        </p:nvSpPr>
+        <p:spPr>
+          <a:xfrm>
+            <a:off x="6858000" y="3977640"/>
+            <a:ext cx="2103120" cy="365760"/>
+          </a:xfrm>
+          <a:prstGeom prst="rect">
+            <a:avLst/>
+          </a:prstGeom>
+          <a:noFill/>
+          <a:ln/>
+        </p:spPr>
+        <p:txBody>
+          <a:bodyPr wrap="square" rtlCol="0" anchor="ctr"/>
+          <a:lstStyle/>
+          <a:p>
+            <a:pPr indent="0" marL="0">
+              <a:buNone/>
+            </a:pPr>
+            <a:r>
+              <a:rPr lang="en-US" sz="1400" dirty="0">
+                <a:solidFill>
+                  <a:srgbClr val="0A0A0A"/>
+                </a:solidFill>
+                <a:latin typeface="Microsoft YaHei" pitchFamily="34" charset="0"/>
+                <a:ea typeface="Microsoft YaHei" pitchFamily="34" charset="-122"/>
+                <a:cs typeface="Microsoft YaHei" pitchFamily="34" charset="-120"/>
+              </a:rPr>
+              <a:t>数据隐私</a:t>
+            </a:r>
+            <a:endParaRPr lang="en-US" sz="1400" dirty="0"/>
+          </a:p>
+        </p:txBody>
+      </p:sp>
+      <p:sp>
+        <p:nvSpPr>
+          <p:cNvPr id="26" name="Text 24"/>
+          <p:cNvSpPr/>
+          <p:nvPr/>
+        </p:nvSpPr>
+        <p:spPr>
+          <a:xfrm>
+            <a:off x="6858000" y="4343400"/>
+            <a:ext cx="2103120" cy="914400"/>
+          </a:xfrm>
+          <a:prstGeom prst="rect">
+            <a:avLst/>
+          </a:prstGeom>
+          <a:noFill/>
+          <a:ln/>
+        </p:spPr>
+        <p:txBody>
+          <a:bodyPr wrap="square" rtlCol="0" anchor="ctr"/>
+          <a:lstStyle/>
+          <a:p>
+            <a:pPr indent="0" marL="0">
+              <a:buNone/>
+            </a:pPr>
+            <a:r>
+              <a:rPr lang="en-US" sz="1100" dirty="0">
+                <a:solidFill>
+                  <a:srgbClr val="888888"/>
+                </a:solidFill>
+              </a:rPr>
+              <a:t>行业标准加密</a:t>
+            </a:r>
+            <a:endParaRPr lang="en-US" sz="1100" dirty="0"/>
+          </a:p>
+          <a:p>
+            <a:pPr indent="0" marL="0">
+              <a:buNone/>
+            </a:pPr>
+            <a:r>
+              <a:rPr lang="en-US" sz="1100" dirty="0">
+                <a:solidFill>
+                  <a:srgbClr val="888888"/>
+                </a:solidFill>
+              </a:rPr>
+              <a:t>用户数据不出境</a:t>
+            </a:r>
+            <a:endParaRPr lang="en-US" sz="1100" dirty="0"/>
           </a:p>
         </p:txBody>
       </p:sp>
@@ -4476,6 +4638,445 @@
 <file path=ppt/slides/slide14.xml><?xml version="1.0" encoding="utf-8"?>
 <p:sld xmlns:a="http://schemas.openxmlformats.org/drawingml/2006/main" xmlns:r="http://schemas.openxmlformats.org/officeDocument/2006/relationships" xmlns:p="http://schemas.openxmlformats.org/presentationml/2006/main">
   <p:cSld name="Slide 14">
+    <p:bg>
+      <p:bgPr>
+        <a:solidFill>
+          <a:srgbClr val="F5F5F3"/>
+        </a:solidFill>
+      </p:bgPr>
+    </p:bg>
+    <p:spTree>
+      <p:nvGrpSpPr>
+        <p:cNvPr id="1" name=""/>
+        <p:cNvGrpSpPr/>
+        <p:nvPr/>
+      </p:nvGrpSpPr>
+      <p:grpSpPr>
+        <a:xfrm>
+          <a:off x="0" y="0"/>
+          <a:ext cx="0" cy="0"/>
+          <a:chOff x="0" y="0"/>
+          <a:chExt cx="0" cy="0"/>
+        </a:xfrm>
+      </p:grpSpPr>
+      <p:sp>
+        <p:nvSpPr>
+          <p:cNvPr id="2" name="Text 0"/>
+          <p:cNvSpPr/>
+          <p:nvPr/>
+        </p:nvSpPr>
+        <p:spPr>
+          <a:xfrm>
+            <a:off x="1097280" y="457200"/>
+            <a:ext cx="9144000" cy="0"/>
+          </a:xfrm>
+          <a:prstGeom prst="rect">
+            <a:avLst/>
+          </a:prstGeom>
+          <a:noFill/>
+          <a:ln/>
+        </p:spPr>
+        <p:txBody>
+          <a:bodyPr wrap="square" rtlCol="0" anchor="ctr"/>
+          <a:lstStyle/>
+          <a:p>
+            <a:pPr indent="0" marL="0">
+              <a:buNone/>
+            </a:pPr>
+            <a:r>
+              <a:rPr lang="en-US" sz="1200" b="1" dirty="0">
+                <a:solidFill>
+                  <a:srgbClr val="1A56DB"/>
+                </a:solidFill>
+                <a:latin typeface="Microsoft YaHei" pitchFamily="34" charset="0"/>
+                <a:ea typeface="Microsoft YaHei" pitchFamily="34" charset="-122"/>
+                <a:cs typeface="Microsoft YaHei" pitchFamily="34" charset="-120"/>
+              </a:rPr>
+              <a:t>下一步</a:t>
+            </a:r>
+            <a:endParaRPr lang="en-US" sz="1200" dirty="0"/>
+          </a:p>
+        </p:txBody>
+      </p:sp>
+      <p:sp>
+        <p:nvSpPr>
+          <p:cNvPr id="3" name="Shape 1"/>
+          <p:cNvSpPr/>
+          <p:nvPr/>
+        </p:nvSpPr>
+        <p:spPr>
+          <a:xfrm>
+            <a:off x="1097280" y="1828800"/>
+            <a:ext cx="457200" cy="457200"/>
+          </a:xfrm>
+          <a:prstGeom prst="rect">
+            <a:avLst/>
+          </a:prstGeom>
+          <a:solidFill>
+            <a:srgbClr val="1A56DB"/>
+          </a:solidFill>
+          <a:ln/>
+        </p:spPr>
+      </p:sp>
+      <p:sp>
+        <p:nvSpPr>
+          <p:cNvPr id="4" name="Text 2"/>
+          <p:cNvSpPr/>
+          <p:nvPr/>
+        </p:nvSpPr>
+        <p:spPr>
+          <a:xfrm>
+            <a:off x="1097280" y="1874520"/>
+            <a:ext cx="457200" cy="457200"/>
+          </a:xfrm>
+          <a:prstGeom prst="rect">
+            <a:avLst/>
+          </a:prstGeom>
+          <a:noFill/>
+          <a:ln/>
+        </p:spPr>
+        <p:txBody>
+          <a:bodyPr wrap="square" rtlCol="0" anchor="ctr"/>
+          <a:lstStyle/>
+          <a:p>
+            <a:pPr algn="ctr" indent="0" marL="0">
+              <a:buNone/>
+            </a:pPr>
+            <a:r>
+              <a:rPr lang="en-US" sz="1400" dirty="0">
+                <a:solidFill>
+                  <a:srgbClr val="FFFFFF"/>
+                </a:solidFill>
+              </a:rPr>
+              <a:t>1</a:t>
+            </a:r>
+            <a:endParaRPr lang="en-US" sz="1400" dirty="0"/>
+          </a:p>
+        </p:txBody>
+      </p:sp>
+      <p:sp>
+        <p:nvSpPr>
+          <p:cNvPr id="5" name="Text 3"/>
+          <p:cNvSpPr/>
+          <p:nvPr/>
+        </p:nvSpPr>
+        <p:spPr>
+          <a:xfrm>
+            <a:off x="1828800" y="1828800"/>
+            <a:ext cx="9144000" cy="0"/>
+          </a:xfrm>
+          <a:prstGeom prst="rect">
+            <a:avLst/>
+          </a:prstGeom>
+          <a:noFill/>
+          <a:ln/>
+        </p:spPr>
+        <p:txBody>
+          <a:bodyPr wrap="square" rtlCol="0" anchor="ctr"/>
+          <a:lstStyle/>
+          <a:p>
+            <a:pPr indent="0" marL="0">
+              <a:buNone/>
+            </a:pPr>
+            <a:r>
+              <a:rPr lang="en-US" sz="1500" dirty="0">
+                <a:solidFill>
+                  <a:srgbClr val="0A0A0A"/>
+                </a:solidFill>
+              </a:rPr>
+              <a:t>找到 10-20 个真实用户，进行为期 2 周的测试</a:t>
+            </a:r>
+            <a:endParaRPr lang="en-US" sz="1500" dirty="0"/>
+          </a:p>
+        </p:txBody>
+      </p:sp>
+      <p:sp>
+        <p:nvSpPr>
+          <p:cNvPr id="6" name="Shape 4"/>
+          <p:cNvSpPr/>
+          <p:nvPr/>
+        </p:nvSpPr>
+        <p:spPr>
+          <a:xfrm>
+            <a:off x="1097280" y="2834640"/>
+            <a:ext cx="457200" cy="457200"/>
+          </a:xfrm>
+          <a:prstGeom prst="rect">
+            <a:avLst/>
+          </a:prstGeom>
+          <a:solidFill>
+            <a:srgbClr val="1A56DB"/>
+          </a:solidFill>
+          <a:ln/>
+        </p:spPr>
+      </p:sp>
+      <p:sp>
+        <p:nvSpPr>
+          <p:cNvPr id="7" name="Text 5"/>
+          <p:cNvSpPr/>
+          <p:nvPr/>
+        </p:nvSpPr>
+        <p:spPr>
+          <a:xfrm>
+            <a:off x="1097280" y="2880360"/>
+            <a:ext cx="457200" cy="457200"/>
+          </a:xfrm>
+          <a:prstGeom prst="rect">
+            <a:avLst/>
+          </a:prstGeom>
+          <a:noFill/>
+          <a:ln/>
+        </p:spPr>
+        <p:txBody>
+          <a:bodyPr wrap="square" rtlCol="0" anchor="ctr"/>
+          <a:lstStyle/>
+          <a:p>
+            <a:pPr algn="ctr" indent="0" marL="0">
+              <a:buNone/>
+            </a:pPr>
+            <a:r>
+              <a:rPr lang="en-US" sz="1400" dirty="0">
+                <a:solidFill>
+                  <a:srgbClr val="FFFFFF"/>
+                </a:solidFill>
+              </a:rPr>
+              <a:t>2</a:t>
+            </a:r>
+            <a:endParaRPr lang="en-US" sz="1400" dirty="0"/>
+          </a:p>
+        </p:txBody>
+      </p:sp>
+      <p:sp>
+        <p:nvSpPr>
+          <p:cNvPr id="8" name="Text 6"/>
+          <p:cNvSpPr/>
+          <p:nvPr/>
+        </p:nvSpPr>
+        <p:spPr>
+          <a:xfrm>
+            <a:off x="1828800" y="2834640"/>
+            <a:ext cx="9144000" cy="0"/>
+          </a:xfrm>
+          <a:prstGeom prst="rect">
+            <a:avLst/>
+          </a:prstGeom>
+          <a:noFill/>
+          <a:ln/>
+        </p:spPr>
+        <p:txBody>
+          <a:bodyPr wrap="square" rtlCol="0" anchor="ctr"/>
+          <a:lstStyle/>
+          <a:p>
+            <a:pPr indent="0" marL="0">
+              <a:buNone/>
+            </a:pPr>
+            <a:r>
+              <a:rPr lang="en-US" sz="1500" dirty="0">
+                <a:solidFill>
+                  <a:srgbClr val="0A0A0A"/>
+                </a:solidFill>
+              </a:rPr>
+              <a:t>收集 AI 识别准确率和用户满意度数据</a:t>
+            </a:r>
+            <a:endParaRPr lang="en-US" sz="1500" dirty="0"/>
+          </a:p>
+        </p:txBody>
+      </p:sp>
+      <p:sp>
+        <p:nvSpPr>
+          <p:cNvPr id="9" name="Shape 7"/>
+          <p:cNvSpPr/>
+          <p:nvPr/>
+        </p:nvSpPr>
+        <p:spPr>
+          <a:xfrm>
+            <a:off x="1097280" y="3840480"/>
+            <a:ext cx="457200" cy="457200"/>
+          </a:xfrm>
+          <a:prstGeom prst="rect">
+            <a:avLst/>
+          </a:prstGeom>
+          <a:solidFill>
+            <a:srgbClr val="1A56DB"/>
+          </a:solidFill>
+          <a:ln/>
+        </p:spPr>
+      </p:sp>
+      <p:sp>
+        <p:nvSpPr>
+          <p:cNvPr id="10" name="Text 8"/>
+          <p:cNvSpPr/>
+          <p:nvPr/>
+        </p:nvSpPr>
+        <p:spPr>
+          <a:xfrm>
+            <a:off x="1097280" y="3886200"/>
+            <a:ext cx="457200" cy="457200"/>
+          </a:xfrm>
+          <a:prstGeom prst="rect">
+            <a:avLst/>
+          </a:prstGeom>
+          <a:noFill/>
+          <a:ln/>
+        </p:spPr>
+        <p:txBody>
+          <a:bodyPr wrap="square" rtlCol="0" anchor="ctr"/>
+          <a:lstStyle/>
+          <a:p>
+            <a:pPr algn="ctr" indent="0" marL="0">
+              <a:buNone/>
+            </a:pPr>
+            <a:r>
+              <a:rPr lang="en-US" sz="1400" dirty="0">
+                <a:solidFill>
+                  <a:srgbClr val="FFFFFF"/>
+                </a:solidFill>
+              </a:rPr>
+              <a:t>3</a:t>
+            </a:r>
+            <a:endParaRPr lang="en-US" sz="1400" dirty="0"/>
+          </a:p>
+        </p:txBody>
+      </p:sp>
+      <p:sp>
+        <p:nvSpPr>
+          <p:cNvPr id="11" name="Text 9"/>
+          <p:cNvSpPr/>
+          <p:nvPr/>
+        </p:nvSpPr>
+        <p:spPr>
+          <a:xfrm>
+            <a:off x="1828800" y="3840480"/>
+            <a:ext cx="9144000" cy="0"/>
+          </a:xfrm>
+          <a:prstGeom prst="rect">
+            <a:avLst/>
+          </a:prstGeom>
+          <a:noFill/>
+          <a:ln/>
+        </p:spPr>
+        <p:txBody>
+          <a:bodyPr wrap="square" rtlCol="0" anchor="ctr"/>
+          <a:lstStyle/>
+          <a:p>
+            <a:pPr indent="0" marL="0">
+              <a:buNone/>
+            </a:pPr>
+            <a:r>
+              <a:rPr lang="en-US" sz="1500" dirty="0">
+                <a:solidFill>
+                  <a:srgbClr val="0A0A0A"/>
+                </a:solidFill>
+              </a:rPr>
+              <a:t>验证体检报告 → AI 分析 → 饮食建议需求强度</a:t>
+            </a:r>
+            <a:endParaRPr lang="en-US" sz="1500" dirty="0"/>
+          </a:p>
+        </p:txBody>
+      </p:sp>
+      <p:sp>
+        <p:nvSpPr>
+          <p:cNvPr id="12" name="Shape 10"/>
+          <p:cNvSpPr/>
+          <p:nvPr/>
+        </p:nvSpPr>
+        <p:spPr>
+          <a:xfrm>
+            <a:off x="1097280" y="4846320"/>
+            <a:ext cx="457200" cy="457200"/>
+          </a:xfrm>
+          <a:prstGeom prst="rect">
+            <a:avLst/>
+          </a:prstGeom>
+          <a:solidFill>
+            <a:srgbClr val="1A56DB"/>
+          </a:solidFill>
+          <a:ln/>
+        </p:spPr>
+      </p:sp>
+      <p:sp>
+        <p:nvSpPr>
+          <p:cNvPr id="13" name="Text 11"/>
+          <p:cNvSpPr/>
+          <p:nvPr/>
+        </p:nvSpPr>
+        <p:spPr>
+          <a:xfrm>
+            <a:off x="1097280" y="4892040"/>
+            <a:ext cx="457200" cy="457200"/>
+          </a:xfrm>
+          <a:prstGeom prst="rect">
+            <a:avLst/>
+          </a:prstGeom>
+          <a:noFill/>
+          <a:ln/>
+        </p:spPr>
+        <p:txBody>
+          <a:bodyPr wrap="square" rtlCol="0" anchor="ctr"/>
+          <a:lstStyle/>
+          <a:p>
+            <a:pPr algn="ctr" indent="0" marL="0">
+              <a:buNone/>
+            </a:pPr>
+            <a:r>
+              <a:rPr lang="en-US" sz="1400" dirty="0">
+                <a:solidFill>
+                  <a:srgbClr val="FFFFFF"/>
+                </a:solidFill>
+              </a:rPr>
+              <a:t>4</a:t>
+            </a:r>
+            <a:endParaRPr lang="en-US" sz="1400" dirty="0"/>
+          </a:p>
+        </p:txBody>
+      </p:sp>
+      <p:sp>
+        <p:nvSpPr>
+          <p:cNvPr id="14" name="Text 12"/>
+          <p:cNvSpPr/>
+          <p:nvPr/>
+        </p:nvSpPr>
+        <p:spPr>
+          <a:xfrm>
+            <a:off x="1828800" y="4846320"/>
+            <a:ext cx="9144000" cy="0"/>
+          </a:xfrm>
+          <a:prstGeom prst="rect">
+            <a:avLst/>
+          </a:prstGeom>
+          <a:noFill/>
+          <a:ln/>
+        </p:spPr>
+        <p:txBody>
+          <a:bodyPr wrap="square" rtlCol="0" anchor="ctr"/>
+          <a:lstStyle/>
+          <a:p>
+            <a:pPr indent="0" marL="0">
+              <a:buNone/>
+            </a:pPr>
+            <a:r>
+              <a:rPr lang="en-US" sz="1500" dirty="0">
+                <a:solidFill>
+                  <a:srgbClr val="0A0A0A"/>
+                </a:solidFill>
+              </a:rPr>
+              <a:t>确定国内部署方案，迭代产品</a:t>
+            </a:r>
+            <a:endParaRPr lang="en-US" sz="1500" dirty="0"/>
+          </a:p>
+        </p:txBody>
+      </p:sp>
+    </p:spTree>
+  </p:cSld>
+  <p:clrMapOvr>
+    <a:masterClrMapping/>
+  </p:clrMapOvr>
+</p:sld>
+</file>
+
+<file path=ppt/slides/slide15.xml><?xml version="1.0" encoding="utf-8"?>
+<p:sld xmlns:a="http://schemas.openxmlformats.org/drawingml/2006/main" xmlns:r="http://schemas.openxmlformats.org/officeDocument/2006/relationships" xmlns:p="http://schemas.openxmlformats.org/presentationml/2006/main">
+  <p:cSld name="Slide 15">
     <p:bg>
       <p:bgPr>
         <a:solidFill>

</xml_diff>